<commit_message>
Update itinerary: Add Mikane D1, Karasuma Daimaru & Jojoen D2, Kobe D4, Kaiyukan D5, remove naps and Nijo Castle, add daily interactive maps
</commit_message>
<xml_diff>
--- a/itinerary.pptx
+++ b/itinerary.pptx
@@ -1888,7 +1888,7 @@
                 <a:ea typeface="Microsoft JhengHei" pitchFamily="34" charset="-122"/>
                 <a:cs typeface="Microsoft JhengHei" pitchFamily="34" charset="-120"/>
               </a:rPr>
-              <a:t>專車直達版  ·  含御金神社  ·  幼兒友善動線</a:t>
+              <a:t>專車直達版  ·  御金神社  ·  敘敘苑燒肉  ·  雙神社參拜</a:t>
             </a:r>
             <a:endParaRPr lang="en-US" sz="1600" dirty="0"/>
           </a:p>
@@ -2090,7 +2090,7 @@
                 <a:ea typeface="Microsoft JhengHei" pitchFamily="34" charset="-122"/>
                 <a:cs typeface="Microsoft JhengHei" pitchFamily="34" charset="-120"/>
               </a:rPr>
-              <a:t>核心策略：專車點對點  ·  中午死守小睡  ·  午後室內避暑  ·  清晨快閃熱門小神社</a:t>
+              <a:t>核心策略：專車點對點  ·  烏丸精緻美食  ·  全室內避暑  ·  彈性幼兒放電</a:t>
             </a:r>
             <a:endParaRPr lang="en-US" sz="1300" dirty="0"/>
           </a:p>
@@ -2303,7 +2303,7 @@
                 <a:ea typeface="Microsoft JhengHei" pitchFamily="34" charset="-122"/>
                 <a:cs typeface="Microsoft JhengHei" pitchFamily="34" charset="-120"/>
               </a:rPr>
-              <a:t>御金 × 二条</a:t>
+              <a:t>御金 × 烏丸美食</a:t>
             </a:r>
             <a:endParaRPr lang="en-US" sz="1600" dirty="0"/>
           </a:p>
@@ -2342,7 +2342,7 @@
                 <a:ea typeface="Microsoft JhengHei" pitchFamily="34" charset="-122"/>
                 <a:cs typeface="Microsoft JhengHei" pitchFamily="34" charset="-120"/>
               </a:rPr>
-              <a:t>清晨快閃金色鳥居 → 步行 6 分古城放電。不擠、不繞、不打亂午睡。</a:t>
+              <a:t>D1 傍晚快閃金色鳥居；D2 烏丸體驗大丸、寶可夢中心與敘敘苑燒肉。</a:t>
             </a:r>
             <a:endParaRPr lang="en-US" sz="1400" dirty="0"/>
           </a:p>
@@ -2410,7 +2410,7 @@
                 <a:ea typeface="Microsoft JhengHei" pitchFamily="34" charset="-122"/>
                 <a:cs typeface="Microsoft JhengHei" pitchFamily="34" charset="-120"/>
               </a:rPr>
-              <a:t>專車三趟</a:t>
+              <a:t>專車三趟直達</a:t>
             </a:r>
             <a:endParaRPr lang="en-US" sz="1600" dirty="0"/>
           </a:p>
@@ -2449,7 +2449,7 @@
                 <a:ea typeface="Microsoft JhengHei" pitchFamily="34" charset="-122"/>
                 <a:cs typeface="Microsoft JhengHei" pitchFamily="34" charset="-120"/>
               </a:rPr>
-              <a:t>D1 KIX→京都 · D2 京都→天滿宮→OMO7 · D3 OMO7→KIX。零轉乘、行李不離身。</a:t>
+              <a:t>D1 KIX→京都 · D3 京都→OMO7 · D6 OMO7→KIX。零轉乘、行李不離身。</a:t>
             </a:r>
             <a:endParaRPr lang="en-US" sz="1400" dirty="0"/>
           </a:p>
@@ -2517,7 +2517,7 @@
                 <a:ea typeface="Microsoft JhengHei" pitchFamily="34" charset="-122"/>
                 <a:cs typeface="Microsoft JhengHei" pitchFamily="34" charset="-120"/>
               </a:rPr>
-              <a:t>幼兒鐵律</a:t>
+              <a:t>幼兒彈性放電</a:t>
             </a:r>
             <a:endParaRPr lang="en-US" sz="1600" dirty="0"/>
           </a:p>
@@ -2556,7 +2556,7 @@
                 <a:ea typeface="Microsoft JhengHei" pitchFamily="34" charset="-122"/>
                 <a:cs typeface="Microsoft JhengHei" pitchFamily="34" charset="-120"/>
               </a:rPr>
-              <a:t>中午常態小睡不可破 · 午後室內避暑 · 推車空間優先 · 熱門小神社大人輪流抱嬰。</a:t>
+              <a:t>全室內避暑館（麵包超人/海遊館）· 天王寺集中採購 · 星野封閉大草皮安全奔跑。</a:t>
             </a:r>
             <a:endParaRPr lang="en-US" sz="1400" dirty="0"/>
           </a:p>
@@ -2786,7 +2786,7 @@
                 <a:ea typeface="Microsoft JhengHei" pitchFamily="34" charset="-122"/>
                 <a:cs typeface="Microsoft JhengHei" pitchFamily="34" charset="-120"/>
               </a:rPr>
-              <a:t>點對點專車串起京都與大阪，每天保留幼兒午睡黃金時段</a:t>
+              <a:t>點對點專車串起京都與大阪，彈性舒適放電動線</a:t>
             </a:r>
             <a:endParaRPr lang="en-US" sz="1400" dirty="0"/>
           </a:p>
@@ -3001,7 +3001,7 @@
                 <a:ea typeface="Microsoft JhengHei" pitchFamily="34" charset="-122"/>
                 <a:cs typeface="Microsoft JhengHei" pitchFamily="34" charset="-120"/>
               </a:rPr>
-              <a:t>KIX → nol sanjo</a:t>
+              <a:t>御金神社快閃</a:t>
             </a:r>
             <a:endParaRPr lang="en-US" sz="1200" dirty="0"/>
           </a:p>
@@ -3018,7 +3018,7 @@
                 <a:ea typeface="Microsoft JhengHei" pitchFamily="34" charset="-122"/>
                 <a:cs typeface="Microsoft JhengHei" pitchFamily="34" charset="-120"/>
               </a:rPr>
-              <a:t>LE LABO 散步</a:t>
+              <a:t>HUMAN MADE</a:t>
             </a:r>
             <a:endParaRPr lang="en-US" sz="1200" dirty="0"/>
           </a:p>
@@ -3194,7 +3194,7 @@
                 <a:ea typeface="Microsoft JhengHei" pitchFamily="34" charset="-122"/>
                 <a:cs typeface="Microsoft JhengHei" pitchFamily="34" charset="-120"/>
               </a:rPr>
-              <a:t>財運 · 古城</a:t>
+              <a:t>烏丸燒肉</a:t>
             </a:r>
             <a:endParaRPr lang="en-US" sz="1600" dirty="0"/>
           </a:p>
@@ -3233,7 +3233,7 @@
                 <a:ea typeface="Microsoft JhengHei" pitchFamily="34" charset="-122"/>
                 <a:cs typeface="Microsoft JhengHei" pitchFamily="34" charset="-120"/>
               </a:rPr>
-              <a:t>御金神社 → 二条城</a:t>
+              <a:t>大丸 · 敘敘苑</a:t>
             </a:r>
             <a:endParaRPr lang="en-US" sz="1200" dirty="0"/>
           </a:p>
@@ -3250,7 +3250,7 @@
                 <a:ea typeface="Microsoft JhengHei" pitchFamily="34" charset="-122"/>
                 <a:cs typeface="Microsoft JhengHei" pitchFamily="34" charset="-120"/>
               </a:rPr>
-              <a:t>京瓷美術館</a:t>
+              <a:t>天滿宮 &amp; 檀王</a:t>
             </a:r>
             <a:endParaRPr lang="en-US" sz="1200" dirty="0"/>
           </a:p>
@@ -3426,7 +3426,7 @@
                 <a:ea typeface="Microsoft JhengHei" pitchFamily="34" charset="-122"/>
                 <a:cs typeface="Microsoft JhengHei" pitchFamily="34" charset="-120"/>
               </a:rPr>
-              <a:t>轉進大阪</a:t>
+              <a:t>專車轉進</a:t>
             </a:r>
             <a:endParaRPr lang="en-US" sz="1600" dirty="0"/>
           </a:p>
@@ -3465,7 +3465,7 @@
                 <a:ea typeface="Microsoft JhengHei" pitchFamily="34" charset="-122"/>
                 <a:cs typeface="Microsoft JhengHei" pitchFamily="34" charset="-120"/>
               </a:rPr>
-              <a:t>吉祥院天滿宮</a:t>
+              <a:t>飯店直達 OMO7</a:t>
             </a:r>
             <a:endParaRPr lang="en-US" sz="1200" dirty="0"/>
           </a:p>
@@ -3482,7 +3482,7 @@
                 <a:ea typeface="Microsoft JhengHei" pitchFamily="34" charset="-122"/>
                 <a:cs typeface="Microsoft JhengHei" pitchFamily="34" charset="-120"/>
               </a:rPr>
-              <a:t>OMO7 大草皮</a:t>
+              <a:t>Miya 大草皮</a:t>
             </a:r>
             <a:endParaRPr lang="en-US" sz="1200" dirty="0"/>
           </a:p>
@@ -3658,7 +3658,7 @@
                 <a:ea typeface="Microsoft JhengHei" pitchFamily="34" charset="-122"/>
                 <a:cs typeface="Microsoft JhengHei" pitchFamily="34" charset="-120"/>
               </a:rPr>
-              <a:t>深海 · 高空</a:t>
+              <a:t>神戶 · 夜景</a:t>
             </a:r>
             <a:endParaRPr lang="en-US" sz="1600" dirty="0"/>
           </a:p>
@@ -3697,7 +3697,7 @@
                 <a:ea typeface="Microsoft JhengHei" pitchFamily="34" charset="-122"/>
                 <a:cs typeface="Microsoft JhengHei" pitchFamily="34" charset="-120"/>
               </a:rPr>
-              <a:t>海遊館</a:t>
+              <a:t>麵包超人博物館</a:t>
             </a:r>
             <a:endParaRPr lang="en-US" sz="1200" dirty="0"/>
           </a:p>
@@ -3714,7 +3714,7 @@
                 <a:ea typeface="Microsoft JhengHei" pitchFamily="34" charset="-122"/>
                 <a:cs typeface="Microsoft JhengHei" pitchFamily="34" charset="-120"/>
               </a:rPr>
-              <a:t>Harukas 夜景</a:t>
+              <a:t>Harukas &amp; 阿卡將</a:t>
             </a:r>
             <a:endParaRPr lang="en-US" sz="1200" dirty="0"/>
           </a:p>
@@ -3890,7 +3890,7 @@
                 <a:ea typeface="Microsoft JhengHei" pitchFamily="34" charset="-122"/>
                 <a:cs typeface="Microsoft JhengHei" pitchFamily="34" charset="-120"/>
               </a:rPr>
-              <a:t>神戶 · 採購</a:t>
+              <a:t>深海 · 草皮</a:t>
             </a:r>
             <a:endParaRPr lang="en-US" sz="1600" dirty="0"/>
           </a:p>
@@ -3929,7 +3929,7 @@
                 <a:ea typeface="Microsoft JhengHei" pitchFamily="34" charset="-122"/>
                 <a:cs typeface="Microsoft JhengHei" pitchFamily="34" charset="-120"/>
               </a:rPr>
-              <a:t>麵包超人</a:t>
+              <a:t>天保山海遊館</a:t>
             </a:r>
             <a:endParaRPr lang="en-US" sz="1200" dirty="0"/>
           </a:p>
@@ -3946,7 +3946,7 @@
                 <a:ea typeface="Microsoft JhengHei" pitchFamily="34" charset="-122"/>
                 <a:cs typeface="Microsoft JhengHei" pitchFamily="34" charset="-120"/>
               </a:rPr>
-              <a:t>大丸心齋橋</a:t>
+              <a:t>OMO7 草皮散步</a:t>
             </a:r>
             <a:endParaRPr lang="en-US" sz="1200" dirty="0"/>
           </a:p>
@@ -4394,7 +4394,7 @@
                 <a:ea typeface="Microsoft JhengHei" pitchFamily="34" charset="-122"/>
                 <a:cs typeface="Microsoft JhengHei" pitchFamily="34" charset="-120"/>
               </a:rPr>
-              <a:t>抵達京都 · 專車直達與町家香氛</a:t>
+              <a:t>抵達京都 · 專車直達、御金快閃與三條美學</a:t>
             </a:r>
             <a:endParaRPr lang="en-US" sz="2600" dirty="0"/>
           </a:p>
@@ -4433,7 +4433,7 @@
                 <a:ea typeface="Microsoft JhengHei" pitchFamily="34" charset="-122"/>
                 <a:cs typeface="Microsoft JhengHei" pitchFamily="34" charset="-120"/>
               </a:rPr>
-              <a:t>8/3（週一）  ·  京都中京區  ·  「先補眠，再慢慢走進京都的午後」</a:t>
+              <a:t>8/3（週一）  ·  京都中京區  ·  「專車無縫接送，金運快閃與潮牌咖啡散步」</a:t>
             </a:r>
             <a:endParaRPr lang="en-US" sz="1300" dirty="0"/>
           </a:p>
@@ -4767,7 +4767,7 @@
                 <a:ea typeface="Microsoft JhengHei" pitchFamily="34" charset="-122"/>
                 <a:cs typeface="Microsoft JhengHei" pitchFamily="34" charset="-120"/>
               </a:rPr>
-              <a:t>專車直達 nol kyoto sanjo。車程約 80–90 分鐘，寶寶於車上繼續補眠。</a:t>
+              <a:t>專車直達 nol kyoto sanjo。車程約 80–90 分鐘，寶寶於車上休息。</a:t>
             </a:r>
             <a:endParaRPr lang="en-US" sz="1300" dirty="0"/>
           </a:p>
@@ -4856,7 +4856,7 @@
                 <a:ea typeface="Georgia" pitchFamily="34" charset="-122"/>
                 <a:cs typeface="Georgia" pitchFamily="34" charset="-120"/>
               </a:rPr>
-              <a:t>15:00</a:t>
+              <a:t>15:40–16:30</a:t>
             </a:r>
             <a:endParaRPr lang="en-US" sz="1600" dirty="0"/>
           </a:p>
@@ -4895,7 +4895,7 @@
                 <a:ea typeface="Microsoft JhengHei" pitchFamily="34" charset="-122"/>
                 <a:cs typeface="Microsoft JhengHei" pitchFamily="34" charset="-120"/>
               </a:rPr>
-              <a:t>辦理入住 · 休整</a:t>
+              <a:t>【計程車快閃】御金神社參拜</a:t>
             </a:r>
             <a:endParaRPr lang="en-US" sz="1600" dirty="0"/>
           </a:p>
@@ -4934,7 +4934,7 @@
                 <a:ea typeface="Microsoft JhengHei" pitchFamily="34" charset="-122"/>
                 <a:cs typeface="Microsoft JhengHei" pitchFamily="34" charset="-120"/>
               </a:rPr>
-              <a:t>放下行李、洗澡換裝、調整空調與尿布站。不急著出門。</a:t>
+              <a:t>飯店門口搭計程車 5 分鐘直達。參拜金山毘古神，17:00 社務所關閉前購入金運御守。</a:t>
             </a:r>
             <a:endParaRPr lang="en-US" sz="1300" dirty="0"/>
           </a:p>
@@ -4998,7 +4998,7 @@
                 <a:ea typeface="Georgia" pitchFamily="34" charset="-122"/>
                 <a:cs typeface="Georgia" pitchFamily="34" charset="-120"/>
               </a:rPr>
-              <a:t>傍晚</a:t>
+              <a:t>16:40–17:30</a:t>
             </a:r>
             <a:endParaRPr lang="en-US" sz="1600" dirty="0"/>
           </a:p>
@@ -5037,7 +5037,7 @@
                 <a:ea typeface="Microsoft JhengHei" pitchFamily="34" charset="-122"/>
                 <a:cs typeface="Microsoft JhengHei" pitchFamily="34" charset="-120"/>
               </a:rPr>
-              <a:t>LE LABO KYOTO → 周邊超市</a:t>
+              <a:t>HUMAN MADE 1928 &amp; LE LABO</a:t>
             </a:r>
             <a:endParaRPr lang="en-US" sz="1600" dirty="0"/>
           </a:p>
@@ -5076,7 +5076,7 @@
                 <a:ea typeface="Microsoft JhengHei" pitchFamily="34" charset="-122"/>
                 <a:cs typeface="Microsoft JhengHei" pitchFamily="34" charset="-120"/>
               </a:rPr>
-              <a:t>町家改建香氛店美學考察，再到質感超市採購鮮乳與幼兒物資。</a:t>
+              <a:t>HUMAN MADE 1928 Cafe by Blue Bottle Coffee 與 LE LABO KYOTO 美學散步（離飯店 350m）。</a:t>
             </a:r>
             <a:endParaRPr lang="en-US" sz="1300" dirty="0"/>
           </a:p>
@@ -5292,7 +5292,7 @@
                 <a:ea typeface="Microsoft JhengHei" pitchFamily="34" charset="-122"/>
                 <a:cs typeface="Microsoft JhengHei" pitchFamily="34" charset="-120"/>
               </a:rPr>
-              <a:t>財運祈願 · 古城放電 · 美術館避暑</a:t>
+              <a:t>烏丸極致體驗 · 敘敘苑燒肉與雙神社參拜</a:t>
             </a:r>
             <a:endParaRPr lang="en-US" sz="2400" dirty="0"/>
           </a:p>
@@ -5331,7 +5331,7 @@
                 <a:ea typeface="Microsoft JhengHei" pitchFamily="34" charset="-122"/>
                 <a:cs typeface="Microsoft JhengHei" pitchFamily="34" charset="-120"/>
               </a:rPr>
-              <a:t>8/4（週二）  ·  御金神社 → 二条城 → 京瓷美術館 → 鴨川</a:t>
+              <a:t>8/4（週二）  ·  鴨川散步 → 大丸/SHAKE SHACK → 敘敘苑 → 吉祥院天滿宮 → 檀王法林寺</a:t>
             </a:r>
             <a:endParaRPr lang="en-US" sz="1300" dirty="0"/>
           </a:p>
@@ -5346,6 +5346,738 @@
         <p:spPr>
           <a:xfrm>
             <a:off x="457200" y="1645920"/>
+            <a:ext cx="2194560" cy="2286000"/>
+          </a:xfrm>
+          <a:prstGeom prst="roundRect">
+            <a:avLst>
+              <a:gd name="adj" fmla="val 4167"/>
+            </a:avLst>
+          </a:prstGeom>
+          <a:solidFill>
+            <a:srgbClr val="FFF8EB"/>
+          </a:solidFill>
+          <a:ln w="19050">
+            <a:solidFill>
+              <a:srgbClr val="6B7F5A"/>
+            </a:solidFill>
+            <a:prstDash val="solid"/>
+          </a:ln>
+        </p:spPr>
+      </p:sp>
+      <p:sp>
+        <p:nvSpPr>
+          <p:cNvPr id="9" name="Text 7"/>
+          <p:cNvSpPr/>
+          <p:nvPr/>
+        </p:nvSpPr>
+        <p:spPr>
+          <a:xfrm>
+            <a:off x="457200" y="1828800"/>
+            <a:ext cx="2194560" cy="320040"/>
+          </a:xfrm>
+          <a:prstGeom prst="rect">
+            <a:avLst/>
+          </a:prstGeom>
+          <a:noFill/>
+          <a:ln/>
+        </p:spPr>
+        <p:txBody>
+          <a:bodyPr wrap="square" lIns="0" tIns="0" rIns="0" bIns="0" rtlCol="0" anchor="ctr"/>
+          <a:lstStyle/>
+          <a:p>
+            <a:pPr algn="ctr" indent="0" marL="0">
+              <a:buNone/>
+            </a:pPr>
+            <a:r>
+              <a:rPr lang="en-US" sz="1200" b="1" dirty="0">
+                <a:solidFill>
+                  <a:srgbClr val="6B7F5A"/>
+                </a:solidFill>
+                <a:latin typeface="Georgia" pitchFamily="34" charset="0"/>
+                <a:ea typeface="Georgia" pitchFamily="34" charset="-122"/>
+                <a:cs typeface="Georgia" pitchFamily="34" charset="-120"/>
+              </a:rPr>
+              <a:t>09:00–10:15</a:t>
+            </a:r>
+            <a:endParaRPr lang="en-US" sz="1200" dirty="0"/>
+          </a:p>
+        </p:txBody>
+      </p:sp>
+      <p:sp>
+        <p:nvSpPr>
+          <p:cNvPr id="10" name="Text 8"/>
+          <p:cNvSpPr/>
+          <p:nvPr/>
+        </p:nvSpPr>
+        <p:spPr>
+          <a:xfrm>
+            <a:off x="548640" y="2331720"/>
+            <a:ext cx="2011680" cy="640080"/>
+          </a:xfrm>
+          <a:prstGeom prst="rect">
+            <a:avLst/>
+          </a:prstGeom>
+          <a:noFill/>
+          <a:ln/>
+        </p:spPr>
+        <p:txBody>
+          <a:bodyPr wrap="square" lIns="0" tIns="0" rIns="0" bIns="0" rtlCol="0" anchor="ctr"/>
+          <a:lstStyle/>
+          <a:p>
+            <a:pPr algn="ctr" indent="0" marL="0">
+              <a:buNone/>
+            </a:pPr>
+            <a:r>
+              <a:rPr lang="en-US" sz="1700" b="1" dirty="0">
+                <a:solidFill>
+                  <a:srgbClr val="2A2218"/>
+                </a:solidFill>
+                <a:latin typeface="Microsoft JhengHei" pitchFamily="34" charset="0"/>
+                <a:ea typeface="Microsoft JhengHei" pitchFamily="34" charset="-122"/>
+                <a:cs typeface="Microsoft JhengHei" pitchFamily="34" charset="-120"/>
+              </a:rPr>
+              <a:t>鴨川/三條散步</a:t>
+            </a:r>
+            <a:endParaRPr lang="en-US" sz="1700" dirty="0"/>
+          </a:p>
+        </p:txBody>
+      </p:sp>
+      <p:sp>
+        <p:nvSpPr>
+          <p:cNvPr id="11" name="Text 9"/>
+          <p:cNvSpPr/>
+          <p:nvPr/>
+        </p:nvSpPr>
+        <p:spPr>
+          <a:xfrm>
+            <a:off x="548640" y="3108960"/>
+            <a:ext cx="2011680" cy="502920"/>
+          </a:xfrm>
+          <a:prstGeom prst="rect">
+            <a:avLst/>
+          </a:prstGeom>
+          <a:noFill/>
+          <a:ln/>
+        </p:spPr>
+        <p:txBody>
+          <a:bodyPr wrap="square" lIns="0" tIns="0" rIns="0" bIns="0" rtlCol="0" anchor="ctr"/>
+          <a:lstStyle/>
+          <a:p>
+            <a:pPr algn="ctr" indent="0" marL="0">
+              <a:buNone/>
+            </a:pPr>
+            <a:r>
+              <a:rPr lang="en-US" sz="1200" dirty="0">
+                <a:solidFill>
+                  <a:srgbClr val="5C4A38"/>
+                </a:solidFill>
+                <a:latin typeface="Microsoft JhengHei" pitchFamily="34" charset="0"/>
+                <a:ea typeface="Microsoft JhengHei" pitchFamily="34" charset="-122"/>
+                <a:cs typeface="Microsoft JhengHei" pitchFamily="34" charset="-120"/>
+              </a:rPr>
+              <a:t>晨間推車涼風</a:t>
+            </a:r>
+            <a:endParaRPr lang="en-US" sz="1200" dirty="0"/>
+          </a:p>
+        </p:txBody>
+      </p:sp>
+      <p:sp>
+        <p:nvSpPr>
+          <p:cNvPr id="12" name="Text 10"/>
+          <p:cNvSpPr/>
+          <p:nvPr/>
+        </p:nvSpPr>
+        <p:spPr>
+          <a:xfrm>
+            <a:off x="2468880" y="2468880"/>
+            <a:ext cx="365760" cy="365760"/>
+          </a:xfrm>
+          <a:prstGeom prst="rect">
+            <a:avLst/>
+          </a:prstGeom>
+          <a:noFill/>
+          <a:ln/>
+        </p:spPr>
+        <p:txBody>
+          <a:bodyPr wrap="square" lIns="0" tIns="0" rIns="0" bIns="0" rtlCol="0" anchor="ctr"/>
+          <a:lstStyle/>
+          <a:p>
+            <a:pPr indent="0" marL="0">
+              <a:buNone/>
+            </a:pPr>
+            <a:r>
+              <a:rPr lang="en-US" sz="2000" b="1" dirty="0">
+                <a:solidFill>
+                  <a:srgbClr val="9A7B1A"/>
+                </a:solidFill>
+                <a:latin typeface="Georgia" pitchFamily="34" charset="0"/>
+                <a:ea typeface="Georgia" pitchFamily="34" charset="-122"/>
+                <a:cs typeface="Georgia" pitchFamily="34" charset="-120"/>
+              </a:rPr>
+              <a:t>→</a:t>
+            </a:r>
+            <a:endParaRPr lang="en-US" sz="2000" dirty="0"/>
+          </a:p>
+        </p:txBody>
+      </p:sp>
+      <p:sp>
+        <p:nvSpPr>
+          <p:cNvPr id="13" name="Shape 11"/>
+          <p:cNvSpPr/>
+          <p:nvPr/>
+        </p:nvSpPr>
+        <p:spPr>
+          <a:xfrm>
+            <a:off x="2788920" y="1645920"/>
+            <a:ext cx="2194560" cy="2286000"/>
+          </a:xfrm>
+          <a:prstGeom prst="roundRect">
+            <a:avLst>
+              <a:gd name="adj" fmla="val 4167"/>
+            </a:avLst>
+          </a:prstGeom>
+          <a:solidFill>
+            <a:srgbClr val="FFF8EB"/>
+          </a:solidFill>
+          <a:ln w="19050">
+            <a:solidFill>
+              <a:srgbClr val="4A6B7C"/>
+            </a:solidFill>
+            <a:prstDash val="solid"/>
+          </a:ln>
+        </p:spPr>
+      </p:sp>
+      <p:sp>
+        <p:nvSpPr>
+          <p:cNvPr id="14" name="Text 12"/>
+          <p:cNvSpPr/>
+          <p:nvPr/>
+        </p:nvSpPr>
+        <p:spPr>
+          <a:xfrm>
+            <a:off x="2788920" y="1828800"/>
+            <a:ext cx="2194560" cy="320040"/>
+          </a:xfrm>
+          <a:prstGeom prst="rect">
+            <a:avLst/>
+          </a:prstGeom>
+          <a:noFill/>
+          <a:ln/>
+        </p:spPr>
+        <p:txBody>
+          <a:bodyPr wrap="square" lIns="0" tIns="0" rIns="0" bIns="0" rtlCol="0" anchor="ctr"/>
+          <a:lstStyle/>
+          <a:p>
+            <a:pPr algn="ctr" indent="0" marL="0">
+              <a:buNone/>
+            </a:pPr>
+            <a:r>
+              <a:rPr lang="en-US" sz="1200" b="1" dirty="0">
+                <a:solidFill>
+                  <a:srgbClr val="4A6B7C"/>
+                </a:solidFill>
+                <a:latin typeface="Georgia" pitchFamily="34" charset="0"/>
+                <a:ea typeface="Georgia" pitchFamily="34" charset="-122"/>
+                <a:cs typeface="Georgia" pitchFamily="34" charset="-120"/>
+              </a:rPr>
+              <a:t>10:30–12:20</a:t>
+            </a:r>
+            <a:endParaRPr lang="en-US" sz="1200" dirty="0"/>
+          </a:p>
+        </p:txBody>
+      </p:sp>
+      <p:sp>
+        <p:nvSpPr>
+          <p:cNvPr id="15" name="Text 13"/>
+          <p:cNvSpPr/>
+          <p:nvPr/>
+        </p:nvSpPr>
+        <p:spPr>
+          <a:xfrm>
+            <a:off x="2880360" y="2331720"/>
+            <a:ext cx="2011680" cy="640080"/>
+          </a:xfrm>
+          <a:prstGeom prst="rect">
+            <a:avLst/>
+          </a:prstGeom>
+          <a:noFill/>
+          <a:ln/>
+        </p:spPr>
+        <p:txBody>
+          <a:bodyPr wrap="square" lIns="0" tIns="0" rIns="0" bIns="0" rtlCol="0" anchor="ctr"/>
+          <a:lstStyle/>
+          <a:p>
+            <a:pPr algn="ctr" indent="0" marL="0">
+              <a:buNone/>
+            </a:pPr>
+            <a:r>
+              <a:rPr lang="en-US" sz="1700" b="1" dirty="0">
+                <a:solidFill>
+                  <a:srgbClr val="2A2218"/>
+                </a:solidFill>
+                <a:latin typeface="Microsoft JhengHei" pitchFamily="34" charset="0"/>
+                <a:ea typeface="Microsoft JhengHei" pitchFamily="34" charset="-122"/>
+                <a:cs typeface="Microsoft JhengHei" pitchFamily="34" charset="-120"/>
+              </a:rPr>
+              <a:t>大丸/SHAKE SHACK</a:t>
+            </a:r>
+            <a:endParaRPr lang="en-US" sz="1700" dirty="0"/>
+          </a:p>
+        </p:txBody>
+      </p:sp>
+      <p:sp>
+        <p:nvSpPr>
+          <p:cNvPr id="16" name="Text 14"/>
+          <p:cNvSpPr/>
+          <p:nvPr/>
+        </p:nvSpPr>
+        <p:spPr>
+          <a:xfrm>
+            <a:off x="2880360" y="3108960"/>
+            <a:ext cx="2011680" cy="502920"/>
+          </a:xfrm>
+          <a:prstGeom prst="rect">
+            <a:avLst/>
+          </a:prstGeom>
+          <a:noFill/>
+          <a:ln/>
+        </p:spPr>
+        <p:txBody>
+          <a:bodyPr wrap="square" lIns="0" tIns="0" rIns="0" bIns="0" rtlCol="0" anchor="ctr"/>
+          <a:lstStyle/>
+          <a:p>
+            <a:pPr algn="ctr" indent="0" marL="0">
+              <a:buNone/>
+            </a:pPr>
+            <a:r>
+              <a:rPr lang="en-US" sz="1200" dirty="0">
+                <a:solidFill>
+                  <a:srgbClr val="5C4A38"/>
+                </a:solidFill>
+                <a:latin typeface="Microsoft JhengHei" pitchFamily="34" charset="0"/>
+                <a:ea typeface="Microsoft JhengHei" pitchFamily="34" charset="-122"/>
+                <a:cs typeface="Microsoft JhengHei" pitchFamily="34" charset="-120"/>
+              </a:rPr>
+              <a:t>寶可夢中心避暑</a:t>
+            </a:r>
+            <a:endParaRPr lang="en-US" sz="1200" dirty="0"/>
+          </a:p>
+        </p:txBody>
+      </p:sp>
+      <p:sp>
+        <p:nvSpPr>
+          <p:cNvPr id="17" name="Text 15"/>
+          <p:cNvSpPr/>
+          <p:nvPr/>
+        </p:nvSpPr>
+        <p:spPr>
+          <a:xfrm>
+            <a:off x="4800600" y="2468880"/>
+            <a:ext cx="365760" cy="365760"/>
+          </a:xfrm>
+          <a:prstGeom prst="rect">
+            <a:avLst/>
+          </a:prstGeom>
+          <a:noFill/>
+          <a:ln/>
+        </p:spPr>
+        <p:txBody>
+          <a:bodyPr wrap="square" lIns="0" tIns="0" rIns="0" bIns="0" rtlCol="0" anchor="ctr"/>
+          <a:lstStyle/>
+          <a:p>
+            <a:pPr indent="0" marL="0">
+              <a:buNone/>
+            </a:pPr>
+            <a:r>
+              <a:rPr lang="en-US" sz="2000" b="1" dirty="0">
+                <a:solidFill>
+                  <a:srgbClr val="9A7B1A"/>
+                </a:solidFill>
+                <a:latin typeface="Georgia" pitchFamily="34" charset="0"/>
+                <a:ea typeface="Georgia" pitchFamily="34" charset="-122"/>
+                <a:cs typeface="Georgia" pitchFamily="34" charset="-120"/>
+              </a:rPr>
+              <a:t>→</a:t>
+            </a:r>
+            <a:endParaRPr lang="en-US" sz="2000" dirty="0"/>
+          </a:p>
+        </p:txBody>
+      </p:sp>
+      <p:sp>
+        <p:nvSpPr>
+          <p:cNvPr id="18" name="Shape 16"/>
+          <p:cNvSpPr/>
+          <p:nvPr/>
+        </p:nvSpPr>
+        <p:spPr>
+          <a:xfrm>
+            <a:off x="5120640" y="1645920"/>
+            <a:ext cx="2194560" cy="2286000"/>
+          </a:xfrm>
+          <a:prstGeom prst="roundRect">
+            <a:avLst>
+              <a:gd name="adj" fmla="val 4167"/>
+            </a:avLst>
+          </a:prstGeom>
+          <a:solidFill>
+            <a:srgbClr val="FFF8EB"/>
+          </a:solidFill>
+          <a:ln w="19050">
+            <a:solidFill>
+              <a:srgbClr val="C23B22"/>
+            </a:solidFill>
+            <a:prstDash val="solid"/>
+          </a:ln>
+        </p:spPr>
+      </p:sp>
+      <p:sp>
+        <p:nvSpPr>
+          <p:cNvPr id="19" name="Text 17"/>
+          <p:cNvSpPr/>
+          <p:nvPr/>
+        </p:nvSpPr>
+        <p:spPr>
+          <a:xfrm>
+            <a:off x="5120640" y="1828800"/>
+            <a:ext cx="2194560" cy="320040"/>
+          </a:xfrm>
+          <a:prstGeom prst="rect">
+            <a:avLst/>
+          </a:prstGeom>
+          <a:noFill/>
+          <a:ln/>
+        </p:spPr>
+        <p:txBody>
+          <a:bodyPr wrap="square" lIns="0" tIns="0" rIns="0" bIns="0" rtlCol="0" anchor="ctr"/>
+          <a:lstStyle/>
+          <a:p>
+            <a:pPr algn="ctr" indent="0" marL="0">
+              <a:buNone/>
+            </a:pPr>
+            <a:r>
+              <a:rPr lang="en-US" sz="1200" b="1" dirty="0">
+                <a:solidFill>
+                  <a:srgbClr val="C23B22"/>
+                </a:solidFill>
+                <a:latin typeface="Georgia" pitchFamily="34" charset="0"/>
+                <a:ea typeface="Georgia" pitchFamily="34" charset="-122"/>
+                <a:cs typeface="Georgia" pitchFamily="34" charset="-120"/>
+              </a:rPr>
+              <a:t>12:30–14:00</a:t>
+            </a:r>
+            <a:endParaRPr lang="en-US" sz="1200" dirty="0"/>
+          </a:p>
+        </p:txBody>
+      </p:sp>
+      <p:sp>
+        <p:nvSpPr>
+          <p:cNvPr id="20" name="Text 18"/>
+          <p:cNvSpPr/>
+          <p:nvPr/>
+        </p:nvSpPr>
+        <p:spPr>
+          <a:xfrm>
+            <a:off x="5212080" y="2331720"/>
+            <a:ext cx="2011680" cy="640080"/>
+          </a:xfrm>
+          <a:prstGeom prst="rect">
+            <a:avLst/>
+          </a:prstGeom>
+          <a:noFill/>
+          <a:ln/>
+        </p:spPr>
+        <p:txBody>
+          <a:bodyPr wrap="square" lIns="0" tIns="0" rIns="0" bIns="0" rtlCol="0" anchor="ctr"/>
+          <a:lstStyle/>
+          <a:p>
+            <a:pPr algn="ctr" indent="0" marL="0">
+              <a:buNone/>
+            </a:pPr>
+            <a:r>
+              <a:rPr lang="en-US" sz="1700" b="1" dirty="0">
+                <a:solidFill>
+                  <a:srgbClr val="2A2218"/>
+                </a:solidFill>
+                <a:latin typeface="Microsoft JhengHei" pitchFamily="34" charset="0"/>
+                <a:ea typeface="Microsoft JhengHei" pitchFamily="34" charset="-122"/>
+                <a:cs typeface="Microsoft JhengHei" pitchFamily="34" charset="-120"/>
+              </a:rPr>
+              <a:t>敘敘苑 四條烏丸</a:t>
+            </a:r>
+            <a:endParaRPr lang="en-US" sz="1700" dirty="0"/>
+          </a:p>
+        </p:txBody>
+      </p:sp>
+      <p:sp>
+        <p:nvSpPr>
+          <p:cNvPr id="21" name="Text 19"/>
+          <p:cNvSpPr/>
+          <p:nvPr/>
+        </p:nvSpPr>
+        <p:spPr>
+          <a:xfrm>
+            <a:off x="5212080" y="3108960"/>
+            <a:ext cx="2011680" cy="502920"/>
+          </a:xfrm>
+          <a:prstGeom prst="rect">
+            <a:avLst/>
+          </a:prstGeom>
+          <a:noFill/>
+          <a:ln/>
+        </p:spPr>
+        <p:txBody>
+          <a:bodyPr wrap="square" lIns="0" tIns="0" rIns="0" bIns="0" rtlCol="0" anchor="ctr"/>
+          <a:lstStyle/>
+          <a:p>
+            <a:pPr algn="ctr" indent="0" marL="0">
+              <a:buNone/>
+            </a:pPr>
+            <a:r>
+              <a:rPr lang="en-US" sz="1200" dirty="0">
+                <a:solidFill>
+                  <a:srgbClr val="5C4A38"/>
+                </a:solidFill>
+                <a:latin typeface="Microsoft JhengHei" pitchFamily="34" charset="0"/>
+                <a:ea typeface="Microsoft JhengHei" pitchFamily="34" charset="-122"/>
+                <a:cs typeface="Microsoft JhengHei" pitchFamily="34" charset="-120"/>
+              </a:rPr>
+              <a:t>已預訂 · 頂級燒肉</a:t>
+            </a:r>
+            <a:endParaRPr lang="en-US" sz="1200" dirty="0"/>
+          </a:p>
+        </p:txBody>
+      </p:sp>
+      <p:sp>
+        <p:nvSpPr>
+          <p:cNvPr id="22" name="Text 20"/>
+          <p:cNvSpPr/>
+          <p:nvPr/>
+        </p:nvSpPr>
+        <p:spPr>
+          <a:xfrm>
+            <a:off x="7132320" y="2468880"/>
+            <a:ext cx="365760" cy="365760"/>
+          </a:xfrm>
+          <a:prstGeom prst="rect">
+            <a:avLst/>
+          </a:prstGeom>
+          <a:noFill/>
+          <a:ln/>
+        </p:spPr>
+        <p:txBody>
+          <a:bodyPr wrap="square" lIns="0" tIns="0" rIns="0" bIns="0" rtlCol="0" anchor="ctr"/>
+          <a:lstStyle/>
+          <a:p>
+            <a:pPr indent="0" marL="0">
+              <a:buNone/>
+            </a:pPr>
+            <a:r>
+              <a:rPr lang="en-US" sz="2000" b="1" dirty="0">
+                <a:solidFill>
+                  <a:srgbClr val="9A7B1A"/>
+                </a:solidFill>
+                <a:latin typeface="Georgia" pitchFamily="34" charset="0"/>
+                <a:ea typeface="Georgia" pitchFamily="34" charset="-122"/>
+                <a:cs typeface="Georgia" pitchFamily="34" charset="-120"/>
+              </a:rPr>
+              <a:t>→</a:t>
+            </a:r>
+            <a:endParaRPr lang="en-US" sz="2000" dirty="0"/>
+          </a:p>
+        </p:txBody>
+      </p:sp>
+      <p:sp>
+        <p:nvSpPr>
+          <p:cNvPr id="23" name="Shape 21"/>
+          <p:cNvSpPr/>
+          <p:nvPr/>
+        </p:nvSpPr>
+        <p:spPr>
+          <a:xfrm>
+            <a:off x="7452360" y="1645920"/>
+            <a:ext cx="2194560" cy="2286000"/>
+          </a:xfrm>
+          <a:prstGeom prst="roundRect">
+            <a:avLst>
+              <a:gd name="adj" fmla="val 4167"/>
+            </a:avLst>
+          </a:prstGeom>
+          <a:solidFill>
+            <a:srgbClr val="FFF8EB"/>
+          </a:solidFill>
+          <a:ln w="19050">
+            <a:solidFill>
+              <a:srgbClr val="2A2218"/>
+            </a:solidFill>
+            <a:prstDash val="solid"/>
+          </a:ln>
+        </p:spPr>
+      </p:sp>
+      <p:sp>
+        <p:nvSpPr>
+          <p:cNvPr id="24" name="Text 22"/>
+          <p:cNvSpPr/>
+          <p:nvPr/>
+        </p:nvSpPr>
+        <p:spPr>
+          <a:xfrm>
+            <a:off x="7452360" y="1828800"/>
+            <a:ext cx="2194560" cy="320040"/>
+          </a:xfrm>
+          <a:prstGeom prst="rect">
+            <a:avLst/>
+          </a:prstGeom>
+          <a:noFill/>
+          <a:ln/>
+        </p:spPr>
+        <p:txBody>
+          <a:bodyPr wrap="square" lIns="0" tIns="0" rIns="0" bIns="0" rtlCol="0" anchor="ctr"/>
+          <a:lstStyle/>
+          <a:p>
+            <a:pPr algn="ctr" indent="0" marL="0">
+              <a:buNone/>
+            </a:pPr>
+            <a:r>
+              <a:rPr lang="en-US" sz="1200" b="1" dirty="0">
+                <a:solidFill>
+                  <a:srgbClr val="2A2218"/>
+                </a:solidFill>
+                <a:latin typeface="Georgia" pitchFamily="34" charset="0"/>
+                <a:ea typeface="Georgia" pitchFamily="34" charset="-122"/>
+                <a:cs typeface="Georgia" pitchFamily="34" charset="-120"/>
+              </a:rPr>
+              <a:t>14:15–15:00</a:t>
+            </a:r>
+            <a:endParaRPr lang="en-US" sz="1200" dirty="0"/>
+          </a:p>
+        </p:txBody>
+      </p:sp>
+      <p:sp>
+        <p:nvSpPr>
+          <p:cNvPr id="25" name="Text 23"/>
+          <p:cNvSpPr/>
+          <p:nvPr/>
+        </p:nvSpPr>
+        <p:spPr>
+          <a:xfrm>
+            <a:off x="7543800" y="2331720"/>
+            <a:ext cx="2011680" cy="640080"/>
+          </a:xfrm>
+          <a:prstGeom prst="rect">
+            <a:avLst/>
+          </a:prstGeom>
+          <a:noFill/>
+          <a:ln/>
+        </p:spPr>
+        <p:txBody>
+          <a:bodyPr wrap="square" lIns="0" tIns="0" rIns="0" bIns="0" rtlCol="0" anchor="ctr"/>
+          <a:lstStyle/>
+          <a:p>
+            <a:pPr algn="ctr" indent="0" marL="0">
+              <a:buNone/>
+            </a:pPr>
+            <a:r>
+              <a:rPr lang="en-US" sz="1700" b="1" dirty="0">
+                <a:solidFill>
+                  <a:srgbClr val="2A2218"/>
+                </a:solidFill>
+                <a:latin typeface="Microsoft JhengHei" pitchFamily="34" charset="0"/>
+                <a:ea typeface="Microsoft JhengHei" pitchFamily="34" charset="-122"/>
+                <a:cs typeface="Microsoft JhengHei" pitchFamily="34" charset="-120"/>
+              </a:rPr>
+              <a:t>吉祥院天滿宮</a:t>
+            </a:r>
+            <a:endParaRPr lang="en-US" sz="1700" dirty="0"/>
+          </a:p>
+        </p:txBody>
+      </p:sp>
+      <p:sp>
+        <p:nvSpPr>
+          <p:cNvPr id="26" name="Text 24"/>
+          <p:cNvSpPr/>
+          <p:nvPr/>
+        </p:nvSpPr>
+        <p:spPr>
+          <a:xfrm>
+            <a:off x="7543800" y="3108960"/>
+            <a:ext cx="2011680" cy="502920"/>
+          </a:xfrm>
+          <a:prstGeom prst="rect">
+            <a:avLst/>
+          </a:prstGeom>
+          <a:noFill/>
+          <a:ln/>
+        </p:spPr>
+        <p:txBody>
+          <a:bodyPr wrap="square" lIns="0" tIns="0" rIns="0" bIns="0" rtlCol="0" anchor="ctr"/>
+          <a:lstStyle/>
+          <a:p>
+            <a:pPr algn="ctr" indent="0" marL="0">
+              <a:buNone/>
+            </a:pPr>
+            <a:r>
+              <a:rPr lang="en-US" sz="1200" dirty="0">
+                <a:solidFill>
+                  <a:srgbClr val="5C4A38"/>
+                </a:solidFill>
+                <a:latin typeface="Microsoft JhengHei" pitchFamily="34" charset="0"/>
+                <a:ea typeface="Microsoft JhengHei" pitchFamily="34" charset="-122"/>
+                <a:cs typeface="Microsoft JhengHei" pitchFamily="34" charset="-120"/>
+              </a:rPr>
+              <a:t>計程車 18 分參拜</a:t>
+            </a:r>
+            <a:endParaRPr lang="en-US" sz="1200" dirty="0"/>
+          </a:p>
+        </p:txBody>
+      </p:sp>
+      <p:sp>
+        <p:nvSpPr>
+          <p:cNvPr id="27" name="Text 25"/>
+          <p:cNvSpPr/>
+          <p:nvPr/>
+        </p:nvSpPr>
+        <p:spPr>
+          <a:xfrm>
+            <a:off x="9464040" y="2468880"/>
+            <a:ext cx="365760" cy="365760"/>
+          </a:xfrm>
+          <a:prstGeom prst="rect">
+            <a:avLst/>
+          </a:prstGeom>
+          <a:noFill/>
+          <a:ln/>
+        </p:spPr>
+        <p:txBody>
+          <a:bodyPr wrap="square" lIns="0" tIns="0" rIns="0" bIns="0" rtlCol="0" anchor="ctr"/>
+          <a:lstStyle/>
+          <a:p>
+            <a:pPr indent="0" marL="0">
+              <a:buNone/>
+            </a:pPr>
+            <a:r>
+              <a:rPr lang="en-US" sz="2000" b="1" dirty="0">
+                <a:solidFill>
+                  <a:srgbClr val="9A7B1A"/>
+                </a:solidFill>
+                <a:latin typeface="Georgia" pitchFamily="34" charset="0"/>
+                <a:ea typeface="Georgia" pitchFamily="34" charset="-122"/>
+                <a:cs typeface="Georgia" pitchFamily="34" charset="-120"/>
+              </a:rPr>
+              <a:t>→</a:t>
+            </a:r>
+            <a:endParaRPr lang="en-US" sz="2000" dirty="0"/>
+          </a:p>
+        </p:txBody>
+      </p:sp>
+      <p:sp>
+        <p:nvSpPr>
+          <p:cNvPr id="28" name="Shape 26"/>
+          <p:cNvSpPr/>
+          <p:nvPr/>
+        </p:nvSpPr>
+        <p:spPr>
+          <a:xfrm>
+            <a:off x="9784080" y="1645920"/>
             <a:ext cx="2194560" cy="2286000"/>
           </a:xfrm>
           <a:prstGeom prst="roundRect">
@@ -5366,13 +6098,13 @@
       </p:sp>
       <p:sp>
         <p:nvSpPr>
-          <p:cNvPr id="9" name="Text 7"/>
-          <p:cNvSpPr/>
-          <p:nvPr/>
-        </p:nvSpPr>
-        <p:spPr>
-          <a:xfrm>
-            <a:off x="457200" y="1828800"/>
+          <p:cNvPr id="29" name="Text 27"/>
+          <p:cNvSpPr/>
+          <p:nvPr/>
+        </p:nvSpPr>
+        <p:spPr>
+          <a:xfrm>
+            <a:off x="9784080" y="1828800"/>
             <a:ext cx="2194560" cy="320040"/>
           </a:xfrm>
           <a:prstGeom prst="rect">
@@ -5397,739 +6129,7 @@
                 <a:ea typeface="Georgia" pitchFamily="34" charset="-122"/>
                 <a:cs typeface="Georgia" pitchFamily="34" charset="-120"/>
               </a:rPr>
-              <a:t>08:00–08:30</a:t>
-            </a:r>
-            <a:endParaRPr lang="en-US" sz="1200" dirty="0"/>
-          </a:p>
-        </p:txBody>
-      </p:sp>
-      <p:sp>
-        <p:nvSpPr>
-          <p:cNvPr id="10" name="Text 8"/>
-          <p:cNvSpPr/>
-          <p:nvPr/>
-        </p:nvSpPr>
-        <p:spPr>
-          <a:xfrm>
-            <a:off x="548640" y="2331720"/>
-            <a:ext cx="2011680" cy="640080"/>
-          </a:xfrm>
-          <a:prstGeom prst="rect">
-            <a:avLst/>
-          </a:prstGeom>
-          <a:noFill/>
-          <a:ln/>
-        </p:spPr>
-        <p:txBody>
-          <a:bodyPr wrap="square" lIns="0" tIns="0" rIns="0" bIns="0" rtlCol="0" anchor="ctr"/>
-          <a:lstStyle/>
-          <a:p>
-            <a:pPr algn="ctr" indent="0" marL="0">
-              <a:buNone/>
-            </a:pPr>
-            <a:r>
-              <a:rPr lang="en-US" sz="1800" b="1" dirty="0">
-                <a:solidFill>
-                  <a:srgbClr val="2A2218"/>
-                </a:solidFill>
-                <a:latin typeface="Microsoft JhengHei" pitchFamily="34" charset="0"/>
-                <a:ea typeface="Microsoft JhengHei" pitchFamily="34" charset="-122"/>
-                <a:cs typeface="Microsoft JhengHei" pitchFamily="34" charset="-120"/>
-              </a:rPr>
-              <a:t>御金神社</a:t>
-            </a:r>
-            <a:endParaRPr lang="en-US" sz="1800" dirty="0"/>
-          </a:p>
-        </p:txBody>
-      </p:sp>
-      <p:sp>
-        <p:nvSpPr>
-          <p:cNvPr id="11" name="Text 9"/>
-          <p:cNvSpPr/>
-          <p:nvPr/>
-        </p:nvSpPr>
-        <p:spPr>
-          <a:xfrm>
-            <a:off x="548640" y="3108960"/>
-            <a:ext cx="2011680" cy="502920"/>
-          </a:xfrm>
-          <a:prstGeom prst="rect">
-            <a:avLst/>
-          </a:prstGeom>
-          <a:noFill/>
-          <a:ln/>
-        </p:spPr>
-        <p:txBody>
-          <a:bodyPr wrap="square" lIns="0" tIns="0" rIns="0" bIns="0" rtlCol="0" anchor="ctr"/>
-          <a:lstStyle/>
-          <a:p>
-            <a:pPr algn="ctr" indent="0" marL="0">
-              <a:buNone/>
-            </a:pPr>
-            <a:r>
-              <a:rPr lang="en-US" sz="1300" dirty="0">
-                <a:solidFill>
-                  <a:srgbClr val="5C4A38"/>
-                </a:solidFill>
-                <a:latin typeface="Microsoft JhengHei" pitchFamily="34" charset="0"/>
-                <a:ea typeface="Microsoft JhengHei" pitchFamily="34" charset="-122"/>
-                <a:cs typeface="Microsoft JhengHei" pitchFamily="34" charset="-120"/>
-              </a:rPr>
-              <a:t>金運快閃 15–20 分</a:t>
-            </a:r>
-            <a:endParaRPr lang="en-US" sz="1300" dirty="0"/>
-          </a:p>
-        </p:txBody>
-      </p:sp>
-      <p:sp>
-        <p:nvSpPr>
-          <p:cNvPr id="12" name="Text 10"/>
-          <p:cNvSpPr/>
-          <p:nvPr/>
-        </p:nvSpPr>
-        <p:spPr>
-          <a:xfrm>
-            <a:off x="2468880" y="2468880"/>
-            <a:ext cx="365760" cy="365760"/>
-          </a:xfrm>
-          <a:prstGeom prst="rect">
-            <a:avLst/>
-          </a:prstGeom>
-          <a:noFill/>
-          <a:ln/>
-        </p:spPr>
-        <p:txBody>
-          <a:bodyPr wrap="square" lIns="0" tIns="0" rIns="0" bIns="0" rtlCol="0" anchor="ctr"/>
-          <a:lstStyle/>
-          <a:p>
-            <a:pPr indent="0" marL="0">
-              <a:buNone/>
-            </a:pPr>
-            <a:r>
-              <a:rPr lang="en-US" sz="2000" b="1" dirty="0">
-                <a:solidFill>
-                  <a:srgbClr val="9A7B1A"/>
-                </a:solidFill>
-                <a:latin typeface="Georgia" pitchFamily="34" charset="0"/>
-                <a:ea typeface="Georgia" pitchFamily="34" charset="-122"/>
-                <a:cs typeface="Georgia" pitchFamily="34" charset="-120"/>
-              </a:rPr>
-              <a:t>→</a:t>
-            </a:r>
-            <a:endParaRPr lang="en-US" sz="2000" dirty="0"/>
-          </a:p>
-        </p:txBody>
-      </p:sp>
-      <p:sp>
-        <p:nvSpPr>
-          <p:cNvPr id="13" name="Shape 11"/>
-          <p:cNvSpPr/>
-          <p:nvPr/>
-        </p:nvSpPr>
-        <p:spPr>
-          <a:xfrm>
-            <a:off x="2788920" y="1645920"/>
-            <a:ext cx="2194560" cy="2286000"/>
-          </a:xfrm>
-          <a:prstGeom prst="roundRect">
-            <a:avLst>
-              <a:gd name="adj" fmla="val 4167"/>
-            </a:avLst>
-          </a:prstGeom>
-          <a:solidFill>
-            <a:srgbClr val="FFF8EB"/>
-          </a:solidFill>
-          <a:ln w="19050">
-            <a:solidFill>
-              <a:srgbClr val="2A2218"/>
-            </a:solidFill>
-            <a:prstDash val="solid"/>
-          </a:ln>
-        </p:spPr>
-      </p:sp>
-      <p:sp>
-        <p:nvSpPr>
-          <p:cNvPr id="14" name="Text 12"/>
-          <p:cNvSpPr/>
-          <p:nvPr/>
-        </p:nvSpPr>
-        <p:spPr>
-          <a:xfrm>
-            <a:off x="2788920" y="1828800"/>
-            <a:ext cx="2194560" cy="320040"/>
-          </a:xfrm>
-          <a:prstGeom prst="rect">
-            <a:avLst/>
-          </a:prstGeom>
-          <a:noFill/>
-          <a:ln/>
-        </p:spPr>
-        <p:txBody>
-          <a:bodyPr wrap="square" lIns="0" tIns="0" rIns="0" bIns="0" rtlCol="0" anchor="ctr"/>
-          <a:lstStyle/>
-          <a:p>
-            <a:pPr algn="ctr" indent="0" marL="0">
-              <a:buNone/>
-            </a:pPr>
-            <a:r>
-              <a:rPr lang="en-US" sz="1200" b="1" dirty="0">
-                <a:solidFill>
-                  <a:srgbClr val="2A2218"/>
-                </a:solidFill>
-                <a:latin typeface="Georgia" pitchFamily="34" charset="0"/>
-                <a:ea typeface="Georgia" pitchFamily="34" charset="-122"/>
-                <a:cs typeface="Georgia" pitchFamily="34" charset="-120"/>
-              </a:rPr>
-              <a:t>08:30–10:30</a:t>
-            </a:r>
-            <a:endParaRPr lang="en-US" sz="1200" dirty="0"/>
-          </a:p>
-        </p:txBody>
-      </p:sp>
-      <p:sp>
-        <p:nvSpPr>
-          <p:cNvPr id="15" name="Text 13"/>
-          <p:cNvSpPr/>
-          <p:nvPr/>
-        </p:nvSpPr>
-        <p:spPr>
-          <a:xfrm>
-            <a:off x="2880360" y="2331720"/>
-            <a:ext cx="2011680" cy="640080"/>
-          </a:xfrm>
-          <a:prstGeom prst="rect">
-            <a:avLst/>
-          </a:prstGeom>
-          <a:noFill/>
-          <a:ln/>
-        </p:spPr>
-        <p:txBody>
-          <a:bodyPr wrap="square" lIns="0" tIns="0" rIns="0" bIns="0" rtlCol="0" anchor="ctr"/>
-          <a:lstStyle/>
-          <a:p>
-            <a:pPr algn="ctr" indent="0" marL="0">
-              <a:buNone/>
-            </a:pPr>
-            <a:r>
-              <a:rPr lang="en-US" sz="1800" b="1" dirty="0">
-                <a:solidFill>
-                  <a:srgbClr val="2A2218"/>
-                </a:solidFill>
-                <a:latin typeface="Microsoft JhengHei" pitchFamily="34" charset="0"/>
-                <a:ea typeface="Microsoft JhengHei" pitchFamily="34" charset="-122"/>
-                <a:cs typeface="Microsoft JhengHei" pitchFamily="34" charset="-120"/>
-              </a:rPr>
-              <a:t>二条城</a:t>
-            </a:r>
-            <a:endParaRPr lang="en-US" sz="1800" dirty="0"/>
-          </a:p>
-        </p:txBody>
-      </p:sp>
-      <p:sp>
-        <p:nvSpPr>
-          <p:cNvPr id="16" name="Text 14"/>
-          <p:cNvSpPr/>
-          <p:nvPr/>
-        </p:nvSpPr>
-        <p:spPr>
-          <a:xfrm>
-            <a:off x="2880360" y="3108960"/>
-            <a:ext cx="2011680" cy="502920"/>
-          </a:xfrm>
-          <a:prstGeom prst="rect">
-            <a:avLst/>
-          </a:prstGeom>
-          <a:noFill/>
-          <a:ln/>
-        </p:spPr>
-        <p:txBody>
-          <a:bodyPr wrap="square" lIns="0" tIns="0" rIns="0" bIns="0" rtlCol="0" anchor="ctr"/>
-          <a:lstStyle/>
-          <a:p>
-            <a:pPr algn="ctr" indent="0" marL="0">
-              <a:buNone/>
-            </a:pPr>
-            <a:r>
-              <a:rPr lang="en-US" sz="1300" dirty="0">
-                <a:solidFill>
-                  <a:srgbClr val="5C4A38"/>
-                </a:solidFill>
-                <a:latin typeface="Microsoft JhengHei" pitchFamily="34" charset="0"/>
-                <a:ea typeface="Microsoft JhengHei" pitchFamily="34" charset="-122"/>
-                <a:cs typeface="Microsoft JhengHei" pitchFamily="34" charset="-120"/>
-              </a:rPr>
-              <a:t>步行 6–8 分放電</a:t>
-            </a:r>
-            <a:endParaRPr lang="en-US" sz="1300" dirty="0"/>
-          </a:p>
-        </p:txBody>
-      </p:sp>
-      <p:sp>
-        <p:nvSpPr>
-          <p:cNvPr id="17" name="Text 15"/>
-          <p:cNvSpPr/>
-          <p:nvPr/>
-        </p:nvSpPr>
-        <p:spPr>
-          <a:xfrm>
-            <a:off x="4800600" y="2468880"/>
-            <a:ext cx="365760" cy="365760"/>
-          </a:xfrm>
-          <a:prstGeom prst="rect">
-            <a:avLst/>
-          </a:prstGeom>
-          <a:noFill/>
-          <a:ln/>
-        </p:spPr>
-        <p:txBody>
-          <a:bodyPr wrap="square" lIns="0" tIns="0" rIns="0" bIns="0" rtlCol="0" anchor="ctr"/>
-          <a:lstStyle/>
-          <a:p>
-            <a:pPr indent="0" marL="0">
-              <a:buNone/>
-            </a:pPr>
-            <a:r>
-              <a:rPr lang="en-US" sz="2000" b="1" dirty="0">
-                <a:solidFill>
-                  <a:srgbClr val="9A7B1A"/>
-                </a:solidFill>
-                <a:latin typeface="Georgia" pitchFamily="34" charset="0"/>
-                <a:ea typeface="Georgia" pitchFamily="34" charset="-122"/>
-                <a:cs typeface="Georgia" pitchFamily="34" charset="-120"/>
-              </a:rPr>
-              <a:t>→</a:t>
-            </a:r>
-            <a:endParaRPr lang="en-US" sz="2000" dirty="0"/>
-          </a:p>
-        </p:txBody>
-      </p:sp>
-      <p:sp>
-        <p:nvSpPr>
-          <p:cNvPr id="18" name="Shape 16"/>
-          <p:cNvSpPr/>
-          <p:nvPr/>
-        </p:nvSpPr>
-        <p:spPr>
-          <a:xfrm>
-            <a:off x="5120640" y="1645920"/>
-            <a:ext cx="2194560" cy="2286000"/>
-          </a:xfrm>
-          <a:prstGeom prst="roundRect">
-            <a:avLst>
-              <a:gd name="adj" fmla="val 4167"/>
-            </a:avLst>
-          </a:prstGeom>
-          <a:solidFill>
-            <a:srgbClr val="FFF8EB"/>
-          </a:solidFill>
-          <a:ln w="19050">
-            <a:solidFill>
-              <a:srgbClr val="4A6B7C"/>
-            </a:solidFill>
-            <a:prstDash val="solid"/>
-          </a:ln>
-        </p:spPr>
-      </p:sp>
-      <p:sp>
-        <p:nvSpPr>
-          <p:cNvPr id="19" name="Text 17"/>
-          <p:cNvSpPr/>
-          <p:nvPr/>
-        </p:nvSpPr>
-        <p:spPr>
-          <a:xfrm>
-            <a:off x="5120640" y="1828800"/>
-            <a:ext cx="2194560" cy="320040"/>
-          </a:xfrm>
-          <a:prstGeom prst="rect">
-            <a:avLst/>
-          </a:prstGeom>
-          <a:noFill/>
-          <a:ln/>
-        </p:spPr>
-        <p:txBody>
-          <a:bodyPr wrap="square" lIns="0" tIns="0" rIns="0" bIns="0" rtlCol="0" anchor="ctr"/>
-          <a:lstStyle/>
-          <a:p>
-            <a:pPr algn="ctr" indent="0" marL="0">
-              <a:buNone/>
-            </a:pPr>
-            <a:r>
-              <a:rPr lang="en-US" sz="1200" b="1" dirty="0">
-                <a:solidFill>
-                  <a:srgbClr val="4A6B7C"/>
-                </a:solidFill>
-                <a:latin typeface="Georgia" pitchFamily="34" charset="0"/>
-                <a:ea typeface="Georgia" pitchFamily="34" charset="-122"/>
-                <a:cs typeface="Georgia" pitchFamily="34" charset="-120"/>
-              </a:rPr>
-              <a:t>11:00–14:00</a:t>
-            </a:r>
-            <a:endParaRPr lang="en-US" sz="1200" dirty="0"/>
-          </a:p>
-        </p:txBody>
-      </p:sp>
-      <p:sp>
-        <p:nvSpPr>
-          <p:cNvPr id="20" name="Text 18"/>
-          <p:cNvSpPr/>
-          <p:nvPr/>
-        </p:nvSpPr>
-        <p:spPr>
-          <a:xfrm>
-            <a:off x="5212080" y="2331720"/>
-            <a:ext cx="2011680" cy="640080"/>
-          </a:xfrm>
-          <a:prstGeom prst="rect">
-            <a:avLst/>
-          </a:prstGeom>
-          <a:noFill/>
-          <a:ln/>
-        </p:spPr>
-        <p:txBody>
-          <a:bodyPr wrap="square" lIns="0" tIns="0" rIns="0" bIns="0" rtlCol="0" anchor="ctr"/>
-          <a:lstStyle/>
-          <a:p>
-            <a:pPr algn="ctr" indent="0" marL="0">
-              <a:buNone/>
-            </a:pPr>
-            <a:r>
-              <a:rPr lang="en-US" sz="1800" b="1" dirty="0">
-                <a:solidFill>
-                  <a:srgbClr val="2A2218"/>
-                </a:solidFill>
-                <a:latin typeface="Microsoft JhengHei" pitchFamily="34" charset="0"/>
-                <a:ea typeface="Microsoft JhengHei" pitchFamily="34" charset="-122"/>
-                <a:cs typeface="Microsoft JhengHei" pitchFamily="34" charset="-120"/>
-              </a:rPr>
-              <a:t>京瓷美術館</a:t>
-            </a:r>
-            <a:endParaRPr lang="en-US" sz="1800" dirty="0"/>
-          </a:p>
-        </p:txBody>
-      </p:sp>
-      <p:sp>
-        <p:nvSpPr>
-          <p:cNvPr id="21" name="Text 19"/>
-          <p:cNvSpPr/>
-          <p:nvPr/>
-        </p:nvSpPr>
-        <p:spPr>
-          <a:xfrm>
-            <a:off x="5212080" y="3108960"/>
-            <a:ext cx="2011680" cy="502920"/>
-          </a:xfrm>
-          <a:prstGeom prst="rect">
-            <a:avLst/>
-          </a:prstGeom>
-          <a:noFill/>
-          <a:ln/>
-        </p:spPr>
-        <p:txBody>
-          <a:bodyPr wrap="square" lIns="0" tIns="0" rIns="0" bIns="0" rtlCol="0" anchor="ctr"/>
-          <a:lstStyle/>
-          <a:p>
-            <a:pPr algn="ctr" indent="0" marL="0">
-              <a:buNone/>
-            </a:pPr>
-            <a:r>
-              <a:rPr lang="en-US" sz="1300" dirty="0">
-                <a:solidFill>
-                  <a:srgbClr val="5C4A38"/>
-                </a:solidFill>
-                <a:latin typeface="Microsoft JhengHei" pitchFamily="34" charset="0"/>
-                <a:ea typeface="Microsoft JhengHei" pitchFamily="34" charset="-122"/>
-                <a:cs typeface="Microsoft JhengHei" pitchFamily="34" charset="-120"/>
-              </a:rPr>
-              <a:t>ENFUSE 午餐避暑</a:t>
-            </a:r>
-            <a:endParaRPr lang="en-US" sz="1300" dirty="0"/>
-          </a:p>
-        </p:txBody>
-      </p:sp>
-      <p:sp>
-        <p:nvSpPr>
-          <p:cNvPr id="22" name="Text 20"/>
-          <p:cNvSpPr/>
-          <p:nvPr/>
-        </p:nvSpPr>
-        <p:spPr>
-          <a:xfrm>
-            <a:off x="7132320" y="2468880"/>
-            <a:ext cx="365760" cy="365760"/>
-          </a:xfrm>
-          <a:prstGeom prst="rect">
-            <a:avLst/>
-          </a:prstGeom>
-          <a:noFill/>
-          <a:ln/>
-        </p:spPr>
-        <p:txBody>
-          <a:bodyPr wrap="square" lIns="0" tIns="0" rIns="0" bIns="0" rtlCol="0" anchor="ctr"/>
-          <a:lstStyle/>
-          <a:p>
-            <a:pPr indent="0" marL="0">
-              <a:buNone/>
-            </a:pPr>
-            <a:r>
-              <a:rPr lang="en-US" sz="2000" b="1" dirty="0">
-                <a:solidFill>
-                  <a:srgbClr val="9A7B1A"/>
-                </a:solidFill>
-                <a:latin typeface="Georgia" pitchFamily="34" charset="0"/>
-                <a:ea typeface="Georgia" pitchFamily="34" charset="-122"/>
-                <a:cs typeface="Georgia" pitchFamily="34" charset="-120"/>
-              </a:rPr>
-              <a:t>→</a:t>
-            </a:r>
-            <a:endParaRPr lang="en-US" sz="2000" dirty="0"/>
-          </a:p>
-        </p:txBody>
-      </p:sp>
-      <p:sp>
-        <p:nvSpPr>
-          <p:cNvPr id="23" name="Shape 21"/>
-          <p:cNvSpPr/>
-          <p:nvPr/>
-        </p:nvSpPr>
-        <p:spPr>
-          <a:xfrm>
-            <a:off x="7452360" y="1645920"/>
-            <a:ext cx="2194560" cy="2286000"/>
-          </a:xfrm>
-          <a:prstGeom prst="roundRect">
-            <a:avLst>
-              <a:gd name="adj" fmla="val 4167"/>
-            </a:avLst>
-          </a:prstGeom>
-          <a:solidFill>
-            <a:srgbClr val="FFF8EB"/>
-          </a:solidFill>
-          <a:ln w="19050">
-            <a:solidFill>
-              <a:srgbClr val="6B7F5A"/>
-            </a:solidFill>
-            <a:prstDash val="solid"/>
-          </a:ln>
-        </p:spPr>
-      </p:sp>
-      <p:sp>
-        <p:nvSpPr>
-          <p:cNvPr id="24" name="Text 22"/>
-          <p:cNvSpPr/>
-          <p:nvPr/>
-        </p:nvSpPr>
-        <p:spPr>
-          <a:xfrm>
-            <a:off x="7452360" y="1828800"/>
-            <a:ext cx="2194560" cy="320040"/>
-          </a:xfrm>
-          <a:prstGeom prst="rect">
-            <a:avLst/>
-          </a:prstGeom>
-          <a:noFill/>
-          <a:ln/>
-        </p:spPr>
-        <p:txBody>
-          <a:bodyPr wrap="square" lIns="0" tIns="0" rIns="0" bIns="0" rtlCol="0" anchor="ctr"/>
-          <a:lstStyle/>
-          <a:p>
-            <a:pPr algn="ctr" indent="0" marL="0">
-              <a:buNone/>
-            </a:pPr>
-            <a:r>
-              <a:rPr lang="en-US" sz="1200" b="1" dirty="0">
-                <a:solidFill>
-                  <a:srgbClr val="6B7F5A"/>
-                </a:solidFill>
-                <a:latin typeface="Georgia" pitchFamily="34" charset="0"/>
-                <a:ea typeface="Georgia" pitchFamily="34" charset="-122"/>
-                <a:cs typeface="Georgia" pitchFamily="34" charset="-120"/>
-              </a:rPr>
-              <a:t>15:00–17:00</a:t>
-            </a:r>
-            <a:endParaRPr lang="en-US" sz="1200" dirty="0"/>
-          </a:p>
-        </p:txBody>
-      </p:sp>
-      <p:sp>
-        <p:nvSpPr>
-          <p:cNvPr id="25" name="Text 23"/>
-          <p:cNvSpPr/>
-          <p:nvPr/>
-        </p:nvSpPr>
-        <p:spPr>
-          <a:xfrm>
-            <a:off x="7543800" y="2331720"/>
-            <a:ext cx="2011680" cy="640080"/>
-          </a:xfrm>
-          <a:prstGeom prst="rect">
-            <a:avLst/>
-          </a:prstGeom>
-          <a:noFill/>
-          <a:ln/>
-        </p:spPr>
-        <p:txBody>
-          <a:bodyPr wrap="square" lIns="0" tIns="0" rIns="0" bIns="0" rtlCol="0" anchor="ctr"/>
-          <a:lstStyle/>
-          <a:p>
-            <a:pPr algn="ctr" indent="0" marL="0">
-              <a:buNone/>
-            </a:pPr>
-            <a:r>
-              <a:rPr lang="en-US" sz="1800" b="1" dirty="0">
-                <a:solidFill>
-                  <a:srgbClr val="2A2218"/>
-                </a:solidFill>
-                <a:latin typeface="Microsoft JhengHei" pitchFamily="34" charset="0"/>
-                <a:ea typeface="Microsoft JhengHei" pitchFamily="34" charset="-122"/>
-                <a:cs typeface="Microsoft JhengHei" pitchFamily="34" charset="-120"/>
-              </a:rPr>
-              <a:t>飯店小睡</a:t>
-            </a:r>
-            <a:endParaRPr lang="en-US" sz="1800" dirty="0"/>
-          </a:p>
-        </p:txBody>
-      </p:sp>
-      <p:sp>
-        <p:nvSpPr>
-          <p:cNvPr id="26" name="Text 24"/>
-          <p:cNvSpPr/>
-          <p:nvPr/>
-        </p:nvSpPr>
-        <p:spPr>
-          <a:xfrm>
-            <a:off x="7543800" y="3108960"/>
-            <a:ext cx="2011680" cy="502920"/>
-          </a:xfrm>
-          <a:prstGeom prst="rect">
-            <a:avLst/>
-          </a:prstGeom>
-          <a:noFill/>
-          <a:ln/>
-        </p:spPr>
-        <p:txBody>
-          <a:bodyPr wrap="square" lIns="0" tIns="0" rIns="0" bIns="0" rtlCol="0" anchor="ctr"/>
-          <a:lstStyle/>
-          <a:p>
-            <a:pPr algn="ctr" indent="0" marL="0">
-              <a:buNone/>
-            </a:pPr>
-            <a:r>
-              <a:rPr lang="en-US" sz="1300" dirty="0">
-                <a:solidFill>
-                  <a:srgbClr val="5C4A38"/>
-                </a:solidFill>
-                <a:latin typeface="Microsoft JhengHei" pitchFamily="34" charset="0"/>
-                <a:ea typeface="Microsoft JhengHei" pitchFamily="34" charset="-122"/>
-                <a:cs typeface="Microsoft JhengHei" pitchFamily="34" charset="-120"/>
-              </a:rPr>
-              <a:t>常態午睡死守</a:t>
-            </a:r>
-            <a:endParaRPr lang="en-US" sz="1300" dirty="0"/>
-          </a:p>
-        </p:txBody>
-      </p:sp>
-      <p:sp>
-        <p:nvSpPr>
-          <p:cNvPr id="27" name="Text 25"/>
-          <p:cNvSpPr/>
-          <p:nvPr/>
-        </p:nvSpPr>
-        <p:spPr>
-          <a:xfrm>
-            <a:off x="9464040" y="2468880"/>
-            <a:ext cx="365760" cy="365760"/>
-          </a:xfrm>
-          <a:prstGeom prst="rect">
-            <a:avLst/>
-          </a:prstGeom>
-          <a:noFill/>
-          <a:ln/>
-        </p:spPr>
-        <p:txBody>
-          <a:bodyPr wrap="square" lIns="0" tIns="0" rIns="0" bIns="0" rtlCol="0" anchor="ctr"/>
-          <a:lstStyle/>
-          <a:p>
-            <a:pPr indent="0" marL="0">
-              <a:buNone/>
-            </a:pPr>
-            <a:r>
-              <a:rPr lang="en-US" sz="2000" b="1" dirty="0">
-                <a:solidFill>
-                  <a:srgbClr val="9A7B1A"/>
-                </a:solidFill>
-                <a:latin typeface="Georgia" pitchFamily="34" charset="0"/>
-                <a:ea typeface="Georgia" pitchFamily="34" charset="-122"/>
-                <a:cs typeface="Georgia" pitchFamily="34" charset="-120"/>
-              </a:rPr>
-              <a:t>→</a:t>
-            </a:r>
-            <a:endParaRPr lang="en-US" sz="2000" dirty="0"/>
-          </a:p>
-        </p:txBody>
-      </p:sp>
-      <p:sp>
-        <p:nvSpPr>
-          <p:cNvPr id="28" name="Shape 26"/>
-          <p:cNvSpPr/>
-          <p:nvPr/>
-        </p:nvSpPr>
-        <p:spPr>
-          <a:xfrm>
-            <a:off x="9784080" y="1645920"/>
-            <a:ext cx="2194560" cy="2286000"/>
-          </a:xfrm>
-          <a:prstGeom prst="roundRect">
-            <a:avLst>
-              <a:gd name="adj" fmla="val 4167"/>
-            </a:avLst>
-          </a:prstGeom>
-          <a:solidFill>
-            <a:srgbClr val="FFF8EB"/>
-          </a:solidFill>
-          <a:ln w="19050">
-            <a:solidFill>
-              <a:srgbClr val="C23B22"/>
-            </a:solidFill>
-            <a:prstDash val="solid"/>
-          </a:ln>
-        </p:spPr>
-      </p:sp>
-      <p:sp>
-        <p:nvSpPr>
-          <p:cNvPr id="29" name="Text 27"/>
-          <p:cNvSpPr/>
-          <p:nvPr/>
-        </p:nvSpPr>
-        <p:spPr>
-          <a:xfrm>
-            <a:off x="9784080" y="1828800"/>
-            <a:ext cx="2194560" cy="320040"/>
-          </a:xfrm>
-          <a:prstGeom prst="rect">
-            <a:avLst/>
-          </a:prstGeom>
-          <a:noFill/>
-          <a:ln/>
-        </p:spPr>
-        <p:txBody>
-          <a:bodyPr wrap="square" lIns="0" tIns="0" rIns="0" bIns="0" rtlCol="0" anchor="ctr"/>
-          <a:lstStyle/>
-          <a:p>
-            <a:pPr algn="ctr" indent="0" marL="0">
-              <a:buNone/>
-            </a:pPr>
-            <a:r>
-              <a:rPr lang="en-US" sz="1200" b="1" dirty="0">
-                <a:solidFill>
-                  <a:srgbClr val="C23B22"/>
-                </a:solidFill>
-                <a:latin typeface="Georgia" pitchFamily="34" charset="0"/>
-                <a:ea typeface="Georgia" pitchFamily="34" charset="-122"/>
-                <a:cs typeface="Georgia" pitchFamily="34" charset="-120"/>
-              </a:rPr>
-              <a:t>17:30+</a:t>
+              <a:t>15:20–16:00</a:t>
             </a:r>
             <a:endParaRPr lang="en-US" sz="1200" dirty="0"/>
           </a:p>
@@ -6160,7 +6160,7 @@
               <a:buNone/>
             </a:pPr>
             <a:r>
-              <a:rPr lang="en-US" sz="1800" b="1" dirty="0">
+              <a:rPr lang="en-US" sz="1700" b="1" dirty="0">
                 <a:solidFill>
                   <a:srgbClr val="2A2218"/>
                 </a:solidFill>
@@ -6168,9 +6168,9 @@
                 <a:ea typeface="Microsoft JhengHei" pitchFamily="34" charset="-122"/>
                 <a:cs typeface="Microsoft JhengHei" pitchFamily="34" charset="-120"/>
               </a:rPr>
-              <a:t>檀王→鴨川</a:t>
-            </a:r>
-            <a:endParaRPr lang="en-US" sz="1800" dirty="0"/>
+              <a:t>檀王法林寺</a:t>
+            </a:r>
+            <a:endParaRPr lang="en-US" sz="1700" dirty="0"/>
           </a:p>
         </p:txBody>
       </p:sp>
@@ -6199,7 +6199,7 @@
               <a:buNone/>
             </a:pPr>
             <a:r>
-              <a:rPr lang="en-US" sz="1300" dirty="0">
+              <a:rPr lang="en-US" sz="1200" dirty="0">
                 <a:solidFill>
                   <a:srgbClr val="5C4A38"/>
                 </a:solidFill>
@@ -6207,9 +6207,9 @@
                 <a:ea typeface="Microsoft JhengHei" pitchFamily="34" charset="-122"/>
                 <a:cs typeface="Microsoft JhengHei" pitchFamily="34" charset="-120"/>
               </a:rPr>
-              <a:t>黑招財貓 · 河畔</a:t>
-            </a:r>
-            <a:endParaRPr lang="en-US" sz="1300" dirty="0"/>
+              <a:t>黑招財貓御守</a:t>
+            </a:r>
+            <a:endParaRPr lang="en-US" sz="1200" dirty="0"/>
           </a:p>
         </p:txBody>
       </p:sp>
@@ -6312,7 +6312,7 @@
                 <a:ea typeface="Microsoft JhengHei" pitchFamily="34" charset="-122"/>
                 <a:cs typeface="Microsoft JhengHei" pitchFamily="34" charset="-120"/>
               </a:rPr>
-              <a:t>御金神社（快閃買金運御守）── 步行 6 分鐘 ── 二条城（大空間平整放電）。既滿足神社參拜，又完全不打亂寶寶中午回去小睡的黃金作息。與下榻 nol sanjo 同屬中京區，地理優勢極大。</a:t>
+              <a:t>四條烏丸核心區（大丸京都店寶可夢中心 + SHAKE SHACK）無縫接軌 12:30 預訂之敘敘苑燒肉午餐。午後搭計程車順路參拜吉祥院天滿宮與檀王法林寺，時間極度完美緊扣 17:00 社務所關門線，購入黑招財貓御守。</a:t>
             </a:r>
             <a:endParaRPr lang="en-US" sz="1400" dirty="0"/>
           </a:p>
@@ -6489,7 +6489,7 @@
                 <a:ea typeface="Georgia" pitchFamily="34" charset="-122"/>
                 <a:cs typeface="Georgia" pitchFamily="34" charset="-120"/>
               </a:rPr>
-              <a:t>CORE SPOT</a:t>
+              <a:t>CORE SPOTS</a:t>
             </a:r>
             <a:endParaRPr lang="en-US" sz="1300" dirty="0"/>
           </a:p>
@@ -6528,7 +6528,7 @@
                 <a:ea typeface="Microsoft JhengHei" pitchFamily="34" charset="-122"/>
                 <a:cs typeface="Microsoft JhengHei" pitchFamily="34" charset="-120"/>
               </a:rPr>
-              <a:t>御金神社 · 地理空間與物理動線</a:t>
+              <a:t>四條烏丸美學美食與雙神社攻略</a:t>
             </a:r>
             <a:endParaRPr lang="en-US" sz="2400" dirty="0"/>
           </a:p>
@@ -6594,7 +6594,7 @@
                 <a:ea typeface="Microsoft JhengHei" pitchFamily="34" charset="-122"/>
                 <a:cs typeface="Microsoft JhengHei" pitchFamily="34" charset="-120"/>
               </a:rPr>
-              <a:t>景點定位</a:t>
+              <a:t>四條烏丸核心基地</a:t>
             </a:r>
             <a:endParaRPr lang="en-US" sz="1600" dirty="0"/>
           </a:p>
@@ -6625,7 +6625,7 @@
               <a:buNone/>
             </a:pPr>
             <a:r>
-              <a:rPr lang="en-US" sz="1300" b="1" dirty="0">
+              <a:rPr lang="en-US" sz="1400" b="1" dirty="0">
                 <a:solidFill>
                   <a:srgbClr val="C23B22"/>
                 </a:solidFill>
@@ -6633,32 +6633,49 @@
                 <a:ea typeface="Microsoft JhengHei" pitchFamily="34" charset="-122"/>
                 <a:cs typeface="Microsoft JhengHei" pitchFamily="34" charset="-120"/>
               </a:rPr>
-              <a:t>地理位置</a:t>
+              <a:t>大丸京都店</a:t>
+            </a:r>
+            <a:endParaRPr lang="en-US" sz="1400" dirty="0"/>
+          </a:p>
+        </p:txBody>
+      </p:sp>
+      <p:sp>
+        <p:nvSpPr>
+          <p:cNvPr id="10" name="Text 8"/>
+          <p:cNvSpPr/>
+          <p:nvPr/>
+        </p:nvSpPr>
+        <p:spPr>
+          <a:xfrm>
+            <a:off x="685800" y="2221992"/>
+            <a:ext cx="5029200" cy="731520"/>
+          </a:xfrm>
+          <a:prstGeom prst="rect">
+            <a:avLst/>
+          </a:prstGeom>
+          <a:noFill/>
+          <a:ln/>
+        </p:spPr>
+        <p:txBody>
+          <a:bodyPr wrap="square" lIns="0" tIns="0" rIns="0" bIns="0" rtlCol="0" anchor="ctr"/>
+          <a:lstStyle/>
+          <a:p>
+            <a:pPr indent="0" marL="0">
+              <a:buNone/>
+            </a:pPr>
+            <a:r>
+              <a:rPr lang="en-US" sz="1300" dirty="0">
+                <a:solidFill>
+                  <a:srgbClr val="5C4A38"/>
+                </a:solidFill>
+                <a:latin typeface="Microsoft JhengHei" pitchFamily="34" charset="0"/>
+                <a:ea typeface="Microsoft JhengHei" pitchFamily="34" charset="-122"/>
+                <a:cs typeface="Microsoft JhengHei" pitchFamily="34" charset="-120"/>
+              </a:rPr>
+              <a:t>10:00開店避暑 · 2F 寶可夢中心</a:t>
             </a:r>
             <a:endParaRPr lang="en-US" sz="1300" dirty="0"/>
           </a:p>
-        </p:txBody>
-      </p:sp>
-      <p:sp>
-        <p:nvSpPr>
-          <p:cNvPr id="10" name="Text 8"/>
-          <p:cNvSpPr/>
-          <p:nvPr/>
-        </p:nvSpPr>
-        <p:spPr>
-          <a:xfrm>
-            <a:off x="685800" y="2221992"/>
-            <a:ext cx="5029200" cy="548640"/>
-          </a:xfrm>
-          <a:prstGeom prst="rect">
-            <a:avLst/>
-          </a:prstGeom>
-          <a:noFill/>
-          <a:ln/>
-        </p:spPr>
-        <p:txBody>
-          <a:bodyPr wrap="square" lIns="0" tIns="0" rIns="0" bIns="0" rtlCol="0" anchor="ctr"/>
-          <a:lstStyle/>
           <a:p>
             <a:pPr indent="0" marL="0">
               <a:buNone/>
@@ -6672,15 +6689,76 @@
                 <a:ea typeface="Microsoft JhengHei" pitchFamily="34" charset="-122"/>
                 <a:cs typeface="Microsoft JhengHei" pitchFamily="34" charset="-120"/>
               </a:rPr>
-              <a:t>京都市中京區押西洞院町</a:t>
+              <a:t>頂級育嬰室 · 地下美食街</a:t>
             </a:r>
             <a:endParaRPr lang="en-US" sz="1300" dirty="0"/>
           </a:p>
+        </p:txBody>
+      </p:sp>
+      <p:sp>
+        <p:nvSpPr>
+          <p:cNvPr id="11" name="Text 9"/>
+          <p:cNvSpPr/>
+          <p:nvPr/>
+        </p:nvSpPr>
+        <p:spPr>
+          <a:xfrm>
+            <a:off x="685800" y="3246120"/>
+            <a:ext cx="5029200" cy="256032"/>
+          </a:xfrm>
+          <a:prstGeom prst="rect">
+            <a:avLst/>
+          </a:prstGeom>
+          <a:noFill/>
+          <a:ln/>
+        </p:spPr>
+        <p:txBody>
+          <a:bodyPr wrap="square" lIns="0" tIns="0" rIns="0" bIns="0" rtlCol="0" anchor="ctr"/>
+          <a:lstStyle/>
           <a:p>
             <a:pPr indent="0" marL="0">
               <a:buNone/>
             </a:pPr>
             <a:r>
+              <a:rPr lang="en-US" sz="1400" b="1" dirty="0">
+                <a:solidFill>
+                  <a:srgbClr val="C23B22"/>
+                </a:solidFill>
+                <a:latin typeface="Microsoft JhengHei" pitchFamily="34" charset="0"/>
+                <a:ea typeface="Microsoft JhengHei" pitchFamily="34" charset="-122"/>
+                <a:cs typeface="Microsoft JhengHei" pitchFamily="34" charset="-120"/>
+              </a:rPr>
+              <a:t>SHAKE SHACK</a:t>
+            </a:r>
+            <a:endParaRPr lang="en-US" sz="1400" dirty="0"/>
+          </a:p>
+        </p:txBody>
+      </p:sp>
+      <p:sp>
+        <p:nvSpPr>
+          <p:cNvPr id="12" name="Text 10"/>
+          <p:cNvSpPr/>
+          <p:nvPr/>
+        </p:nvSpPr>
+        <p:spPr>
+          <a:xfrm>
+            <a:off x="685800" y="3502152"/>
+            <a:ext cx="5029200" cy="731520"/>
+          </a:xfrm>
+          <a:prstGeom prst="rect">
+            <a:avLst/>
+          </a:prstGeom>
+          <a:noFill/>
+          <a:ln/>
+        </p:spPr>
+        <p:txBody>
+          <a:bodyPr wrap="square" lIns="0" tIns="0" rIns="0" bIns="0" rtlCol="0" anchor="ctr"/>
+          <a:lstStyle/>
+          <a:p>
+            <a:pPr indent="0" marL="0">
+              <a:buNone/>
+            </a:pPr>
+            <a:r>
               <a:rPr lang="en-US" sz="1300" dirty="0">
                 <a:solidFill>
                   <a:srgbClr val="5C4A38"/>
@@ -6689,21 +6767,38 @@
                 <a:ea typeface="Microsoft JhengHei" pitchFamily="34" charset="-122"/>
                 <a:cs typeface="Microsoft JhengHei" pitchFamily="34" charset="-120"/>
               </a:rPr>
-              <a:t>靠近二条城、地鐵烏丸御池站</a:t>
+              <a:t>京都四條烏丸店 · 大丸正後方</a:t>
             </a:r>
             <a:endParaRPr lang="en-US" sz="1300" dirty="0"/>
           </a:p>
-        </p:txBody>
-      </p:sp>
-      <p:sp>
-        <p:nvSpPr>
-          <p:cNvPr id="11" name="Text 9"/>
-          <p:cNvSpPr/>
-          <p:nvPr/>
-        </p:nvSpPr>
-        <p:spPr>
-          <a:xfrm>
-            <a:off x="685800" y="2880360"/>
+          <a:p>
+            <a:pPr indent="0" marL="0">
+              <a:buNone/>
+            </a:pPr>
+            <a:r>
+              <a:rPr lang="en-US" sz="1300" dirty="0">
+                <a:solidFill>
+                  <a:srgbClr val="5C4A38"/>
+                </a:solidFill>
+                <a:latin typeface="Microsoft JhengHei" pitchFamily="34" charset="0"/>
+                <a:ea typeface="Microsoft JhengHei" pitchFamily="34" charset="-122"/>
+                <a:cs typeface="Microsoft JhengHei" pitchFamily="34" charset="-120"/>
+              </a:rPr>
+              <a:t>關西限定宇治抹茶奶昔</a:t>
+            </a:r>
+            <a:endParaRPr lang="en-US" sz="1300" dirty="0"/>
+          </a:p>
+        </p:txBody>
+      </p:sp>
+      <p:sp>
+        <p:nvSpPr>
+          <p:cNvPr id="13" name="Text 11"/>
+          <p:cNvSpPr/>
+          <p:nvPr/>
+        </p:nvSpPr>
+        <p:spPr>
+          <a:xfrm>
+            <a:off x="685800" y="4526280"/>
             <a:ext cx="5029200" cy="256032"/>
           </a:xfrm>
           <a:prstGeom prst="rect">
@@ -6720,7 +6815,7 @@
               <a:buNone/>
             </a:pPr>
             <a:r>
-              <a:rPr lang="en-US" sz="1300" b="1" dirty="0">
+              <a:rPr lang="en-US" sz="1400" b="1" dirty="0">
                 <a:solidFill>
                   <a:srgbClr val="C23B22"/>
                 </a:solidFill>
@@ -6728,32 +6823,49 @@
                 <a:ea typeface="Microsoft JhengHei" pitchFamily="34" charset="-122"/>
                 <a:cs typeface="Microsoft JhengHei" pitchFamily="34" charset="-120"/>
               </a:rPr>
-              <a:t>文化本質</a:t>
+              <a:t>敘敘苑 游玄亭</a:t>
+            </a:r>
+            <a:endParaRPr lang="en-US" sz="1400" dirty="0"/>
+          </a:p>
+        </p:txBody>
+      </p:sp>
+      <p:sp>
+        <p:nvSpPr>
+          <p:cNvPr id="14" name="Text 12"/>
+          <p:cNvSpPr/>
+          <p:nvPr/>
+        </p:nvSpPr>
+        <p:spPr>
+          <a:xfrm>
+            <a:off x="685800" y="4782312"/>
+            <a:ext cx="5029200" cy="731520"/>
+          </a:xfrm>
+          <a:prstGeom prst="rect">
+            <a:avLst/>
+          </a:prstGeom>
+          <a:noFill/>
+          <a:ln/>
+        </p:spPr>
+        <p:txBody>
+          <a:bodyPr wrap="square" lIns="0" tIns="0" rIns="0" bIns="0" rtlCol="0" anchor="ctr"/>
+          <a:lstStyle/>
+          <a:p>
+            <a:pPr indent="0" marL="0">
+              <a:buNone/>
+            </a:pPr>
+            <a:r>
+              <a:rPr lang="en-US" sz="1300" dirty="0">
+                <a:solidFill>
+                  <a:srgbClr val="5C4A38"/>
+                </a:solidFill>
+                <a:latin typeface="Microsoft JhengHei" pitchFamily="34" charset="0"/>
+                <a:ea typeface="Microsoft JhengHei" pitchFamily="34" charset="-122"/>
+                <a:cs typeface="Microsoft JhengHei" pitchFamily="34" charset="-120"/>
+              </a:rPr>
+              <a:t>已預訂 12:30 用餐 · FT 烏丸大樓 8F</a:t>
             </a:r>
             <a:endParaRPr lang="en-US" sz="1300" dirty="0"/>
           </a:p>
-        </p:txBody>
-      </p:sp>
-      <p:sp>
-        <p:nvSpPr>
-          <p:cNvPr id="12" name="Text 10"/>
-          <p:cNvSpPr/>
-          <p:nvPr/>
-        </p:nvSpPr>
-        <p:spPr>
-          <a:xfrm>
-            <a:off x="685800" y="3136392"/>
-            <a:ext cx="5029200" cy="548640"/>
-          </a:xfrm>
-          <a:prstGeom prst="rect">
-            <a:avLst/>
-          </a:prstGeom>
-          <a:noFill/>
-          <a:ln/>
-        </p:spPr>
-        <p:txBody>
-          <a:bodyPr wrap="square" lIns="0" tIns="0" rIns="0" bIns="0" rtlCol="0" anchor="ctr"/>
-          <a:lstStyle/>
           <a:p>
             <a:pPr indent="0" marL="0">
               <a:buNone/>
@@ -6767,222 +6879,15 @@
                 <a:ea typeface="Microsoft JhengHei" pitchFamily="34" charset="-122"/>
                 <a:cs typeface="Microsoft JhengHei" pitchFamily="34" charset="-120"/>
               </a:rPr>
-              <a:t>主祀金山毘古神（金屬、礦物與財運）</a:t>
+              <a:t>奢華包廂 · 頂級和牛燒肉</a:t>
             </a:r>
             <a:endParaRPr lang="en-US" sz="1300" dirty="0"/>
           </a:p>
-          <a:p>
-            <a:pPr indent="0" marL="0">
-              <a:buNone/>
-            </a:pPr>
-            <a:r>
-              <a:rPr lang="en-US" sz="1300" dirty="0">
-                <a:solidFill>
-                  <a:srgbClr val="5C4A38"/>
-                </a:solidFill>
-                <a:latin typeface="Microsoft JhengHei" pitchFamily="34" charset="0"/>
-                <a:ea typeface="Microsoft JhengHei" pitchFamily="34" charset="-122"/>
-                <a:cs typeface="Microsoft JhengHei" pitchFamily="34" charset="-120"/>
-              </a:rPr>
-              <a:t>金黃色鳥居 · 洗錢／金運御守</a:t>
-            </a:r>
-            <a:endParaRPr lang="en-US" sz="1300" dirty="0"/>
-          </a:p>
-        </p:txBody>
-      </p:sp>
-      <p:sp>
-        <p:nvSpPr>
-          <p:cNvPr id="13" name="Text 11"/>
-          <p:cNvSpPr/>
-          <p:nvPr/>
-        </p:nvSpPr>
-        <p:spPr>
-          <a:xfrm>
-            <a:off x="685800" y="3794760"/>
-            <a:ext cx="5029200" cy="256032"/>
-          </a:xfrm>
-          <a:prstGeom prst="rect">
-            <a:avLst/>
-          </a:prstGeom>
-          <a:noFill/>
-          <a:ln/>
-        </p:spPr>
-        <p:txBody>
-          <a:bodyPr wrap="square" lIns="0" tIns="0" rIns="0" bIns="0" rtlCol="0" anchor="ctr"/>
-          <a:lstStyle/>
-          <a:p>
-            <a:pPr indent="0" marL="0">
-              <a:buNone/>
-            </a:pPr>
-            <a:r>
-              <a:rPr lang="en-US" sz="1300" b="1" dirty="0">
-                <a:solidFill>
-                  <a:srgbClr val="C23B22"/>
-                </a:solidFill>
-                <a:latin typeface="Microsoft JhengHei" pitchFamily="34" charset="0"/>
-                <a:ea typeface="Microsoft JhengHei" pitchFamily="34" charset="-122"/>
-                <a:cs typeface="Microsoft JhengHei" pitchFamily="34" charset="-120"/>
-              </a:rPr>
-              <a:t>空間特性</a:t>
-            </a:r>
-            <a:endParaRPr lang="en-US" sz="1300" dirty="0"/>
-          </a:p>
-        </p:txBody>
-      </p:sp>
-      <p:sp>
-        <p:nvSpPr>
-          <p:cNvPr id="14" name="Text 12"/>
-          <p:cNvSpPr/>
-          <p:nvPr/>
-        </p:nvSpPr>
-        <p:spPr>
-          <a:xfrm>
-            <a:off x="685800" y="4050792"/>
-            <a:ext cx="5029200" cy="548640"/>
-          </a:xfrm>
-          <a:prstGeom prst="rect">
-            <a:avLst/>
-          </a:prstGeom>
-          <a:noFill/>
-          <a:ln/>
-        </p:spPr>
-        <p:txBody>
-          <a:bodyPr wrap="square" lIns="0" tIns="0" rIns="0" bIns="0" rtlCol="0" anchor="ctr"/>
-          <a:lstStyle/>
-          <a:p>
-            <a:pPr indent="0" marL="0">
-              <a:buNone/>
-            </a:pPr>
-            <a:r>
-              <a:rPr lang="en-US" sz="1300" dirty="0">
-                <a:solidFill>
-                  <a:srgbClr val="5C4A38"/>
-                </a:solidFill>
-                <a:latin typeface="Microsoft JhengHei" pitchFamily="34" charset="0"/>
-                <a:ea typeface="Microsoft JhengHei" pitchFamily="34" charset="-122"/>
-                <a:cs typeface="Microsoft JhengHei" pitchFamily="34" charset="-120"/>
-              </a:rPr>
-              <a:t>著名熱門小型神社</a:t>
-            </a:r>
-            <a:endParaRPr lang="en-US" sz="1300" dirty="0"/>
-          </a:p>
-          <a:p>
-            <a:pPr indent="0" marL="0">
-              <a:buNone/>
-            </a:pPr>
-            <a:r>
-              <a:rPr lang="en-US" sz="1300" dirty="0">
-                <a:solidFill>
-                  <a:srgbClr val="5C4A38"/>
-                </a:solidFill>
-                <a:latin typeface="Microsoft JhengHei" pitchFamily="34" charset="0"/>
-                <a:ea typeface="Microsoft JhengHei" pitchFamily="34" charset="-122"/>
-                <a:cs typeface="Microsoft JhengHei" pitchFamily="34" charset="-120"/>
-              </a:rPr>
-              <a:t>境內極狹小，經常排隊擁擠</a:t>
-            </a:r>
-            <a:endParaRPr lang="en-US" sz="1300" dirty="0"/>
-          </a:p>
-        </p:txBody>
-      </p:sp>
-      <p:sp>
-        <p:nvSpPr>
-          <p:cNvPr id="15" name="Text 13"/>
-          <p:cNvSpPr/>
-          <p:nvPr/>
-        </p:nvSpPr>
-        <p:spPr>
-          <a:xfrm>
-            <a:off x="685800" y="4709160"/>
-            <a:ext cx="5029200" cy="256032"/>
-          </a:xfrm>
-          <a:prstGeom prst="rect">
-            <a:avLst/>
-          </a:prstGeom>
-          <a:noFill/>
-          <a:ln/>
-        </p:spPr>
-        <p:txBody>
-          <a:bodyPr wrap="square" lIns="0" tIns="0" rIns="0" bIns="0" rtlCol="0" anchor="ctr"/>
-          <a:lstStyle/>
-          <a:p>
-            <a:pPr indent="0" marL="0">
-              <a:buNone/>
-            </a:pPr>
-            <a:r>
-              <a:rPr lang="en-US" sz="1300" b="1" dirty="0">
-                <a:solidFill>
-                  <a:srgbClr val="C23B22"/>
-                </a:solidFill>
-                <a:latin typeface="Microsoft JhengHei" pitchFamily="34" charset="0"/>
-                <a:ea typeface="Microsoft JhengHei" pitchFamily="34" charset="-122"/>
-                <a:cs typeface="Microsoft JhengHei" pitchFamily="34" charset="-120"/>
-              </a:rPr>
-              <a:t>與住宿</a:t>
-            </a:r>
-            <a:endParaRPr lang="en-US" sz="1300" dirty="0"/>
-          </a:p>
-        </p:txBody>
-      </p:sp>
-      <p:sp>
-        <p:nvSpPr>
-          <p:cNvPr id="16" name="Text 14"/>
-          <p:cNvSpPr/>
-          <p:nvPr/>
-        </p:nvSpPr>
-        <p:spPr>
-          <a:xfrm>
-            <a:off x="685800" y="4965192"/>
-            <a:ext cx="5029200" cy="548640"/>
-          </a:xfrm>
-          <a:prstGeom prst="rect">
-            <a:avLst/>
-          </a:prstGeom>
-          <a:noFill/>
-          <a:ln/>
-        </p:spPr>
-        <p:txBody>
-          <a:bodyPr wrap="square" lIns="0" tIns="0" rIns="0" bIns="0" rtlCol="0" anchor="ctr"/>
-          <a:lstStyle/>
-          <a:p>
-            <a:pPr indent="0" marL="0">
-              <a:buNone/>
-            </a:pPr>
-            <a:r>
-              <a:rPr lang="en-US" sz="1300" dirty="0">
-                <a:solidFill>
-                  <a:srgbClr val="5C4A38"/>
-                </a:solidFill>
-                <a:latin typeface="Microsoft JhengHei" pitchFamily="34" charset="0"/>
-                <a:ea typeface="Microsoft JhengHei" pitchFamily="34" charset="-122"/>
-                <a:cs typeface="Microsoft JhengHei" pitchFamily="34" charset="-120"/>
-              </a:rPr>
-              <a:t>與 nol kyoto sanjo 同中京區</a:t>
-            </a:r>
-            <a:endParaRPr lang="en-US" sz="1300" dirty="0"/>
-          </a:p>
-          <a:p>
-            <a:pPr indent="0" marL="0">
-              <a:buNone/>
-            </a:pPr>
-            <a:r>
-              <a:rPr lang="en-US" sz="1300" dirty="0">
-                <a:solidFill>
-                  <a:srgbClr val="5C4A38"/>
-                </a:solidFill>
-                <a:latin typeface="Microsoft JhengHei" pitchFamily="34" charset="0"/>
-                <a:ea typeface="Microsoft JhengHei" pitchFamily="34" charset="-122"/>
-                <a:cs typeface="Microsoft JhengHei" pitchFamily="34" charset="-120"/>
-              </a:rPr>
-              <a:t>距離非常近，順路不繞</a:t>
-            </a:r>
-            <a:endParaRPr lang="en-US" sz="1300" dirty="0"/>
-          </a:p>
-        </p:txBody>
-      </p:sp>
-      <p:sp>
-        <p:nvSpPr>
-          <p:cNvPr id="17" name="Shape 15"/>
+        </p:txBody>
+      </p:sp>
+      <p:sp>
+        <p:nvSpPr>
+          <p:cNvPr id="15" name="Shape 13"/>
           <p:cNvSpPr/>
           <p:nvPr/>
         </p:nvSpPr>
@@ -7009,7 +6914,7 @@
       </p:sp>
       <p:sp>
         <p:nvSpPr>
-          <p:cNvPr id="18" name="Text 16"/>
+          <p:cNvPr id="16" name="Text 14"/>
           <p:cNvSpPr/>
           <p:nvPr/>
         </p:nvSpPr>
@@ -7040,7 +6945,7 @@
                 <a:ea typeface="Microsoft JhengHei" pitchFamily="34" charset="-122"/>
                 <a:cs typeface="Microsoft JhengHei" pitchFamily="34" charset="-120"/>
               </a:rPr>
-              <a:t>最佳切入策略</a:t>
+              <a:t>吉祥院天滿宮</a:t>
             </a:r>
             <a:endParaRPr lang="en-US" sz="1600" dirty="0"/>
           </a:p>
@@ -7048,7 +6953,7 @@
       </p:sp>
       <p:sp>
         <p:nvSpPr>
-          <p:cNvPr id="19" name="Text 17"/>
+          <p:cNvPr id="17" name="Text 15"/>
           <p:cNvSpPr/>
           <p:nvPr/>
         </p:nvSpPr>
@@ -7079,7 +6984,7 @@
                 <a:ea typeface="Microsoft JhengHei" pitchFamily="34" charset="-122"/>
                 <a:cs typeface="Microsoft JhengHei" pitchFamily="34" charset="-120"/>
               </a:rPr>
-              <a:t>時段：D2 清晨 08:00–08:30（人潮相對稀少）</a:t>
+              <a:t>定位：菅原道真（學問之神）誕生地</a:t>
             </a:r>
             <a:endParaRPr lang="en-US" sz="1300" dirty="0"/>
           </a:p>
@@ -7096,7 +7001,7 @@
                 <a:ea typeface="Microsoft JhengHei" pitchFamily="34" charset="-122"/>
                 <a:cs typeface="Microsoft JhengHei" pitchFamily="34" charset="-120"/>
               </a:rPr>
-              <a:t>時長：15–20 分鐘快閃參拜／買御守</a:t>
+              <a:t>交通：敘敘苑門口計程車 15–20 分直達</a:t>
             </a:r>
             <a:endParaRPr lang="en-US" sz="1300" dirty="0"/>
           </a:p>
@@ -7113,32 +7018,15 @@
                 <a:ea typeface="Microsoft JhengHei" pitchFamily="34" charset="-122"/>
                 <a:cs typeface="Microsoft JhengHei" pitchFamily="34" charset="-120"/>
               </a:rPr>
-              <a:t>順序：可先御金再二条城（推薦）</a:t>
+              <a:t>時間：14:15–15:00 參拜</a:t>
             </a:r>
             <a:endParaRPr lang="en-US" sz="1300" dirty="0"/>
           </a:p>
-          <a:p>
-            <a:pPr indent="0" marL="0">
-              <a:buNone/>
-            </a:pPr>
-            <a:r>
-              <a:rPr lang="en-US" sz="1300" dirty="0">
-                <a:solidFill>
-                  <a:srgbClr val="2A2218"/>
-                </a:solidFill>
-                <a:latin typeface="Microsoft JhengHei" pitchFamily="34" charset="0"/>
-                <a:ea typeface="Microsoft JhengHei" pitchFamily="34" charset="-122"/>
-                <a:cs typeface="Microsoft JhengHei" pitchFamily="34" charset="-120"/>
-              </a:rPr>
-              <a:t>距離：至二条城約 500 公尺（步行 6–8 分）</a:t>
-            </a:r>
-            <a:endParaRPr lang="en-US" sz="1300" dirty="0"/>
-          </a:p>
-        </p:txBody>
-      </p:sp>
-      <p:sp>
-        <p:nvSpPr>
-          <p:cNvPr id="20" name="Shape 18"/>
+        </p:txBody>
+      </p:sp>
+      <p:sp>
+        <p:nvSpPr>
+          <p:cNvPr id="18" name="Shape 16"/>
           <p:cNvSpPr/>
           <p:nvPr/>
         </p:nvSpPr>
@@ -7165,7 +7053,7 @@
       </p:sp>
       <p:sp>
         <p:nvSpPr>
-          <p:cNvPr id="21" name="Text 19"/>
+          <p:cNvPr id="19" name="Text 17"/>
           <p:cNvSpPr/>
           <p:nvPr/>
         </p:nvSpPr>
@@ -7196,7 +7084,7 @@
                 <a:ea typeface="Microsoft JhengHei" pitchFamily="34" charset="-122"/>
                 <a:cs typeface="Microsoft JhengHei" pitchFamily="34" charset="-120"/>
               </a:rPr>
-              <a:t>推車應變（人多時）</a:t>
+              <a:t>檀王法林寺（黑招財貓）</a:t>
             </a:r>
             <a:endParaRPr lang="en-US" sz="1600" dirty="0"/>
           </a:p>
@@ -7204,7 +7092,7 @@
       </p:sp>
       <p:sp>
         <p:nvSpPr>
-          <p:cNvPr id="22" name="Text 20"/>
+          <p:cNvPr id="20" name="Text 18"/>
           <p:cNvSpPr/>
           <p:nvPr/>
         </p:nvSpPr>
@@ -7235,7 +7123,7 @@
                 <a:ea typeface="Microsoft JhengHei" pitchFamily="34" charset="-122"/>
                 <a:cs typeface="Microsoft JhengHei" pitchFamily="34" charset="-120"/>
               </a:rPr>
-              <a:t>推車停在入口外圍，勿硬擠入狹窄境內</a:t>
+              <a:t>文化：日本最古老招財貓主夜神傳承</a:t>
             </a:r>
             <a:endParaRPr lang="en-US" sz="1300" dirty="0"/>
           </a:p>
@@ -7252,7 +7140,7 @@
                 <a:ea typeface="Microsoft JhengHei" pitchFamily="34" charset="-122"/>
                 <a:cs typeface="Microsoft JhengHei" pitchFamily="34" charset="-120"/>
               </a:rPr>
-              <a:t>大人輪流抱著寶寶（或用揹帶）進去</a:t>
+              <a:t>限制：社務所 17:00 關門</a:t>
             </a:r>
             <a:endParaRPr lang="en-US" sz="1300" dirty="0"/>
           </a:p>
@@ -7269,32 +7157,15 @@
                 <a:ea typeface="Microsoft JhengHei" pitchFamily="34" charset="-122"/>
                 <a:cs typeface="Microsoft JhengHei" pitchFamily="34" charset="-120"/>
               </a:rPr>
-              <a:t>快速參拜／購買金運御守後會合</a:t>
+              <a:t>策略：15:20–16:00 抵達順利購入黑招財貓御守</a:t>
             </a:r>
             <a:endParaRPr lang="en-US" sz="1300" dirty="0"/>
           </a:p>
-          <a:p>
-            <a:pPr indent="0" marL="0">
-              <a:buNone/>
-            </a:pPr>
-            <a:r>
-              <a:rPr lang="en-US" sz="1300" dirty="0">
-                <a:solidFill>
-                  <a:srgbClr val="2A2218"/>
-                </a:solidFill>
-                <a:latin typeface="Microsoft JhengHei" pitchFamily="34" charset="0"/>
-                <a:ea typeface="Microsoft JhengHei" pitchFamily="34" charset="-122"/>
-                <a:cs typeface="Microsoft JhengHei" pitchFamily="34" charset="-120"/>
-              </a:rPr>
-              <a:t>保住情緒與安全，勝過硬排長隊</a:t>
-            </a:r>
-            <a:endParaRPr lang="en-US" sz="1300" dirty="0"/>
-          </a:p>
-        </p:txBody>
-      </p:sp>
-      <p:sp>
-        <p:nvSpPr>
-          <p:cNvPr id="23" name="Text 21"/>
+        </p:txBody>
+      </p:sp>
+      <p:sp>
+        <p:nvSpPr>
+          <p:cNvPr id="21" name="Text 19"/>
           <p:cNvSpPr/>
           <p:nvPr/>
         </p:nvSpPr>
@@ -7541,7 +7412,7 @@
                 <a:ea typeface="Microsoft JhengHei" pitchFamily="34" charset="-122"/>
                 <a:cs typeface="Microsoft JhengHei" pitchFamily="34" charset="-120"/>
               </a:rPr>
-              <a:t>8/5（週三）  ·  專車快閃天滿宮與星野大草皮</a:t>
+              <a:t>8/5（週三）  ·  專車無縫直達 OMO7 Osaka 與星野大草皮</a:t>
             </a:r>
             <a:endParaRPr lang="en-US" sz="1400" dirty="0"/>
           </a:p>
@@ -7685,7 +7556,7 @@
                 <a:ea typeface="Microsoft JhengHei" pitchFamily="34" charset="-122"/>
                 <a:cs typeface="Microsoft JhengHei" pitchFamily="34" charset="-120"/>
               </a:rPr>
-              <a:t>行李直接放入專車後車廂，零搬運壓力。</a:t>
+              <a:t>nol kyoto sanjo 辦理退房，行李直接放入專車後車廂。</a:t>
             </a:r>
             <a:endParaRPr lang="en-US" sz="1300" dirty="0"/>
           </a:p>
@@ -7751,7 +7622,7 @@
                 <a:ea typeface="Georgia" pitchFamily="34" charset="-122"/>
                 <a:cs typeface="Georgia" pitchFamily="34" charset="-120"/>
               </a:rPr>
-              <a:t>10:15–12:15</a:t>
+              <a:t>10:15–11:30</a:t>
             </a:r>
             <a:endParaRPr lang="en-US" sz="1600" dirty="0"/>
           </a:p>
@@ -7790,7 +7661,7 @@
                 <a:ea typeface="Microsoft JhengHei" pitchFamily="34" charset="-122"/>
                 <a:cs typeface="Microsoft JhengHei" pitchFamily="34" charset="-120"/>
               </a:rPr>
-              <a:t>吉祥院天滿宮</a:t>
+              <a:t>專車直達 OMO7 Osaka</a:t>
             </a:r>
             <a:endParaRPr lang="en-US" sz="1800" dirty="0"/>
           </a:p>
@@ -7829,7 +7700,7 @@
                 <a:ea typeface="Microsoft JhengHei" pitchFamily="34" charset="-122"/>
                 <a:cs typeface="Microsoft JhengHei" pitchFamily="34" charset="-120"/>
               </a:rPr>
-              <a:t>外派接駁車 D2 點對點停靠。菅原道真誕生地，快閃 30–40 分鐘後直開大阪。</a:t>
+              <a:t>外派接駁車 D2 飯店對飯店點對點直達，零搬運壓力。</a:t>
             </a:r>
             <a:endParaRPr lang="en-US" sz="1300" dirty="0"/>
           </a:p>
@@ -7934,7 +7805,7 @@
                 <a:ea typeface="Microsoft JhengHei" pitchFamily="34" charset="-122"/>
                 <a:cs typeface="Microsoft JhengHei" pitchFamily="34" charset="-120"/>
               </a:rPr>
-              <a:t>OMO Base 小睡</a:t>
+              <a:t>OMO Base 大廳休整</a:t>
             </a:r>
             <a:endParaRPr lang="en-US" sz="1800" dirty="0"/>
           </a:p>
@@ -7973,7 +7844,7 @@
                 <a:ea typeface="Microsoft JhengHei" pitchFamily="34" charset="-122"/>
                 <a:cs typeface="Microsoft JhengHei" pitchFamily="34" charset="-120"/>
               </a:rPr>
-              <a:t>冷氣強勁、沙發舒適，大廳調解幼兒小睡。</a:t>
+              <a:t>強勁冷氣、沙發舒適，輕鬆體驗星野大廳美學空間。</a:t>
             </a:r>
             <a:endParaRPr lang="en-US" sz="1300" dirty="0"/>
           </a:p>
@@ -8078,7 +7949,7 @@
                 <a:ea typeface="Microsoft JhengHei" pitchFamily="34" charset="-122"/>
                 <a:cs typeface="Microsoft JhengHei" pitchFamily="34" charset="-120"/>
               </a:rPr>
-              <a:t>Miya-green + 燈光節</a:t>
+              <a:t>Miya-green 大草皮</a:t>
             </a:r>
             <a:endParaRPr lang="en-US" sz="1800" dirty="0"/>
           </a:p>
@@ -8333,7 +8204,7 @@
                 <a:ea typeface="Microsoft JhengHei" pitchFamily="34" charset="-122"/>
                 <a:cs typeface="Microsoft JhengHei" pitchFamily="34" charset="-120"/>
               </a:rPr>
-              <a:t>深海鯨鯊與高空夜景</a:t>
+              <a:t>神戶放電 · 阿倍野高空夜景與近鐵阿卡將採購</a:t>
             </a:r>
             <a:endParaRPr lang="en-US" sz="2600" dirty="0"/>
           </a:p>
@@ -8372,7 +8243,7 @@
                 <a:ea typeface="Microsoft JhengHei" pitchFamily="34" charset="-122"/>
                 <a:cs typeface="Microsoft JhengHei" pitchFamily="34" charset="-120"/>
               </a:rPr>
-              <a:t>8/6（週四）  ·  大阪  ·  「全室內看鯨鯊，晚上再上 Harukas」</a:t>
+              <a:t>8/6（週四）  ·  神戶 → 大阪天王寺  ·  「麵包超人全室內放電，晚上 Harukas 夜景」</a:t>
             </a:r>
             <a:endParaRPr lang="en-US" sz="1400" dirty="0"/>
           </a:p>
@@ -8499,7 +8370,7 @@
                 <a:ea typeface="Microsoft JhengHei" pitchFamily="34" charset="-122"/>
                 <a:cs typeface="Microsoft JhengHei" pitchFamily="34" charset="-120"/>
               </a:rPr>
-              <a:t>天保山海遊館</a:t>
+              <a:t>神戶 · 麵包超人兒童博物館</a:t>
             </a:r>
             <a:endParaRPr lang="en-US" sz="1800" dirty="0"/>
           </a:p>
@@ -8538,7 +8409,7 @@
                 <a:ea typeface="Microsoft JhengHei" pitchFamily="34" charset="-122"/>
                 <a:cs typeface="Microsoft JhengHei" pitchFamily="34" charset="-120"/>
               </a:rPr>
-              <a:t>全室內恆溫避暑，全無障礙推車動線看鯨鯊。中午於天保山購物中心美食街親子區用餐。</a:t>
+              <a:t>開館直入，全室內冷氣避暑，幼兒高放電效率公園。</a:t>
             </a:r>
             <a:endParaRPr lang="en-US" sz="1300" dirty="0"/>
           </a:p>
@@ -8577,7 +8448,7 @@
                 <a:ea typeface="Microsoft JhengHei" pitchFamily="34" charset="-122"/>
                 <a:cs typeface="Microsoft JhengHei" pitchFamily="34" charset="-120"/>
               </a:rPr>
-              <a:t>室內恆溫 · 推車友善</a:t>
+              <a:t>全室內避暑 · 高放電</a:t>
             </a:r>
             <a:endParaRPr lang="en-US" sz="1200" dirty="0"/>
           </a:p>
@@ -8704,7 +8575,7 @@
                 <a:ea typeface="Microsoft JhengHei" pitchFamily="34" charset="-122"/>
                 <a:cs typeface="Microsoft JhengHei" pitchFamily="34" charset="-120"/>
               </a:rPr>
-              <a:t>返回 OMO7 · 死守午睡</a:t>
+              <a:t>返大阪車程 / 飯店休整</a:t>
             </a:r>
             <a:endParaRPr lang="en-US" sz="1800" dirty="0"/>
           </a:p>
@@ -8743,7 +8614,7 @@
                 <a:ea typeface="Microsoft JhengHei" pitchFamily="34" charset="-122"/>
                 <a:cs typeface="Microsoft JhengHei" pitchFamily="34" charset="-120"/>
               </a:rPr>
-              <a:t>回房執行幼兒常態午睡，不排戶外行程搶時間。</a:t>
+              <a:t>返大阪輕鬆移動與返回 OMO7 休整。</a:t>
             </a:r>
             <a:endParaRPr lang="en-US" sz="1300" dirty="0"/>
           </a:p>
@@ -8782,7 +8653,7 @@
                 <a:ea typeface="Microsoft JhengHei" pitchFamily="34" charset="-122"/>
                 <a:cs typeface="Microsoft JhengHei" pitchFamily="34" charset="-120"/>
               </a:rPr>
-              <a:t>常態小睡 ★</a:t>
+              <a:t>輕鬆休整</a:t>
             </a:r>
             <a:endParaRPr lang="en-US" sz="1200" dirty="0"/>
           </a:p>
@@ -8909,7 +8780,7 @@
                 <a:ea typeface="Microsoft JhengHei" pitchFamily="34" charset="-122"/>
                 <a:cs typeface="Microsoft JhengHei" pitchFamily="34" charset="-120"/>
               </a:rPr>
-              <a:t>阿倍野 Harukas / 近鐵百貨</a:t>
+              <a:t>阿倍野 Harukas 觀景台 · 近鐵阿卡將</a:t>
             </a:r>
             <a:endParaRPr lang="en-US" sz="1800" dirty="0"/>
           </a:p>
@@ -8948,7 +8819,7 @@
                 <a:ea typeface="Microsoft JhengHei" pitchFamily="34" charset="-122"/>
                 <a:cs typeface="Microsoft JhengHei" pitchFamily="34" charset="-120"/>
               </a:rPr>
-              <a:t>大人服飾與選物考察；利用頂級育嬰室防禦。晚餐於高樓層景觀餐廳。</a:t>
+              <a:t>高空夜景體驗；於近鐵百貨 8F 阿卡將本鋪集中採購母嬰用品與藥妝。</a:t>
             </a:r>
             <a:endParaRPr lang="en-US" sz="1300" dirty="0"/>
           </a:p>
@@ -8987,7 +8858,7 @@
                 <a:ea typeface="Microsoft JhengHei" pitchFamily="34" charset="-122"/>
                 <a:cs typeface="Microsoft JhengHei" pitchFamily="34" charset="-120"/>
               </a:rPr>
-              <a:t>頂級育嬰室 · 高空景觀</a:t>
+              <a:t>頂級育嬰室 · 阿卡將 8F · 夜景</a:t>
             </a:r>
             <a:endParaRPr lang="en-US" sz="1200" dirty="0"/>
           </a:p>
@@ -9203,7 +9074,7 @@
                 <a:ea typeface="Microsoft JhengHei" pitchFamily="34" charset="-122"/>
                 <a:cs typeface="Microsoft JhengHei" pitchFamily="34" charset="-120"/>
               </a:rPr>
-              <a:t>神戶放電與百貨單點大採購</a:t>
+              <a:t>深海鯨鯊 · 星野草皮公園與天王寺在地晚餐</a:t>
             </a:r>
             <a:endParaRPr lang="en-US" sz="2600" dirty="0"/>
           </a:p>
@@ -9242,7 +9113,7 @@
                 <a:ea typeface="Microsoft JhengHei" pitchFamily="34" charset="-122"/>
                 <a:cs typeface="Microsoft JhengHei" pitchFamily="34" charset="-120"/>
               </a:rPr>
-              <a:t>8/7（週五）  ·  「超人博物館放電，心齋橋只進百貨」</a:t>
+              <a:t>8/7（週五）  ·  大阪港 → 天王寺  ·  「看鯨鯊全室內避暑，傍晚草皮散步」</a:t>
             </a:r>
             <a:endParaRPr lang="en-US" sz="1400" dirty="0"/>
           </a:p>
@@ -9347,7 +9218,7 @@
                 <a:ea typeface="Microsoft JhengHei" pitchFamily="34" charset="-122"/>
                 <a:cs typeface="Microsoft JhengHei" pitchFamily="34" charset="-120"/>
               </a:rPr>
-              <a:t>麵包超人兒童博物館</a:t>
+              <a:t>天保山海遊館</a:t>
             </a:r>
             <a:endParaRPr lang="en-US" sz="1800" dirty="0"/>
           </a:p>
@@ -9386,7 +9257,7 @@
                 <a:ea typeface="Microsoft JhengHei" pitchFamily="34" charset="-122"/>
                 <a:cs typeface="Microsoft JhengHei" pitchFamily="34" charset="-120"/>
               </a:rPr>
-              <a:t>神戶開館直入。全室內冷氣，高放電效率——這天的主放電場。</a:t>
+              <a:t>全室內恆溫避暑，無障礙推車動線看鯨鯊。天保山購物中心美食街午餐。</a:t>
             </a:r>
             <a:endParaRPr lang="en-US" sz="1300" dirty="0"/>
           </a:p>
@@ -9447,7 +9318,7 @@
                 <a:ea typeface="Microsoft JhengHei" pitchFamily="34" charset="-122"/>
                 <a:cs typeface="Microsoft JhengHei" pitchFamily="34" charset="-120"/>
               </a:rPr>
-              <a:t>全室內 · 高放電</a:t>
+              <a:t>室內恆溫 · 鯨鯊</a:t>
             </a:r>
             <a:endParaRPr lang="en-US" sz="1200" dirty="0"/>
           </a:p>
@@ -9552,7 +9423,7 @@
                 <a:ea typeface="Microsoft JhengHei" pitchFamily="34" charset="-122"/>
                 <a:cs typeface="Microsoft JhengHei" pitchFamily="34" charset="-120"/>
               </a:rPr>
-              <a:t>返大阪 / 深度小睡</a:t>
+              <a:t>海遊館周邊 / OMO7 休整</a:t>
             </a:r>
             <a:endParaRPr lang="en-US" sz="1800" dirty="0"/>
           </a:p>
@@ -9591,7 +9462,7 @@
                 <a:ea typeface="Microsoft JhengHei" pitchFamily="34" charset="-122"/>
                 <a:cs typeface="Microsoft JhengHei" pitchFamily="34" charset="-120"/>
               </a:rPr>
-              <a:t>車程與回房時段剛好銜接常態深度補眠。</a:t>
+              <a:t>海遊館周邊漫步或返回 OMO7 大廳享受設施。</a:t>
             </a:r>
             <a:endParaRPr lang="en-US" sz="1300" dirty="0"/>
           </a:p>
@@ -9652,7 +9523,7 @@
                 <a:ea typeface="Microsoft JhengHei" pitchFamily="34" charset="-122"/>
                 <a:cs typeface="Microsoft JhengHei" pitchFamily="34" charset="-120"/>
               </a:rPr>
-              <a:t>車上／房內補眠</a:t>
+              <a:t>悠閒休整</a:t>
             </a:r>
             <a:endParaRPr lang="en-US" sz="1200" dirty="0"/>
           </a:p>
@@ -9757,7 +9628,7 @@
                 <a:ea typeface="Microsoft JhengHei" pitchFamily="34" charset="-122"/>
                 <a:cs typeface="Microsoft JhengHei" pitchFamily="34" charset="-120"/>
               </a:rPr>
-              <a:t>大丸心齋橋百貨</a:t>
+              <a:t>OMO7 大草皮公園散步</a:t>
             </a:r>
             <a:endParaRPr lang="en-US" sz="1800" dirty="0"/>
           </a:p>
@@ -9796,7 +9667,7 @@
                 <a:ea typeface="Microsoft JhengHei" pitchFamily="34" charset="-122"/>
                 <a:cs typeface="Microsoft JhengHei" pitchFamily="34" charset="-120"/>
               </a:rPr>
-              <a:t>推車直進百貨內部，阿卡將本鋪採購藥妝與母嬰用品。奢華育嬰室做後盾。</a:t>
+              <a:t>享受草皮涼風，避開擁擠商圈，於天王寺圈享用在地晚餐。</a:t>
             </a:r>
             <a:endParaRPr lang="en-US" sz="1300" dirty="0"/>
           </a:p>
@@ -9819,7 +9690,7 @@
             </a:avLst>
           </a:prstGeom>
           <a:solidFill>
-            <a:srgbClr val="F8E8E4"/>
+            <a:srgbClr val="E8F0E4"/>
           </a:solidFill>
           <a:ln/>
         </p:spPr>
@@ -9851,13 +9722,13 @@
             <a:r>
               <a:rPr lang="en-US" sz="1200" b="1" dirty="0">
                 <a:solidFill>
-                  <a:srgbClr val="C23B22"/>
-                </a:solidFill>
-                <a:latin typeface="Microsoft JhengHei" pitchFamily="34" charset="0"/>
-                <a:ea typeface="Microsoft JhengHei" pitchFamily="34" charset="-122"/>
-                <a:cs typeface="Microsoft JhengHei" pitchFamily="34" charset="-120"/>
-              </a:rPr>
-              <a:t>禁戶外商店街</a:t>
+                  <a:srgbClr val="6B7F5A"/>
+                </a:solidFill>
+                <a:latin typeface="Microsoft JhengHei" pitchFamily="34" charset="0"/>
+                <a:ea typeface="Microsoft JhengHei" pitchFamily="34" charset="-122"/>
+                <a:cs typeface="Microsoft JhengHei" pitchFamily="34" charset="-120"/>
+              </a:rPr>
+              <a:t>草皮散步 · 在地晚餐</a:t>
             </a:r>
             <a:endParaRPr lang="en-US" sz="1200" dirty="0"/>
           </a:p>

</xml_diff>

<commit_message>
Synchronize all project assets (pocket-map.html, itinerary.pptx, create-pptx.js) with today's updates including 'Safe travels · 金運滿滿 · 龍貝貝開心' blessing and streamlined text
</commit_message>
<xml_diff>
--- a/itinerary.pptx
+++ b/itinerary.pptx
@@ -2595,7 +2595,7 @@
                 <a:ea typeface="Georgia" pitchFamily="34" charset="-122"/>
                 <a:cs typeface="Georgia" pitchFamily="34" charset="-120"/>
               </a:rPr>
-              <a:t>Safe travels  ·  金運滿滿  ·  寶寶開心</a:t>
+              <a:t>Safe travels  ·  金運滿滿  ·  龍貝貝開心</a:t>
             </a:r>
             <a:endParaRPr lang="en-US" sz="1600" dirty="0"/>
           </a:p>
@@ -2634,7 +2634,7 @@
                 <a:ea typeface="Microsoft JhengHei" pitchFamily="34" charset="-122"/>
                 <a:cs typeface="Microsoft JhengHei" pitchFamily="34" charset="-120"/>
               </a:rPr>
-              <a:t>京都大阪親子手繪行程  ·  2026.8.3–8.8  ·  專車直達版（含御金神社）</a:t>
+              <a:t>京都大阪親子手繪行程  ·  2026.8.3–8.8</a:t>
             </a:r>
             <a:endParaRPr lang="en-US" sz="1200" dirty="0"/>
           </a:p>

</xml_diff>

<commit_message>
Fully synchronize pocket map and PPTX files with main web app: update Morandi color palette, remove outdated AI slogans, and align title style across all assets
</commit_message>
<xml_diff>
--- a/itinerary.pptx
+++ b/itinerary.pptx
@@ -1684,7 +1684,7 @@
             <a:avLst/>
           </a:prstGeom>
           <a:solidFill>
-            <a:srgbClr val="1F1810"/>
+            <a:srgbClr val="1E2620"/>
           </a:solidFill>
           <a:ln/>
         </p:spPr>
@@ -1704,7 +1704,7 @@
             <a:avLst/>
           </a:prstGeom>
           <a:solidFill>
-            <a:srgbClr val="F3E6D0"/>
+            <a:srgbClr val="F8FAF7"/>
           </a:solidFill>
           <a:ln w="19050">
             <a:solidFill>
@@ -1730,7 +1730,7 @@
           </a:prstGeom>
           <a:ln w="12700">
             <a:solidFill>
-              <a:srgbClr val="2A2218">
+              <a:srgbClr val="1E2620">
                 <a:alpha val="45000"/>
               </a:srgbClr>
             </a:solidFill>
@@ -1746,7 +1746,7 @@
         </p:nvSpPr>
         <p:spPr>
           <a:xfrm>
-            <a:off x="914400" y="1188720"/>
+            <a:off x="914400" y="1280160"/>
             <a:ext cx="10332720" cy="365760"/>
           </a:xfrm>
           <a:prstGeom prst="rect">
@@ -1785,7 +1785,7 @@
         </p:nvSpPr>
         <p:spPr>
           <a:xfrm>
-            <a:off x="914400" y="1737360"/>
+            <a:off x="914400" y="1828800"/>
             <a:ext cx="10332720" cy="685800"/>
           </a:xfrm>
           <a:prstGeom prst="rect">
@@ -1804,7 +1804,7 @@
             <a:r>
               <a:rPr lang="en-US" sz="4000" b="1" dirty="0">
                 <a:solidFill>
-                  <a:srgbClr val="2A2218"/>
+                  <a:srgbClr val="1E2620"/>
                 </a:solidFill>
                 <a:latin typeface="Microsoft JhengHei" pitchFamily="34" charset="0"/>
                 <a:ea typeface="Microsoft JhengHei" pitchFamily="34" charset="-122"/>
@@ -1824,7 +1824,7 @@
         </p:nvSpPr>
         <p:spPr>
           <a:xfrm>
-            <a:off x="914400" y="2423160"/>
+            <a:off x="914400" y="2560320"/>
             <a:ext cx="10332720" cy="640080"/>
           </a:xfrm>
           <a:prstGeom prst="rect">
@@ -1849,7 +1849,7 @@
                 <a:ea typeface="Microsoft JhengHei" pitchFamily="34" charset="-122"/>
                 <a:cs typeface="Microsoft JhengHei" pitchFamily="34" charset="-120"/>
               </a:rPr>
-              <a:t>親子手繪行程</a:t>
+              <a:t>親子寫實手帳行程</a:t>
             </a:r>
             <a:endParaRPr lang="en-US" sz="3600" dirty="0"/>
           </a:p>
@@ -1857,46 +1857,7 @@
       </p:sp>
       <p:sp>
         <p:nvSpPr>
-          <p:cNvPr id="8" name="Text 6"/>
-          <p:cNvSpPr/>
-          <p:nvPr/>
-        </p:nvSpPr>
-        <p:spPr>
-          <a:xfrm>
-            <a:off x="914400" y="3200400"/>
-            <a:ext cx="10332720" cy="365760"/>
-          </a:xfrm>
-          <a:prstGeom prst="rect">
-            <a:avLst/>
-          </a:prstGeom>
-          <a:noFill/>
-          <a:ln/>
-        </p:spPr>
-        <p:txBody>
-          <a:bodyPr wrap="square" lIns="0" tIns="0" rIns="0" bIns="0" rtlCol="0" anchor="ctr"/>
-          <a:lstStyle/>
-          <a:p>
-            <a:pPr algn="ctr" indent="0" marL="0">
-              <a:buNone/>
-            </a:pPr>
-            <a:r>
-              <a:rPr lang="en-US" sz="1600" dirty="0">
-                <a:solidFill>
-                  <a:srgbClr val="5C4A38"/>
-                </a:solidFill>
-                <a:latin typeface="Microsoft JhengHei" pitchFamily="34" charset="0"/>
-                <a:ea typeface="Microsoft JhengHei" pitchFamily="34" charset="-122"/>
-                <a:cs typeface="Microsoft JhengHei" pitchFamily="34" charset="-120"/>
-              </a:rPr>
-              <a:t>專車直達版  ·  御金神社  ·  敘敘苑燒肉  ·  雙神社參拜</a:t>
-            </a:r>
-            <a:endParaRPr lang="en-US" sz="1600" dirty="0"/>
-          </a:p>
-        </p:txBody>
-      </p:sp>
-      <p:sp>
-        <p:nvSpPr>
-          <p:cNvPr id="9" name="Shape 7"/>
+          <p:cNvPr id="8" name="Shape 6"/>
           <p:cNvSpPr/>
           <p:nvPr/>
         </p:nvSpPr>
@@ -1911,11 +1872,11 @@
             </a:avLst>
           </a:prstGeom>
           <a:solidFill>
-            <a:srgbClr val="FFF8EB"/>
+            <a:srgbClr val="F0F4EF"/>
           </a:solidFill>
           <a:ln w="12700">
             <a:solidFill>
-              <a:srgbClr val="2A2218">
+              <a:srgbClr val="1E2620">
                 <a:alpha val="40000"/>
               </a:srgbClr>
             </a:solidFill>
@@ -1925,7 +1886,7 @@
       </p:sp>
       <p:sp>
         <p:nvSpPr>
-          <p:cNvPr id="10" name="Text 8"/>
+          <p:cNvPr id="9" name="Text 7"/>
           <p:cNvSpPr/>
           <p:nvPr/>
         </p:nvSpPr>
@@ -1950,7 +1911,7 @@
             <a:r>
               <a:rPr lang="en-US" sz="1200" dirty="0">
                 <a:solidFill>
-                  <a:srgbClr val="2A2218"/>
+                  <a:srgbClr val="1E2620"/>
                 </a:solidFill>
                 <a:latin typeface="Microsoft JhengHei" pitchFamily="34" charset="0"/>
                 <a:ea typeface="Microsoft JhengHei" pitchFamily="34" charset="-122"/>
@@ -1964,7 +1925,7 @@
       </p:sp>
       <p:sp>
         <p:nvSpPr>
-          <p:cNvPr id="11" name="Shape 9"/>
+          <p:cNvPr id="10" name="Shape 8"/>
           <p:cNvSpPr/>
           <p:nvPr/>
         </p:nvSpPr>
@@ -1986,7 +1947,7 @@
       </p:sp>
       <p:sp>
         <p:nvSpPr>
-          <p:cNvPr id="12" name="Text 10"/>
+          <p:cNvPr id="11" name="Text 9"/>
           <p:cNvSpPr/>
           <p:nvPr/>
         </p:nvSpPr>
@@ -2059,7 +2020,7 @@
       </p:sp>
       <p:sp>
         <p:nvSpPr>
-          <p:cNvPr id="13" name="Text 11"/>
+          <p:cNvPr id="12" name="Text 10"/>
           <p:cNvSpPr/>
           <p:nvPr/>
         </p:nvSpPr>
@@ -2084,7 +2045,7 @@
             <a:r>
               <a:rPr lang="en-US" sz="1300" dirty="0">
                 <a:solidFill>
-                  <a:srgbClr val="5C4A38"/>
+                  <a:srgbClr val="48544C"/>
                 </a:solidFill>
                 <a:latin typeface="Microsoft JhengHei" pitchFamily="34" charset="0"/>
                 <a:ea typeface="Microsoft JhengHei" pitchFamily="34" charset="-122"/>
@@ -2098,7 +2059,7 @@
       </p:sp>
       <p:sp>
         <p:nvSpPr>
-          <p:cNvPr id="14" name="Text 12"/>
+          <p:cNvPr id="13" name="Text 11"/>
           <p:cNvSpPr/>
           <p:nvPr/>
         </p:nvSpPr>
@@ -2175,7 +2136,7 @@
             <a:avLst/>
           </a:prstGeom>
           <a:solidFill>
-            <a:srgbClr val="1F1810"/>
+            <a:srgbClr val="1E2620"/>
           </a:solidFill>
           <a:ln/>
         </p:spPr>
@@ -2336,7 +2297,7 @@
             <a:r>
               <a:rPr lang="en-US" sz="1400" dirty="0">
                 <a:solidFill>
-                  <a:srgbClr val="F3E6D0"/>
+                  <a:srgbClr val="F8FAF7"/>
                 </a:solidFill>
                 <a:latin typeface="Microsoft JhengHei" pitchFamily="34" charset="0"/>
                 <a:ea typeface="Microsoft JhengHei" pitchFamily="34" charset="-122"/>
@@ -2443,7 +2404,7 @@
             <a:r>
               <a:rPr lang="en-US" sz="1400" dirty="0">
                 <a:solidFill>
-                  <a:srgbClr val="F3E6D0"/>
+                  <a:srgbClr val="F8FAF7"/>
                 </a:solidFill>
                 <a:latin typeface="Microsoft JhengHei" pitchFamily="34" charset="0"/>
                 <a:ea typeface="Microsoft JhengHei" pitchFamily="34" charset="-122"/>
@@ -2550,7 +2511,7 @@
             <a:r>
               <a:rPr lang="en-US" sz="1400" dirty="0">
                 <a:solidFill>
-                  <a:srgbClr val="F3E6D0"/>
+                  <a:srgbClr val="F8FAF7"/>
                 </a:solidFill>
                 <a:latin typeface="Microsoft JhengHei" pitchFamily="34" charset="0"/>
                 <a:ea typeface="Microsoft JhengHei" pitchFamily="34" charset="-122"/>
@@ -2628,7 +2589,7 @@
             <a:r>
               <a:rPr lang="en-US" sz="1200" dirty="0">
                 <a:solidFill>
-                  <a:srgbClr val="5C4A38"/>
+                  <a:srgbClr val="48544C"/>
                 </a:solidFill>
                 <a:latin typeface="Microsoft JhengHei" pitchFamily="34" charset="0"/>
                 <a:ea typeface="Microsoft JhengHei" pitchFamily="34" charset="-122"/>
@@ -2680,11 +2641,11 @@
             <a:avLst/>
           </a:prstGeom>
           <a:solidFill>
-            <a:srgbClr val="F3E6D0"/>
+            <a:srgbClr val="F8FAF7"/>
           </a:solidFill>
           <a:ln w="12700">
             <a:solidFill>
-              <a:srgbClr val="F3E6D0"/>
+              <a:srgbClr val="F8FAF7"/>
             </a:solidFill>
             <a:prstDash val="solid"/>
           </a:ln>
@@ -2706,7 +2667,7 @@
           </a:prstGeom>
           <a:ln w="12700">
             <a:solidFill>
-              <a:srgbClr val="2A2218">
+              <a:srgbClr val="1E2620">
                 <a:alpha val="30000"/>
               </a:srgbClr>
             </a:solidFill>
@@ -2741,7 +2702,7 @@
             <a:r>
               <a:rPr lang="en-US" sz="2800" b="1" dirty="0">
                 <a:solidFill>
-                  <a:srgbClr val="2A2218"/>
+                  <a:srgbClr val="1E2620"/>
                 </a:solidFill>
                 <a:latin typeface="Microsoft JhengHei" pitchFamily="34" charset="0"/>
                 <a:ea typeface="Microsoft JhengHei" pitchFamily="34" charset="-122"/>
@@ -2780,7 +2741,7 @@
             <a:r>
               <a:rPr lang="en-US" sz="1400" dirty="0">
                 <a:solidFill>
-                  <a:srgbClr val="5C4A38"/>
+                  <a:srgbClr val="48544C"/>
                 </a:solidFill>
                 <a:latin typeface="Microsoft JhengHei" pitchFamily="34" charset="0"/>
                 <a:ea typeface="Microsoft JhengHei" pitchFamily="34" charset="-122"/>
@@ -2809,7 +2770,7 @@
             </a:avLst>
           </a:prstGeom>
           <a:solidFill>
-            <a:srgbClr val="FFF8EB"/>
+            <a:srgbClr val="F0F4EF"/>
           </a:solidFill>
           <a:ln w="19050">
             <a:solidFill>
@@ -2917,7 +2878,7 @@
             <a:r>
               <a:rPr lang="en-US" sz="1200" dirty="0">
                 <a:solidFill>
-                  <a:srgbClr val="5C4A38"/>
+                  <a:srgbClr val="48544C"/>
                 </a:solidFill>
                 <a:latin typeface="Microsoft JhengHei" pitchFamily="34" charset="0"/>
                 <a:ea typeface="Microsoft JhengHei" pitchFamily="34" charset="-122"/>
@@ -2956,7 +2917,7 @@
             <a:r>
               <a:rPr lang="en-US" sz="1600" b="1" dirty="0">
                 <a:solidFill>
-                  <a:srgbClr val="2A2218"/>
+                  <a:srgbClr val="1E2620"/>
                 </a:solidFill>
                 <a:latin typeface="Microsoft JhengHei" pitchFamily="34" charset="0"/>
                 <a:ea typeface="Microsoft JhengHei" pitchFamily="34" charset="-122"/>
@@ -2995,7 +2956,7 @@
             <a:r>
               <a:rPr lang="en-US" sz="1200" dirty="0">
                 <a:solidFill>
-                  <a:srgbClr val="5C4A38"/>
+                  <a:srgbClr val="48544C"/>
                 </a:solidFill>
                 <a:latin typeface="Microsoft JhengHei" pitchFamily="34" charset="0"/>
                 <a:ea typeface="Microsoft JhengHei" pitchFamily="34" charset="-122"/>
@@ -3012,7 +2973,7 @@
             <a:r>
               <a:rPr lang="en-US" sz="1200" dirty="0">
                 <a:solidFill>
-                  <a:srgbClr val="5C4A38"/>
+                  <a:srgbClr val="48544C"/>
                 </a:solidFill>
                 <a:latin typeface="Microsoft JhengHei" pitchFamily="34" charset="0"/>
                 <a:ea typeface="Microsoft JhengHei" pitchFamily="34" charset="-122"/>
@@ -3041,7 +3002,7 @@
             </a:avLst>
           </a:prstGeom>
           <a:solidFill>
-            <a:srgbClr val="FFF8EB"/>
+            <a:srgbClr val="F0F4EF"/>
           </a:solidFill>
           <a:ln w="19050">
             <a:solidFill>
@@ -3149,7 +3110,7 @@
             <a:r>
               <a:rPr lang="en-US" sz="1200" dirty="0">
                 <a:solidFill>
-                  <a:srgbClr val="5C4A38"/>
+                  <a:srgbClr val="48544C"/>
                 </a:solidFill>
                 <a:latin typeface="Microsoft JhengHei" pitchFamily="34" charset="0"/>
                 <a:ea typeface="Microsoft JhengHei" pitchFamily="34" charset="-122"/>
@@ -3188,7 +3149,7 @@
             <a:r>
               <a:rPr lang="en-US" sz="1600" b="1" dirty="0">
                 <a:solidFill>
-                  <a:srgbClr val="2A2218"/>
+                  <a:srgbClr val="1E2620"/>
                 </a:solidFill>
                 <a:latin typeface="Microsoft JhengHei" pitchFamily="34" charset="0"/>
                 <a:ea typeface="Microsoft JhengHei" pitchFamily="34" charset="-122"/>
@@ -3227,7 +3188,7 @@
             <a:r>
               <a:rPr lang="en-US" sz="1200" dirty="0">
                 <a:solidFill>
-                  <a:srgbClr val="5C4A38"/>
+                  <a:srgbClr val="48544C"/>
                 </a:solidFill>
                 <a:latin typeface="Microsoft JhengHei" pitchFamily="34" charset="0"/>
                 <a:ea typeface="Microsoft JhengHei" pitchFamily="34" charset="-122"/>
@@ -3244,7 +3205,7 @@
             <a:r>
               <a:rPr lang="en-US" sz="1200" dirty="0">
                 <a:solidFill>
-                  <a:srgbClr val="5C4A38"/>
+                  <a:srgbClr val="48544C"/>
                 </a:solidFill>
                 <a:latin typeface="Microsoft JhengHei" pitchFamily="34" charset="0"/>
                 <a:ea typeface="Microsoft JhengHei" pitchFamily="34" charset="-122"/>
@@ -3273,7 +3234,7 @@
             </a:avLst>
           </a:prstGeom>
           <a:solidFill>
-            <a:srgbClr val="FFF8EB"/>
+            <a:srgbClr val="F0F4EF"/>
           </a:solidFill>
           <a:ln w="19050">
             <a:solidFill>
@@ -3381,7 +3342,7 @@
             <a:r>
               <a:rPr lang="en-US" sz="1200" dirty="0">
                 <a:solidFill>
-                  <a:srgbClr val="5C4A38"/>
+                  <a:srgbClr val="48544C"/>
                 </a:solidFill>
                 <a:latin typeface="Microsoft JhengHei" pitchFamily="34" charset="0"/>
                 <a:ea typeface="Microsoft JhengHei" pitchFamily="34" charset="-122"/>
@@ -3420,7 +3381,7 @@
             <a:r>
               <a:rPr lang="en-US" sz="1600" b="1" dirty="0">
                 <a:solidFill>
-                  <a:srgbClr val="2A2218"/>
+                  <a:srgbClr val="1E2620"/>
                 </a:solidFill>
                 <a:latin typeface="Microsoft JhengHei" pitchFamily="34" charset="0"/>
                 <a:ea typeface="Microsoft JhengHei" pitchFamily="34" charset="-122"/>
@@ -3459,7 +3420,7 @@
             <a:r>
               <a:rPr lang="en-US" sz="1200" dirty="0">
                 <a:solidFill>
-                  <a:srgbClr val="5C4A38"/>
+                  <a:srgbClr val="48544C"/>
                 </a:solidFill>
                 <a:latin typeface="Microsoft JhengHei" pitchFamily="34" charset="0"/>
                 <a:ea typeface="Microsoft JhengHei" pitchFamily="34" charset="-122"/>
@@ -3476,7 +3437,7 @@
             <a:r>
               <a:rPr lang="en-US" sz="1200" dirty="0">
                 <a:solidFill>
-                  <a:srgbClr val="5C4A38"/>
+                  <a:srgbClr val="48544C"/>
                 </a:solidFill>
                 <a:latin typeface="Microsoft JhengHei" pitchFamily="34" charset="0"/>
                 <a:ea typeface="Microsoft JhengHei" pitchFamily="34" charset="-122"/>
@@ -3505,7 +3466,7 @@
             </a:avLst>
           </a:prstGeom>
           <a:solidFill>
-            <a:srgbClr val="FFF8EB"/>
+            <a:srgbClr val="F0F4EF"/>
           </a:solidFill>
           <a:ln w="19050">
             <a:solidFill>
@@ -3613,7 +3574,7 @@
             <a:r>
               <a:rPr lang="en-US" sz="1200" dirty="0">
                 <a:solidFill>
-                  <a:srgbClr val="5C4A38"/>
+                  <a:srgbClr val="48544C"/>
                 </a:solidFill>
                 <a:latin typeface="Microsoft JhengHei" pitchFamily="34" charset="0"/>
                 <a:ea typeface="Microsoft JhengHei" pitchFamily="34" charset="-122"/>
@@ -3652,7 +3613,7 @@
             <a:r>
               <a:rPr lang="en-US" sz="1600" b="1" dirty="0">
                 <a:solidFill>
-                  <a:srgbClr val="2A2218"/>
+                  <a:srgbClr val="1E2620"/>
                 </a:solidFill>
                 <a:latin typeface="Microsoft JhengHei" pitchFamily="34" charset="0"/>
                 <a:ea typeface="Microsoft JhengHei" pitchFamily="34" charset="-122"/>
@@ -3691,7 +3652,7 @@
             <a:r>
               <a:rPr lang="en-US" sz="1200" dirty="0">
                 <a:solidFill>
-                  <a:srgbClr val="5C4A38"/>
+                  <a:srgbClr val="48544C"/>
                 </a:solidFill>
                 <a:latin typeface="Microsoft JhengHei" pitchFamily="34" charset="0"/>
                 <a:ea typeface="Microsoft JhengHei" pitchFamily="34" charset="-122"/>
@@ -3708,7 +3669,7 @@
             <a:r>
               <a:rPr lang="en-US" sz="1200" dirty="0">
                 <a:solidFill>
-                  <a:srgbClr val="5C4A38"/>
+                  <a:srgbClr val="48544C"/>
                 </a:solidFill>
                 <a:latin typeface="Microsoft JhengHei" pitchFamily="34" charset="0"/>
                 <a:ea typeface="Microsoft JhengHei" pitchFamily="34" charset="-122"/>
@@ -3737,7 +3698,7 @@
             </a:avLst>
           </a:prstGeom>
           <a:solidFill>
-            <a:srgbClr val="FFF8EB"/>
+            <a:srgbClr val="F0F4EF"/>
           </a:solidFill>
           <a:ln w="19050">
             <a:solidFill>
@@ -3845,7 +3806,7 @@
             <a:r>
               <a:rPr lang="en-US" sz="1200" dirty="0">
                 <a:solidFill>
-                  <a:srgbClr val="5C4A38"/>
+                  <a:srgbClr val="48544C"/>
                 </a:solidFill>
                 <a:latin typeface="Microsoft JhengHei" pitchFamily="34" charset="0"/>
                 <a:ea typeface="Microsoft JhengHei" pitchFamily="34" charset="-122"/>
@@ -3884,7 +3845,7 @@
             <a:r>
               <a:rPr lang="en-US" sz="1600" b="1" dirty="0">
                 <a:solidFill>
-                  <a:srgbClr val="2A2218"/>
+                  <a:srgbClr val="1E2620"/>
                 </a:solidFill>
                 <a:latin typeface="Microsoft JhengHei" pitchFamily="34" charset="0"/>
                 <a:ea typeface="Microsoft JhengHei" pitchFamily="34" charset="-122"/>
@@ -3923,7 +3884,7 @@
             <a:r>
               <a:rPr lang="en-US" sz="1200" dirty="0">
                 <a:solidFill>
-                  <a:srgbClr val="5C4A38"/>
+                  <a:srgbClr val="48544C"/>
                 </a:solidFill>
                 <a:latin typeface="Microsoft JhengHei" pitchFamily="34" charset="0"/>
                 <a:ea typeface="Microsoft JhengHei" pitchFamily="34" charset="-122"/>
@@ -3940,7 +3901,7 @@
             <a:r>
               <a:rPr lang="en-US" sz="1200" dirty="0">
                 <a:solidFill>
-                  <a:srgbClr val="5C4A38"/>
+                  <a:srgbClr val="48544C"/>
                 </a:solidFill>
                 <a:latin typeface="Microsoft JhengHei" pitchFamily="34" charset="0"/>
                 <a:ea typeface="Microsoft JhengHei" pitchFamily="34" charset="-122"/>
@@ -3969,11 +3930,11 @@
             </a:avLst>
           </a:prstGeom>
           <a:solidFill>
-            <a:srgbClr val="FFF8EB"/>
+            <a:srgbClr val="F0F4EF"/>
           </a:solidFill>
           <a:ln w="19050">
             <a:solidFill>
-              <a:srgbClr val="5C4A38"/>
+              <a:srgbClr val="48544C"/>
             </a:solidFill>
             <a:prstDash val="solid"/>
           </a:ln>
@@ -4001,11 +3962,11 @@
             <a:avLst/>
           </a:prstGeom>
           <a:solidFill>
-            <a:srgbClr val="5C4A38"/>
+            <a:srgbClr val="48544C"/>
           </a:solidFill>
           <a:ln w="12700">
             <a:solidFill>
-              <a:srgbClr val="5C4A38"/>
+              <a:srgbClr val="48544C"/>
             </a:solidFill>
             <a:prstDash val="solid"/>
           </a:ln>
@@ -4038,7 +3999,7 @@
             <a:r>
               <a:rPr lang="en-US" sz="2200" b="1" dirty="0">
                 <a:solidFill>
-                  <a:srgbClr val="5C4A38"/>
+                  <a:srgbClr val="48544C"/>
                 </a:solidFill>
                 <a:latin typeface="Georgia" pitchFamily="34" charset="0"/>
                 <a:ea typeface="Georgia" pitchFamily="34" charset="-122"/>
@@ -4077,7 +4038,7 @@
             <a:r>
               <a:rPr lang="en-US" sz="1200" dirty="0">
                 <a:solidFill>
-                  <a:srgbClr val="5C4A38"/>
+                  <a:srgbClr val="48544C"/>
                 </a:solidFill>
                 <a:latin typeface="Microsoft JhengHei" pitchFamily="34" charset="0"/>
                 <a:ea typeface="Microsoft JhengHei" pitchFamily="34" charset="-122"/>
@@ -4116,7 +4077,7 @@
             <a:r>
               <a:rPr lang="en-US" sz="1600" b="1" dirty="0">
                 <a:solidFill>
-                  <a:srgbClr val="2A2218"/>
+                  <a:srgbClr val="1E2620"/>
                 </a:solidFill>
                 <a:latin typeface="Microsoft JhengHei" pitchFamily="34" charset="0"/>
                 <a:ea typeface="Microsoft JhengHei" pitchFamily="34" charset="-122"/>
@@ -4155,7 +4116,7 @@
             <a:r>
               <a:rPr lang="en-US" sz="1200" dirty="0">
                 <a:solidFill>
-                  <a:srgbClr val="5C4A38"/>
+                  <a:srgbClr val="48544C"/>
                 </a:solidFill>
                 <a:latin typeface="Microsoft JhengHei" pitchFamily="34" charset="0"/>
                 <a:ea typeface="Microsoft JhengHei" pitchFamily="34" charset="-122"/>
@@ -4172,7 +4133,7 @@
             <a:r>
               <a:rPr lang="en-US" sz="1200" dirty="0">
                 <a:solidFill>
-                  <a:srgbClr val="5C4A38"/>
+                  <a:srgbClr val="48544C"/>
                 </a:solidFill>
                 <a:latin typeface="Microsoft JhengHei" pitchFamily="34" charset="0"/>
                 <a:ea typeface="Microsoft JhengHei" pitchFamily="34" charset="-122"/>
@@ -4211,7 +4172,7 @@
             <a:r>
               <a:rPr lang="en-US" sz="1100" dirty="0">
                 <a:solidFill>
-                  <a:srgbClr val="5C4A38"/>
+                  <a:srgbClr val="48544C"/>
                 </a:solidFill>
                 <a:latin typeface="Georgia" pitchFamily="34" charset="0"/>
                 <a:ea typeface="Georgia" pitchFamily="34" charset="-122"/>
@@ -4263,11 +4224,11 @@
             <a:avLst/>
           </a:prstGeom>
           <a:solidFill>
-            <a:srgbClr val="F3E6D0"/>
+            <a:srgbClr val="F8FAF7"/>
           </a:solidFill>
           <a:ln w="12700">
             <a:solidFill>
-              <a:srgbClr val="F3E6D0"/>
+              <a:srgbClr val="F8FAF7"/>
             </a:solidFill>
             <a:prstDash val="solid"/>
           </a:ln>
@@ -4289,7 +4250,7 @@
           </a:prstGeom>
           <a:ln w="12700">
             <a:solidFill>
-              <a:srgbClr val="2A2218">
+              <a:srgbClr val="1E2620">
                 <a:alpha val="30000"/>
               </a:srgbClr>
             </a:solidFill>
@@ -4388,7 +4349,7 @@
             <a:r>
               <a:rPr lang="en-US" sz="2600" b="1" dirty="0">
                 <a:solidFill>
-                  <a:srgbClr val="2A2218"/>
+                  <a:srgbClr val="1E2620"/>
                 </a:solidFill>
                 <a:latin typeface="Microsoft JhengHei" pitchFamily="34" charset="0"/>
                 <a:ea typeface="Microsoft JhengHei" pitchFamily="34" charset="-122"/>
@@ -4427,7 +4388,7 @@
             <a:r>
               <a:rPr lang="en-US" sz="1300" dirty="0">
                 <a:solidFill>
-                  <a:srgbClr val="5C4A38"/>
+                  <a:srgbClr val="48544C"/>
                 </a:solidFill>
                 <a:latin typeface="Microsoft JhengHei" pitchFamily="34" charset="0"/>
                 <a:ea typeface="Microsoft JhengHei" pitchFamily="34" charset="-122"/>
@@ -4454,7 +4415,7 @@
             <a:avLst/>
           </a:prstGeom>
           <a:solidFill>
-            <a:srgbClr val="FFF8EB"/>
+            <a:srgbClr val="F0F4EF"/>
           </a:solidFill>
           <a:ln w="25400">
             <a:solidFill>
@@ -4481,7 +4442,7 @@
           <a:noFill/>
           <a:ln w="15875">
             <a:solidFill>
-              <a:srgbClr val="2A2218">
+              <a:srgbClr val="1E2620">
                 <a:alpha val="50000"/>
               </a:srgbClr>
             </a:solidFill>
@@ -4555,7 +4516,7 @@
             <a:r>
               <a:rPr lang="en-US" sz="1600" b="1" dirty="0">
                 <a:solidFill>
-                  <a:srgbClr val="2A2218"/>
+                  <a:srgbClr val="1E2620"/>
                 </a:solidFill>
                 <a:latin typeface="Microsoft JhengHei" pitchFamily="34" charset="0"/>
                 <a:ea typeface="Microsoft JhengHei" pitchFamily="34" charset="-122"/>
@@ -4594,7 +4555,7 @@
             <a:r>
               <a:rPr lang="en-US" sz="1300" dirty="0">
                 <a:solidFill>
-                  <a:srgbClr val="5C4A38"/>
+                  <a:srgbClr val="48544C"/>
                 </a:solidFill>
                 <a:latin typeface="Microsoft JhengHei" pitchFamily="34" charset="0"/>
                 <a:ea typeface="Microsoft JhengHei" pitchFamily="34" charset="-122"/>
@@ -4621,7 +4582,7 @@
             <a:avLst/>
           </a:prstGeom>
           <a:solidFill>
-            <a:srgbClr val="FFF8EB"/>
+            <a:srgbClr val="F0F4EF"/>
           </a:solidFill>
           <a:ln w="25400">
             <a:solidFill>
@@ -4648,7 +4609,7 @@
           <a:noFill/>
           <a:ln w="15875">
             <a:solidFill>
-              <a:srgbClr val="2A2218">
+              <a:srgbClr val="1E2620">
                 <a:alpha val="50000"/>
               </a:srgbClr>
             </a:solidFill>
@@ -4722,7 +4683,7 @@
             <a:r>
               <a:rPr lang="en-US" sz="1600" b="1" dirty="0">
                 <a:solidFill>
-                  <a:srgbClr val="2A2218"/>
+                  <a:srgbClr val="1E2620"/>
                 </a:solidFill>
                 <a:latin typeface="Microsoft JhengHei" pitchFamily="34" charset="0"/>
                 <a:ea typeface="Microsoft JhengHei" pitchFamily="34" charset="-122"/>
@@ -4761,7 +4722,7 @@
             <a:r>
               <a:rPr lang="en-US" sz="1300" dirty="0">
                 <a:solidFill>
-                  <a:srgbClr val="5C4A38"/>
+                  <a:srgbClr val="48544C"/>
                 </a:solidFill>
                 <a:latin typeface="Microsoft JhengHei" pitchFamily="34" charset="0"/>
                 <a:ea typeface="Microsoft JhengHei" pitchFamily="34" charset="-122"/>
@@ -4788,7 +4749,7 @@
             <a:avLst/>
           </a:prstGeom>
           <a:solidFill>
-            <a:srgbClr val="FFF8EB"/>
+            <a:srgbClr val="F0F4EF"/>
           </a:solidFill>
           <a:ln w="25400">
             <a:solidFill>
@@ -4815,7 +4776,7 @@
           <a:noFill/>
           <a:ln w="15875">
             <a:solidFill>
-              <a:srgbClr val="2A2218">
+              <a:srgbClr val="1E2620">
                 <a:alpha val="50000"/>
               </a:srgbClr>
             </a:solidFill>
@@ -4889,7 +4850,7 @@
             <a:r>
               <a:rPr lang="en-US" sz="1600" b="1" dirty="0">
                 <a:solidFill>
-                  <a:srgbClr val="2A2218"/>
+                  <a:srgbClr val="1E2620"/>
                 </a:solidFill>
                 <a:latin typeface="Microsoft JhengHei" pitchFamily="34" charset="0"/>
                 <a:ea typeface="Microsoft JhengHei" pitchFamily="34" charset="-122"/>
@@ -4928,7 +4889,7 @@
             <a:r>
               <a:rPr lang="en-US" sz="1300" dirty="0">
                 <a:solidFill>
-                  <a:srgbClr val="5C4A38"/>
+                  <a:srgbClr val="48544C"/>
                 </a:solidFill>
                 <a:latin typeface="Microsoft JhengHei" pitchFamily="34" charset="0"/>
                 <a:ea typeface="Microsoft JhengHei" pitchFamily="34" charset="-122"/>
@@ -4955,7 +4916,7 @@
             <a:avLst/>
           </a:prstGeom>
           <a:solidFill>
-            <a:srgbClr val="FFF8EB"/>
+            <a:srgbClr val="F0F4EF"/>
           </a:solidFill>
           <a:ln w="25400">
             <a:solidFill>
@@ -5031,7 +4992,7 @@
             <a:r>
               <a:rPr lang="en-US" sz="1600" b="1" dirty="0">
                 <a:solidFill>
-                  <a:srgbClr val="2A2218"/>
+                  <a:srgbClr val="1E2620"/>
                 </a:solidFill>
                 <a:latin typeface="Microsoft JhengHei" pitchFamily="34" charset="0"/>
                 <a:ea typeface="Microsoft JhengHei" pitchFamily="34" charset="-122"/>
@@ -5070,7 +5031,7 @@
             <a:r>
               <a:rPr lang="en-US" sz="1300" dirty="0">
                 <a:solidFill>
-                  <a:srgbClr val="5C4A38"/>
+                  <a:srgbClr val="48544C"/>
                 </a:solidFill>
                 <a:latin typeface="Microsoft JhengHei" pitchFamily="34" charset="0"/>
                 <a:ea typeface="Microsoft JhengHei" pitchFamily="34" charset="-122"/>
@@ -5109,7 +5070,7 @@
             <a:r>
               <a:rPr lang="en-US" sz="1100" dirty="0">
                 <a:solidFill>
-                  <a:srgbClr val="5C4A38"/>
+                  <a:srgbClr val="48544C"/>
                 </a:solidFill>
                 <a:latin typeface="Georgia" pitchFamily="34" charset="0"/>
                 <a:ea typeface="Georgia" pitchFamily="34" charset="-122"/>
@@ -5161,11 +5122,11 @@
             <a:avLst/>
           </a:prstGeom>
           <a:solidFill>
-            <a:srgbClr val="F3E6D0"/>
+            <a:srgbClr val="F8FAF7"/>
           </a:solidFill>
           <a:ln w="12700">
             <a:solidFill>
-              <a:srgbClr val="F3E6D0"/>
+              <a:srgbClr val="F8FAF7"/>
             </a:solidFill>
             <a:prstDash val="solid"/>
           </a:ln>
@@ -5187,7 +5148,7 @@
           </a:prstGeom>
           <a:ln w="12700">
             <a:solidFill>
-              <a:srgbClr val="2A2218">
+              <a:srgbClr val="1E2620">
                 <a:alpha val="30000"/>
               </a:srgbClr>
             </a:solidFill>
@@ -5286,7 +5247,7 @@
             <a:r>
               <a:rPr lang="en-US" sz="2400" b="1" dirty="0">
                 <a:solidFill>
-                  <a:srgbClr val="2A2218"/>
+                  <a:srgbClr val="1E2620"/>
                 </a:solidFill>
                 <a:latin typeface="Microsoft JhengHei" pitchFamily="34" charset="0"/>
                 <a:ea typeface="Microsoft JhengHei" pitchFamily="34" charset="-122"/>
@@ -5325,7 +5286,7 @@
             <a:r>
               <a:rPr lang="en-US" sz="1300" dirty="0">
                 <a:solidFill>
-                  <a:srgbClr val="5C4A38"/>
+                  <a:srgbClr val="48544C"/>
                 </a:solidFill>
                 <a:latin typeface="Microsoft JhengHei" pitchFamily="34" charset="0"/>
                 <a:ea typeface="Microsoft JhengHei" pitchFamily="34" charset="-122"/>
@@ -5354,7 +5315,7 @@
             </a:avLst>
           </a:prstGeom>
           <a:solidFill>
-            <a:srgbClr val="FFF8EB"/>
+            <a:srgbClr val="F0F4EF"/>
           </a:solidFill>
           <a:ln w="19050">
             <a:solidFill>
@@ -5430,7 +5391,7 @@
             <a:r>
               <a:rPr lang="en-US" sz="1700" b="1" dirty="0">
                 <a:solidFill>
-                  <a:srgbClr val="2A2218"/>
+                  <a:srgbClr val="1E2620"/>
                 </a:solidFill>
                 <a:latin typeface="Microsoft JhengHei" pitchFamily="34" charset="0"/>
                 <a:ea typeface="Microsoft JhengHei" pitchFamily="34" charset="-122"/>
@@ -5469,7 +5430,7 @@
             <a:r>
               <a:rPr lang="en-US" sz="1200" dirty="0">
                 <a:solidFill>
-                  <a:srgbClr val="5C4A38"/>
+                  <a:srgbClr val="48544C"/>
                 </a:solidFill>
                 <a:latin typeface="Microsoft JhengHei" pitchFamily="34" charset="0"/>
                 <a:ea typeface="Microsoft JhengHei" pitchFamily="34" charset="-122"/>
@@ -5537,7 +5498,7 @@
             </a:avLst>
           </a:prstGeom>
           <a:solidFill>
-            <a:srgbClr val="FFF8EB"/>
+            <a:srgbClr val="F0F4EF"/>
           </a:solidFill>
           <a:ln w="19050">
             <a:solidFill>
@@ -5613,7 +5574,7 @@
             <a:r>
               <a:rPr lang="en-US" sz="1700" b="1" dirty="0">
                 <a:solidFill>
-                  <a:srgbClr val="2A2218"/>
+                  <a:srgbClr val="1E2620"/>
                 </a:solidFill>
                 <a:latin typeface="Microsoft JhengHei" pitchFamily="34" charset="0"/>
                 <a:ea typeface="Microsoft JhengHei" pitchFamily="34" charset="-122"/>
@@ -5652,7 +5613,7 @@
             <a:r>
               <a:rPr lang="en-US" sz="1200" dirty="0">
                 <a:solidFill>
-                  <a:srgbClr val="5C4A38"/>
+                  <a:srgbClr val="48544C"/>
                 </a:solidFill>
                 <a:latin typeface="Microsoft JhengHei" pitchFamily="34" charset="0"/>
                 <a:ea typeface="Microsoft JhengHei" pitchFamily="34" charset="-122"/>
@@ -5720,7 +5681,7 @@
             </a:avLst>
           </a:prstGeom>
           <a:solidFill>
-            <a:srgbClr val="FFF8EB"/>
+            <a:srgbClr val="F0F4EF"/>
           </a:solidFill>
           <a:ln w="19050">
             <a:solidFill>
@@ -5796,7 +5757,7 @@
             <a:r>
               <a:rPr lang="en-US" sz="1700" b="1" dirty="0">
                 <a:solidFill>
-                  <a:srgbClr val="2A2218"/>
+                  <a:srgbClr val="1E2620"/>
                 </a:solidFill>
                 <a:latin typeface="Microsoft JhengHei" pitchFamily="34" charset="0"/>
                 <a:ea typeface="Microsoft JhengHei" pitchFamily="34" charset="-122"/>
@@ -5835,7 +5796,7 @@
             <a:r>
               <a:rPr lang="en-US" sz="1200" dirty="0">
                 <a:solidFill>
-                  <a:srgbClr val="5C4A38"/>
+                  <a:srgbClr val="48544C"/>
                 </a:solidFill>
                 <a:latin typeface="Microsoft JhengHei" pitchFamily="34" charset="0"/>
                 <a:ea typeface="Microsoft JhengHei" pitchFamily="34" charset="-122"/>
@@ -5903,11 +5864,11 @@
             </a:avLst>
           </a:prstGeom>
           <a:solidFill>
-            <a:srgbClr val="FFF8EB"/>
+            <a:srgbClr val="F0F4EF"/>
           </a:solidFill>
           <a:ln w="19050">
             <a:solidFill>
-              <a:srgbClr val="2A2218"/>
+              <a:srgbClr val="1E2620"/>
             </a:solidFill>
             <a:prstDash val="solid"/>
           </a:ln>
@@ -5940,7 +5901,7 @@
             <a:r>
               <a:rPr lang="en-US" sz="1200" b="1" dirty="0">
                 <a:solidFill>
-                  <a:srgbClr val="2A2218"/>
+                  <a:srgbClr val="1E2620"/>
                 </a:solidFill>
                 <a:latin typeface="Georgia" pitchFamily="34" charset="0"/>
                 <a:ea typeface="Georgia" pitchFamily="34" charset="-122"/>
@@ -5979,7 +5940,7 @@
             <a:r>
               <a:rPr lang="en-US" sz="1700" b="1" dirty="0">
                 <a:solidFill>
-                  <a:srgbClr val="2A2218"/>
+                  <a:srgbClr val="1E2620"/>
                 </a:solidFill>
                 <a:latin typeface="Microsoft JhengHei" pitchFamily="34" charset="0"/>
                 <a:ea typeface="Microsoft JhengHei" pitchFamily="34" charset="-122"/>
@@ -6018,7 +5979,7 @@
             <a:r>
               <a:rPr lang="en-US" sz="1200" dirty="0">
                 <a:solidFill>
-                  <a:srgbClr val="5C4A38"/>
+                  <a:srgbClr val="48544C"/>
                 </a:solidFill>
                 <a:latin typeface="Microsoft JhengHei" pitchFamily="34" charset="0"/>
                 <a:ea typeface="Microsoft JhengHei" pitchFamily="34" charset="-122"/>
@@ -6086,7 +6047,7 @@
             </a:avLst>
           </a:prstGeom>
           <a:solidFill>
-            <a:srgbClr val="FFF8EB"/>
+            <a:srgbClr val="F0F4EF"/>
           </a:solidFill>
           <a:ln w="19050">
             <a:solidFill>
@@ -6162,7 +6123,7 @@
             <a:r>
               <a:rPr lang="en-US" sz="1700" b="1" dirty="0">
                 <a:solidFill>
-                  <a:srgbClr val="2A2218"/>
+                  <a:srgbClr val="1E2620"/>
                 </a:solidFill>
                 <a:latin typeface="Microsoft JhengHei" pitchFamily="34" charset="0"/>
                 <a:ea typeface="Microsoft JhengHei" pitchFamily="34" charset="-122"/>
@@ -6201,7 +6162,7 @@
             <a:r>
               <a:rPr lang="en-US" sz="1200" dirty="0">
                 <a:solidFill>
-                  <a:srgbClr val="5C4A38"/>
+                  <a:srgbClr val="48544C"/>
                 </a:solidFill>
                 <a:latin typeface="Microsoft JhengHei" pitchFamily="34" charset="0"/>
                 <a:ea typeface="Microsoft JhengHei" pitchFamily="34" charset="-122"/>
@@ -6306,7 +6267,7 @@
             <a:r>
               <a:rPr lang="en-US" sz="1400" dirty="0">
                 <a:solidFill>
-                  <a:srgbClr val="2A2218"/>
+                  <a:srgbClr val="1E2620"/>
                 </a:solidFill>
                 <a:latin typeface="Microsoft JhengHei" pitchFamily="34" charset="0"/>
                 <a:ea typeface="Microsoft JhengHei" pitchFamily="34" charset="-122"/>
@@ -6345,7 +6306,7 @@
             <a:r>
               <a:rPr lang="en-US" sz="1100" dirty="0">
                 <a:solidFill>
-                  <a:srgbClr val="5C4A38"/>
+                  <a:srgbClr val="48544C"/>
                 </a:solidFill>
                 <a:latin typeface="Georgia" pitchFamily="34" charset="0"/>
                 <a:ea typeface="Georgia" pitchFamily="34" charset="-122"/>
@@ -6397,11 +6358,11 @@
             <a:avLst/>
           </a:prstGeom>
           <a:solidFill>
-            <a:srgbClr val="F3E6D0"/>
+            <a:srgbClr val="F8FAF7"/>
           </a:solidFill>
           <a:ln w="12700">
             <a:solidFill>
-              <a:srgbClr val="F3E6D0"/>
+              <a:srgbClr val="F8FAF7"/>
             </a:solidFill>
             <a:prstDash val="solid"/>
           </a:ln>
@@ -6423,7 +6384,7 @@
           </a:prstGeom>
           <a:ln w="12700">
             <a:solidFill>
-              <a:srgbClr val="2A2218">
+              <a:srgbClr val="1E2620">
                 <a:alpha val="30000"/>
               </a:srgbClr>
             </a:solidFill>
@@ -6522,7 +6483,7 @@
             <a:r>
               <a:rPr lang="en-US" sz="2400" b="1" dirty="0">
                 <a:solidFill>
-                  <a:srgbClr val="2A2218"/>
+                  <a:srgbClr val="1E2620"/>
                 </a:solidFill>
                 <a:latin typeface="Microsoft JhengHei" pitchFamily="34" charset="0"/>
                 <a:ea typeface="Microsoft JhengHei" pitchFamily="34" charset="-122"/>
@@ -6551,7 +6512,7 @@
             </a:avLst>
           </a:prstGeom>
           <a:solidFill>
-            <a:srgbClr val="FFF8EB"/>
+            <a:srgbClr val="F0F4EF"/>
           </a:solidFill>
           <a:ln w="15875">
             <a:solidFill>
@@ -6666,7 +6627,7 @@
             <a:r>
               <a:rPr lang="en-US" sz="1300" dirty="0">
                 <a:solidFill>
-                  <a:srgbClr val="5C4A38"/>
+                  <a:srgbClr val="48544C"/>
                 </a:solidFill>
                 <a:latin typeface="Microsoft JhengHei" pitchFamily="34" charset="0"/>
                 <a:ea typeface="Microsoft JhengHei" pitchFamily="34" charset="-122"/>
@@ -6683,7 +6644,7 @@
             <a:r>
               <a:rPr lang="en-US" sz="1300" dirty="0">
                 <a:solidFill>
-                  <a:srgbClr val="5C4A38"/>
+                  <a:srgbClr val="48544C"/>
                 </a:solidFill>
                 <a:latin typeface="Microsoft JhengHei" pitchFamily="34" charset="0"/>
                 <a:ea typeface="Microsoft JhengHei" pitchFamily="34" charset="-122"/>
@@ -6761,7 +6722,7 @@
             <a:r>
               <a:rPr lang="en-US" sz="1300" dirty="0">
                 <a:solidFill>
-                  <a:srgbClr val="5C4A38"/>
+                  <a:srgbClr val="48544C"/>
                 </a:solidFill>
                 <a:latin typeface="Microsoft JhengHei" pitchFamily="34" charset="0"/>
                 <a:ea typeface="Microsoft JhengHei" pitchFamily="34" charset="-122"/>
@@ -6778,7 +6739,7 @@
             <a:r>
               <a:rPr lang="en-US" sz="1300" dirty="0">
                 <a:solidFill>
-                  <a:srgbClr val="5C4A38"/>
+                  <a:srgbClr val="48544C"/>
                 </a:solidFill>
                 <a:latin typeface="Microsoft JhengHei" pitchFamily="34" charset="0"/>
                 <a:ea typeface="Microsoft JhengHei" pitchFamily="34" charset="-122"/>
@@ -6856,7 +6817,7 @@
             <a:r>
               <a:rPr lang="en-US" sz="1300" dirty="0">
                 <a:solidFill>
-                  <a:srgbClr val="5C4A38"/>
+                  <a:srgbClr val="48544C"/>
                 </a:solidFill>
                 <a:latin typeface="Microsoft JhengHei" pitchFamily="34" charset="0"/>
                 <a:ea typeface="Microsoft JhengHei" pitchFamily="34" charset="-122"/>
@@ -6873,7 +6834,7 @@
             <a:r>
               <a:rPr lang="en-US" sz="1300" dirty="0">
                 <a:solidFill>
-                  <a:srgbClr val="5C4A38"/>
+                  <a:srgbClr val="48544C"/>
                 </a:solidFill>
                 <a:latin typeface="Microsoft JhengHei" pitchFamily="34" charset="0"/>
                 <a:ea typeface="Microsoft JhengHei" pitchFamily="34" charset="-122"/>
@@ -6978,7 +6939,7 @@
             <a:r>
               <a:rPr lang="en-US" sz="1300" dirty="0">
                 <a:solidFill>
-                  <a:srgbClr val="2A2218"/>
+                  <a:srgbClr val="1E2620"/>
                 </a:solidFill>
                 <a:latin typeface="Microsoft JhengHei" pitchFamily="34" charset="0"/>
                 <a:ea typeface="Microsoft JhengHei" pitchFamily="34" charset="-122"/>
@@ -6995,7 +6956,7 @@
             <a:r>
               <a:rPr lang="en-US" sz="1300" dirty="0">
                 <a:solidFill>
-                  <a:srgbClr val="2A2218"/>
+                  <a:srgbClr val="1E2620"/>
                 </a:solidFill>
                 <a:latin typeface="Microsoft JhengHei" pitchFamily="34" charset="0"/>
                 <a:ea typeface="Microsoft JhengHei" pitchFamily="34" charset="-122"/>
@@ -7012,7 +6973,7 @@
             <a:r>
               <a:rPr lang="en-US" sz="1300" dirty="0">
                 <a:solidFill>
-                  <a:srgbClr val="2A2218"/>
+                  <a:srgbClr val="1E2620"/>
                 </a:solidFill>
                 <a:latin typeface="Microsoft JhengHei" pitchFamily="34" charset="0"/>
                 <a:ea typeface="Microsoft JhengHei" pitchFamily="34" charset="-122"/>
@@ -7117,7 +7078,7 @@
             <a:r>
               <a:rPr lang="en-US" sz="1300" dirty="0">
                 <a:solidFill>
-                  <a:srgbClr val="2A2218"/>
+                  <a:srgbClr val="1E2620"/>
                 </a:solidFill>
                 <a:latin typeface="Microsoft JhengHei" pitchFamily="34" charset="0"/>
                 <a:ea typeface="Microsoft JhengHei" pitchFamily="34" charset="-122"/>
@@ -7134,7 +7095,7 @@
             <a:r>
               <a:rPr lang="en-US" sz="1300" dirty="0">
                 <a:solidFill>
-                  <a:srgbClr val="2A2218"/>
+                  <a:srgbClr val="1E2620"/>
                 </a:solidFill>
                 <a:latin typeface="Microsoft JhengHei" pitchFamily="34" charset="0"/>
                 <a:ea typeface="Microsoft JhengHei" pitchFamily="34" charset="-122"/>
@@ -7151,7 +7112,7 @@
             <a:r>
               <a:rPr lang="en-US" sz="1300" dirty="0">
                 <a:solidFill>
-                  <a:srgbClr val="2A2218"/>
+                  <a:srgbClr val="1E2620"/>
                 </a:solidFill>
                 <a:latin typeface="Microsoft JhengHei" pitchFamily="34" charset="0"/>
                 <a:ea typeface="Microsoft JhengHei" pitchFamily="34" charset="-122"/>
@@ -7190,7 +7151,7 @@
             <a:r>
               <a:rPr lang="en-US" sz="1100" dirty="0">
                 <a:solidFill>
-                  <a:srgbClr val="5C4A38"/>
+                  <a:srgbClr val="48544C"/>
                 </a:solidFill>
                 <a:latin typeface="Georgia" pitchFamily="34" charset="0"/>
                 <a:ea typeface="Georgia" pitchFamily="34" charset="-122"/>
@@ -7242,11 +7203,11 @@
             <a:avLst/>
           </a:prstGeom>
           <a:solidFill>
-            <a:srgbClr val="F3E6D0"/>
+            <a:srgbClr val="F8FAF7"/>
           </a:solidFill>
           <a:ln w="12700">
             <a:solidFill>
-              <a:srgbClr val="F3E6D0"/>
+              <a:srgbClr val="F8FAF7"/>
             </a:solidFill>
             <a:prstDash val="solid"/>
           </a:ln>
@@ -7268,7 +7229,7 @@
           </a:prstGeom>
           <a:ln w="12700">
             <a:solidFill>
-              <a:srgbClr val="2A2218">
+              <a:srgbClr val="1E2620">
                 <a:alpha val="30000"/>
               </a:srgbClr>
             </a:solidFill>
@@ -7367,7 +7328,7 @@
             <a:r>
               <a:rPr lang="en-US" sz="2600" b="1" dirty="0">
                 <a:solidFill>
-                  <a:srgbClr val="2A2218"/>
+                  <a:srgbClr val="1E2620"/>
                 </a:solidFill>
                 <a:latin typeface="Microsoft JhengHei" pitchFamily="34" charset="0"/>
                 <a:ea typeface="Microsoft JhengHei" pitchFamily="34" charset="-122"/>
@@ -7406,7 +7367,7 @@
             <a:r>
               <a:rPr lang="en-US" sz="1400" dirty="0">
                 <a:solidFill>
-                  <a:srgbClr val="5C4A38"/>
+                  <a:srgbClr val="48544C"/>
                 </a:solidFill>
                 <a:latin typeface="Microsoft JhengHei" pitchFamily="34" charset="0"/>
                 <a:ea typeface="Microsoft JhengHei" pitchFamily="34" charset="-122"/>
@@ -7435,7 +7396,7 @@
             </a:avLst>
           </a:prstGeom>
           <a:solidFill>
-            <a:srgbClr val="FFF8EB"/>
+            <a:srgbClr val="F0F4EF"/>
           </a:solidFill>
           <a:ln w="15875">
             <a:solidFill>
@@ -7511,7 +7472,7 @@
             <a:r>
               <a:rPr lang="en-US" sz="1800" b="1" dirty="0">
                 <a:solidFill>
-                  <a:srgbClr val="2A2218"/>
+                  <a:srgbClr val="1E2620"/>
                 </a:solidFill>
                 <a:latin typeface="Microsoft JhengHei" pitchFamily="34" charset="0"/>
                 <a:ea typeface="Microsoft JhengHei" pitchFamily="34" charset="-122"/>
@@ -7550,7 +7511,7 @@
             <a:r>
               <a:rPr lang="en-US" sz="1300" dirty="0">
                 <a:solidFill>
-                  <a:srgbClr val="5C4A38"/>
+                  <a:srgbClr val="48544C"/>
                 </a:solidFill>
                 <a:latin typeface="Microsoft JhengHei" pitchFamily="34" charset="0"/>
                 <a:ea typeface="Microsoft JhengHei" pitchFamily="34" charset="-122"/>
@@ -7579,7 +7540,7 @@
             </a:avLst>
           </a:prstGeom>
           <a:solidFill>
-            <a:srgbClr val="FFF8EB"/>
+            <a:srgbClr val="F0F4EF"/>
           </a:solidFill>
           <a:ln w="15875">
             <a:solidFill>
@@ -7655,7 +7616,7 @@
             <a:r>
               <a:rPr lang="en-US" sz="1800" b="1" dirty="0">
                 <a:solidFill>
-                  <a:srgbClr val="2A2218"/>
+                  <a:srgbClr val="1E2620"/>
                 </a:solidFill>
                 <a:latin typeface="Microsoft JhengHei" pitchFamily="34" charset="0"/>
                 <a:ea typeface="Microsoft JhengHei" pitchFamily="34" charset="-122"/>
@@ -7694,7 +7655,7 @@
             <a:r>
               <a:rPr lang="en-US" sz="1300" dirty="0">
                 <a:solidFill>
-                  <a:srgbClr val="5C4A38"/>
+                  <a:srgbClr val="48544C"/>
                 </a:solidFill>
                 <a:latin typeface="Microsoft JhengHei" pitchFamily="34" charset="0"/>
                 <a:ea typeface="Microsoft JhengHei" pitchFamily="34" charset="-122"/>
@@ -7723,7 +7684,7 @@
             </a:avLst>
           </a:prstGeom>
           <a:solidFill>
-            <a:srgbClr val="FFF8EB"/>
+            <a:srgbClr val="F0F4EF"/>
           </a:solidFill>
           <a:ln w="15875">
             <a:solidFill>
@@ -7799,7 +7760,7 @@
             <a:r>
               <a:rPr lang="en-US" sz="1800" b="1" dirty="0">
                 <a:solidFill>
-                  <a:srgbClr val="2A2218"/>
+                  <a:srgbClr val="1E2620"/>
                 </a:solidFill>
                 <a:latin typeface="Microsoft JhengHei" pitchFamily="34" charset="0"/>
                 <a:ea typeface="Microsoft JhengHei" pitchFamily="34" charset="-122"/>
@@ -7838,7 +7799,7 @@
             <a:r>
               <a:rPr lang="en-US" sz="1300" dirty="0">
                 <a:solidFill>
-                  <a:srgbClr val="5C4A38"/>
+                  <a:srgbClr val="48544C"/>
                 </a:solidFill>
                 <a:latin typeface="Microsoft JhengHei" pitchFamily="34" charset="0"/>
                 <a:ea typeface="Microsoft JhengHei" pitchFamily="34" charset="-122"/>
@@ -7867,7 +7828,7 @@
             </a:avLst>
           </a:prstGeom>
           <a:solidFill>
-            <a:srgbClr val="FFF8EB"/>
+            <a:srgbClr val="F0F4EF"/>
           </a:solidFill>
           <a:ln w="15875">
             <a:solidFill>
@@ -7943,7 +7904,7 @@
             <a:r>
               <a:rPr lang="en-US" sz="1800" b="1" dirty="0">
                 <a:solidFill>
-                  <a:srgbClr val="2A2218"/>
+                  <a:srgbClr val="1E2620"/>
                 </a:solidFill>
                 <a:latin typeface="Microsoft JhengHei" pitchFamily="34" charset="0"/>
                 <a:ea typeface="Microsoft JhengHei" pitchFamily="34" charset="-122"/>
@@ -7982,7 +7943,7 @@
             <a:r>
               <a:rPr lang="en-US" sz="1300" dirty="0">
                 <a:solidFill>
-                  <a:srgbClr val="5C4A38"/>
+                  <a:srgbClr val="48544C"/>
                 </a:solidFill>
                 <a:latin typeface="Microsoft JhengHei" pitchFamily="34" charset="0"/>
                 <a:ea typeface="Microsoft JhengHei" pitchFamily="34" charset="-122"/>
@@ -8021,7 +7982,7 @@
             <a:r>
               <a:rPr lang="en-US" sz="1100" dirty="0">
                 <a:solidFill>
-                  <a:srgbClr val="5C4A38"/>
+                  <a:srgbClr val="48544C"/>
                 </a:solidFill>
                 <a:latin typeface="Georgia" pitchFamily="34" charset="0"/>
                 <a:ea typeface="Georgia" pitchFamily="34" charset="-122"/>
@@ -8073,11 +8034,11 @@
             <a:avLst/>
           </a:prstGeom>
           <a:solidFill>
-            <a:srgbClr val="F3E6D0"/>
+            <a:srgbClr val="F8FAF7"/>
           </a:solidFill>
           <a:ln w="12700">
             <a:solidFill>
-              <a:srgbClr val="F3E6D0"/>
+              <a:srgbClr val="F8FAF7"/>
             </a:solidFill>
             <a:prstDash val="solid"/>
           </a:ln>
@@ -8099,7 +8060,7 @@
           </a:prstGeom>
           <a:ln w="12700">
             <a:solidFill>
-              <a:srgbClr val="2A2218">
+              <a:srgbClr val="1E2620">
                 <a:alpha val="30000"/>
               </a:srgbClr>
             </a:solidFill>
@@ -8198,7 +8159,7 @@
             <a:r>
               <a:rPr lang="en-US" sz="2600" b="1" dirty="0">
                 <a:solidFill>
-                  <a:srgbClr val="2A2218"/>
+                  <a:srgbClr val="1E2620"/>
                 </a:solidFill>
                 <a:latin typeface="Microsoft JhengHei" pitchFamily="34" charset="0"/>
                 <a:ea typeface="Microsoft JhengHei" pitchFamily="34" charset="-122"/>
@@ -8237,7 +8198,7 @@
             <a:r>
               <a:rPr lang="en-US" sz="1400" dirty="0">
                 <a:solidFill>
-                  <a:srgbClr val="5C4A38"/>
+                  <a:srgbClr val="48544C"/>
                 </a:solidFill>
                 <a:latin typeface="Microsoft JhengHei" pitchFamily="34" charset="0"/>
                 <a:ea typeface="Microsoft JhengHei" pitchFamily="34" charset="-122"/>
@@ -8266,7 +8227,7 @@
             </a:avLst>
           </a:prstGeom>
           <a:solidFill>
-            <a:srgbClr val="FFF8EB"/>
+            <a:srgbClr val="F0F4EF"/>
           </a:solidFill>
           <a:ln w="15875">
             <a:solidFill>
@@ -8364,7 +8325,7 @@
             <a:r>
               <a:rPr lang="en-US" sz="1800" b="1" dirty="0">
                 <a:solidFill>
-                  <a:srgbClr val="2A2218"/>
+                  <a:srgbClr val="1E2620"/>
                 </a:solidFill>
                 <a:latin typeface="Microsoft JhengHei" pitchFamily="34" charset="0"/>
                 <a:ea typeface="Microsoft JhengHei" pitchFamily="34" charset="-122"/>
@@ -8403,7 +8364,7 @@
             <a:r>
               <a:rPr lang="en-US" sz="1300" dirty="0">
                 <a:solidFill>
-                  <a:srgbClr val="5C4A38"/>
+                  <a:srgbClr val="48544C"/>
                 </a:solidFill>
                 <a:latin typeface="Microsoft JhengHei" pitchFamily="34" charset="0"/>
                 <a:ea typeface="Microsoft JhengHei" pitchFamily="34" charset="-122"/>
@@ -8471,7 +8432,7 @@
             </a:avLst>
           </a:prstGeom>
           <a:solidFill>
-            <a:srgbClr val="FFF8EB"/>
+            <a:srgbClr val="F0F4EF"/>
           </a:solidFill>
           <a:ln w="15875">
             <a:solidFill>
@@ -8569,7 +8530,7 @@
             <a:r>
               <a:rPr lang="en-US" sz="1800" b="1" dirty="0">
                 <a:solidFill>
-                  <a:srgbClr val="2A2218"/>
+                  <a:srgbClr val="1E2620"/>
                 </a:solidFill>
                 <a:latin typeface="Microsoft JhengHei" pitchFamily="34" charset="0"/>
                 <a:ea typeface="Microsoft JhengHei" pitchFamily="34" charset="-122"/>
@@ -8608,7 +8569,7 @@
             <a:r>
               <a:rPr lang="en-US" sz="1300" dirty="0">
                 <a:solidFill>
-                  <a:srgbClr val="5C4A38"/>
+                  <a:srgbClr val="48544C"/>
                 </a:solidFill>
                 <a:latin typeface="Microsoft JhengHei" pitchFamily="34" charset="0"/>
                 <a:ea typeface="Microsoft JhengHei" pitchFamily="34" charset="-122"/>
@@ -8676,7 +8637,7 @@
             </a:avLst>
           </a:prstGeom>
           <a:solidFill>
-            <a:srgbClr val="FFF8EB"/>
+            <a:srgbClr val="F0F4EF"/>
           </a:solidFill>
           <a:ln w="15875">
             <a:solidFill>
@@ -8774,7 +8735,7 @@
             <a:r>
               <a:rPr lang="en-US" sz="1800" b="1" dirty="0">
                 <a:solidFill>
-                  <a:srgbClr val="2A2218"/>
+                  <a:srgbClr val="1E2620"/>
                 </a:solidFill>
                 <a:latin typeface="Microsoft JhengHei" pitchFamily="34" charset="0"/>
                 <a:ea typeface="Microsoft JhengHei" pitchFamily="34" charset="-122"/>
@@ -8813,7 +8774,7 @@
             <a:r>
               <a:rPr lang="en-US" sz="1300" dirty="0">
                 <a:solidFill>
-                  <a:srgbClr val="5C4A38"/>
+                  <a:srgbClr val="48544C"/>
                 </a:solidFill>
                 <a:latin typeface="Microsoft JhengHei" pitchFamily="34" charset="0"/>
                 <a:ea typeface="Microsoft JhengHei" pitchFamily="34" charset="-122"/>
@@ -8891,7 +8852,7 @@
             <a:r>
               <a:rPr lang="en-US" sz="1100" dirty="0">
                 <a:solidFill>
-                  <a:srgbClr val="5C4A38"/>
+                  <a:srgbClr val="48544C"/>
                 </a:solidFill>
                 <a:latin typeface="Georgia" pitchFamily="34" charset="0"/>
                 <a:ea typeface="Georgia" pitchFamily="34" charset="-122"/>
@@ -8943,11 +8904,11 @@
             <a:avLst/>
           </a:prstGeom>
           <a:solidFill>
-            <a:srgbClr val="F3E6D0"/>
+            <a:srgbClr val="F8FAF7"/>
           </a:solidFill>
           <a:ln w="12700">
             <a:solidFill>
-              <a:srgbClr val="F3E6D0"/>
+              <a:srgbClr val="F8FAF7"/>
             </a:solidFill>
             <a:prstDash val="solid"/>
           </a:ln>
@@ -8969,7 +8930,7 @@
           </a:prstGeom>
           <a:ln w="12700">
             <a:solidFill>
-              <a:srgbClr val="2A2218">
+              <a:srgbClr val="1E2620">
                 <a:alpha val="30000"/>
               </a:srgbClr>
             </a:solidFill>
@@ -9068,7 +9029,7 @@
             <a:r>
               <a:rPr lang="en-US" sz="2600" b="1" dirty="0">
                 <a:solidFill>
-                  <a:srgbClr val="2A2218"/>
+                  <a:srgbClr val="1E2620"/>
                 </a:solidFill>
                 <a:latin typeface="Microsoft JhengHei" pitchFamily="34" charset="0"/>
                 <a:ea typeface="Microsoft JhengHei" pitchFamily="34" charset="-122"/>
@@ -9107,7 +9068,7 @@
             <a:r>
               <a:rPr lang="en-US" sz="1400" dirty="0">
                 <a:solidFill>
-                  <a:srgbClr val="5C4A38"/>
+                  <a:srgbClr val="48544C"/>
                 </a:solidFill>
                 <a:latin typeface="Microsoft JhengHei" pitchFamily="34" charset="0"/>
                 <a:ea typeface="Microsoft JhengHei" pitchFamily="34" charset="-122"/>
@@ -9136,7 +9097,7 @@
             </a:avLst>
           </a:prstGeom>
           <a:solidFill>
-            <a:srgbClr val="FFF8EB"/>
+            <a:srgbClr val="F0F4EF"/>
           </a:solidFill>
           <a:ln w="15875">
             <a:solidFill>
@@ -9212,7 +9173,7 @@
             <a:r>
               <a:rPr lang="en-US" sz="1800" b="1" dirty="0">
                 <a:solidFill>
-                  <a:srgbClr val="2A2218"/>
+                  <a:srgbClr val="1E2620"/>
                 </a:solidFill>
                 <a:latin typeface="Microsoft JhengHei" pitchFamily="34" charset="0"/>
                 <a:ea typeface="Microsoft JhengHei" pitchFamily="34" charset="-122"/>
@@ -9251,7 +9212,7 @@
             <a:r>
               <a:rPr lang="en-US" sz="1300" dirty="0">
                 <a:solidFill>
-                  <a:srgbClr val="5C4A38"/>
+                  <a:srgbClr val="48544C"/>
                 </a:solidFill>
                 <a:latin typeface="Microsoft JhengHei" pitchFamily="34" charset="0"/>
                 <a:ea typeface="Microsoft JhengHei" pitchFamily="34" charset="-122"/>
@@ -9341,7 +9302,7 @@
             </a:avLst>
           </a:prstGeom>
           <a:solidFill>
-            <a:srgbClr val="FFF8EB"/>
+            <a:srgbClr val="F0F4EF"/>
           </a:solidFill>
           <a:ln w="15875">
             <a:solidFill>
@@ -9417,7 +9378,7 @@
             <a:r>
               <a:rPr lang="en-US" sz="1800" b="1" dirty="0">
                 <a:solidFill>
-                  <a:srgbClr val="2A2218"/>
+                  <a:srgbClr val="1E2620"/>
                 </a:solidFill>
                 <a:latin typeface="Microsoft JhengHei" pitchFamily="34" charset="0"/>
                 <a:ea typeface="Microsoft JhengHei" pitchFamily="34" charset="-122"/>
@@ -9456,7 +9417,7 @@
             <a:r>
               <a:rPr lang="en-US" sz="1300" dirty="0">
                 <a:solidFill>
-                  <a:srgbClr val="5C4A38"/>
+                  <a:srgbClr val="48544C"/>
                 </a:solidFill>
                 <a:latin typeface="Microsoft JhengHei" pitchFamily="34" charset="0"/>
                 <a:ea typeface="Microsoft JhengHei" pitchFamily="34" charset="-122"/>
@@ -9546,7 +9507,7 @@
             </a:avLst>
           </a:prstGeom>
           <a:solidFill>
-            <a:srgbClr val="FFF8EB"/>
+            <a:srgbClr val="F0F4EF"/>
           </a:solidFill>
           <a:ln w="15875">
             <a:solidFill>
@@ -9622,7 +9583,7 @@
             <a:r>
               <a:rPr lang="en-US" sz="1800" b="1" dirty="0">
                 <a:solidFill>
-                  <a:srgbClr val="2A2218"/>
+                  <a:srgbClr val="1E2620"/>
                 </a:solidFill>
                 <a:latin typeface="Microsoft JhengHei" pitchFamily="34" charset="0"/>
                 <a:ea typeface="Microsoft JhengHei" pitchFamily="34" charset="-122"/>
@@ -9661,7 +9622,7 @@
             <a:r>
               <a:rPr lang="en-US" sz="1300" dirty="0">
                 <a:solidFill>
-                  <a:srgbClr val="5C4A38"/>
+                  <a:srgbClr val="48544C"/>
                 </a:solidFill>
                 <a:latin typeface="Microsoft JhengHei" pitchFamily="34" charset="0"/>
                 <a:ea typeface="Microsoft JhengHei" pitchFamily="34" charset="-122"/>
@@ -9761,7 +9722,7 @@
             <a:r>
               <a:rPr lang="en-US" sz="1100" dirty="0">
                 <a:solidFill>
-                  <a:srgbClr val="5C4A38"/>
+                  <a:srgbClr val="48544C"/>
                 </a:solidFill>
                 <a:latin typeface="Georgia" pitchFamily="34" charset="0"/>
                 <a:ea typeface="Georgia" pitchFamily="34" charset="-122"/>
@@ -9813,11 +9774,11 @@
             <a:avLst/>
           </a:prstGeom>
           <a:solidFill>
-            <a:srgbClr val="F3E6D0"/>
+            <a:srgbClr val="F8FAF7"/>
           </a:solidFill>
           <a:ln w="12700">
             <a:solidFill>
-              <a:srgbClr val="F3E6D0"/>
+              <a:srgbClr val="F8FAF7"/>
             </a:solidFill>
             <a:prstDash val="solid"/>
           </a:ln>
@@ -9839,7 +9800,7 @@
           </a:prstGeom>
           <a:ln w="12700">
             <a:solidFill>
-              <a:srgbClr val="2A2218">
+              <a:srgbClr val="1E2620">
                 <a:alpha val="30000"/>
               </a:srgbClr>
             </a:solidFill>
@@ -9862,11 +9823,11 @@
             <a:avLst/>
           </a:prstGeom>
           <a:solidFill>
-            <a:srgbClr val="5C4A38"/>
+            <a:srgbClr val="48544C"/>
           </a:solidFill>
           <a:ln w="12700">
             <a:solidFill>
-              <a:srgbClr val="5C4A38"/>
+              <a:srgbClr val="48544C"/>
             </a:solidFill>
             <a:prstDash val="solid"/>
           </a:ln>
@@ -9899,7 +9860,7 @@
             <a:r>
               <a:rPr lang="en-US" sz="1400" b="1" dirty="0">
                 <a:solidFill>
-                  <a:srgbClr val="5C4A38"/>
+                  <a:srgbClr val="48544C"/>
                 </a:solidFill>
                 <a:latin typeface="Georgia" pitchFamily="34" charset="0"/>
                 <a:ea typeface="Georgia" pitchFamily="34" charset="-122"/>
@@ -9938,7 +9899,7 @@
             <a:r>
               <a:rPr lang="en-US" sz="2600" b="1" dirty="0">
                 <a:solidFill>
-                  <a:srgbClr val="2A2218"/>
+                  <a:srgbClr val="1E2620"/>
                 </a:solidFill>
                 <a:latin typeface="Microsoft JhengHei" pitchFamily="34" charset="0"/>
                 <a:ea typeface="Microsoft JhengHei" pitchFamily="34" charset="-122"/>
@@ -9977,7 +9938,7 @@
             <a:r>
               <a:rPr lang="en-US" sz="1400" dirty="0">
                 <a:solidFill>
-                  <a:srgbClr val="5C4A38"/>
+                  <a:srgbClr val="48544C"/>
                 </a:solidFill>
                 <a:latin typeface="Microsoft JhengHei" pitchFamily="34" charset="0"/>
                 <a:ea typeface="Microsoft JhengHei" pitchFamily="34" charset="-122"/>
@@ -10004,11 +9965,11 @@
             <a:avLst/>
           </a:prstGeom>
           <a:solidFill>
-            <a:srgbClr val="2A2218"/>
+            <a:srgbClr val="1E2620"/>
           </a:solidFill>
           <a:ln w="12700">
             <a:solidFill>
-              <a:srgbClr val="2A2218"/>
+              <a:srgbClr val="1E2620"/>
             </a:solidFill>
             <a:prstDash val="solid"/>
           </a:ln>
@@ -10041,7 +10002,7 @@
             <a:r>
               <a:rPr lang="en-US" sz="2200" b="1" dirty="0">
                 <a:solidFill>
-                  <a:srgbClr val="F3E6D0"/>
+                  <a:srgbClr val="F8FAF7"/>
                 </a:solidFill>
                 <a:latin typeface="Georgia" pitchFamily="34" charset="0"/>
                 <a:ea typeface="Georgia" pitchFamily="34" charset="-122"/>
@@ -10070,7 +10031,7 @@
           <a:noFill/>
           <a:ln w="19050">
             <a:solidFill>
-              <a:srgbClr val="2A2218">
+              <a:srgbClr val="1E2620">
                 <a:alpha val="60000"/>
               </a:srgbClr>
             </a:solidFill>
@@ -10144,7 +10105,7 @@
             <a:r>
               <a:rPr lang="en-US" sz="1800" b="1" dirty="0">
                 <a:solidFill>
-                  <a:srgbClr val="2A2218"/>
+                  <a:srgbClr val="1E2620"/>
                 </a:solidFill>
                 <a:latin typeface="Microsoft JhengHei" pitchFamily="34" charset="0"/>
                 <a:ea typeface="Microsoft JhengHei" pitchFamily="34" charset="-122"/>
@@ -10183,7 +10144,7 @@
             <a:r>
               <a:rPr lang="en-US" sz="1300" dirty="0">
                 <a:solidFill>
-                  <a:srgbClr val="5C4A38"/>
+                  <a:srgbClr val="48544C"/>
                 </a:solidFill>
                 <a:latin typeface="Microsoft JhengHei" pitchFamily="34" charset="0"/>
                 <a:ea typeface="Microsoft JhengHei" pitchFamily="34" charset="-122"/>
@@ -10210,11 +10171,11 @@
             <a:avLst/>
           </a:prstGeom>
           <a:solidFill>
-            <a:srgbClr val="2A2218"/>
+            <a:srgbClr val="1E2620"/>
           </a:solidFill>
           <a:ln w="12700">
             <a:solidFill>
-              <a:srgbClr val="2A2218"/>
+              <a:srgbClr val="1E2620"/>
             </a:solidFill>
             <a:prstDash val="solid"/>
           </a:ln>
@@ -10247,7 +10208,7 @@
             <a:r>
               <a:rPr lang="en-US" sz="2200" b="1" dirty="0">
                 <a:solidFill>
-                  <a:srgbClr val="F3E6D0"/>
+                  <a:srgbClr val="F8FAF7"/>
                 </a:solidFill>
                 <a:latin typeface="Georgia" pitchFamily="34" charset="0"/>
                 <a:ea typeface="Georgia" pitchFamily="34" charset="-122"/>
@@ -10276,7 +10237,7 @@
           <a:noFill/>
           <a:ln w="19050">
             <a:solidFill>
-              <a:srgbClr val="2A2218">
+              <a:srgbClr val="1E2620">
                 <a:alpha val="60000"/>
               </a:srgbClr>
             </a:solidFill>
@@ -10350,7 +10311,7 @@
             <a:r>
               <a:rPr lang="en-US" sz="1800" b="1" dirty="0">
                 <a:solidFill>
-                  <a:srgbClr val="2A2218"/>
+                  <a:srgbClr val="1E2620"/>
                 </a:solidFill>
                 <a:latin typeface="Microsoft JhengHei" pitchFamily="34" charset="0"/>
                 <a:ea typeface="Microsoft JhengHei" pitchFamily="34" charset="-122"/>
@@ -10389,7 +10350,7 @@
             <a:r>
               <a:rPr lang="en-US" sz="1300" dirty="0">
                 <a:solidFill>
-                  <a:srgbClr val="5C4A38"/>
+                  <a:srgbClr val="48544C"/>
                 </a:solidFill>
                 <a:latin typeface="Microsoft JhengHei" pitchFamily="34" charset="0"/>
                 <a:ea typeface="Microsoft JhengHei" pitchFamily="34" charset="-122"/>
@@ -10416,11 +10377,11 @@
             <a:avLst/>
           </a:prstGeom>
           <a:solidFill>
-            <a:srgbClr val="2A2218"/>
+            <a:srgbClr val="1E2620"/>
           </a:solidFill>
           <a:ln w="12700">
             <a:solidFill>
-              <a:srgbClr val="2A2218"/>
+              <a:srgbClr val="1E2620"/>
             </a:solidFill>
             <a:prstDash val="solid"/>
           </a:ln>
@@ -10453,7 +10414,7 @@
             <a:r>
               <a:rPr lang="en-US" sz="2200" b="1" dirty="0">
                 <a:solidFill>
-                  <a:srgbClr val="F3E6D0"/>
+                  <a:srgbClr val="F8FAF7"/>
                 </a:solidFill>
                 <a:latin typeface="Georgia" pitchFamily="34" charset="0"/>
                 <a:ea typeface="Georgia" pitchFamily="34" charset="-122"/>
@@ -10531,7 +10492,7 @@
             <a:r>
               <a:rPr lang="en-US" sz="1800" b="1" dirty="0">
                 <a:solidFill>
-                  <a:srgbClr val="2A2218"/>
+                  <a:srgbClr val="1E2620"/>
                 </a:solidFill>
                 <a:latin typeface="Microsoft JhengHei" pitchFamily="34" charset="0"/>
                 <a:ea typeface="Microsoft JhengHei" pitchFamily="34" charset="-122"/>
@@ -10570,7 +10531,7 @@
             <a:r>
               <a:rPr lang="en-US" sz="1300" dirty="0">
                 <a:solidFill>
-                  <a:srgbClr val="5C4A38"/>
+                  <a:srgbClr val="48544C"/>
                 </a:solidFill>
                 <a:latin typeface="Microsoft JhengHei" pitchFamily="34" charset="0"/>
                 <a:ea typeface="Microsoft JhengHei" pitchFamily="34" charset="-122"/>
@@ -10599,7 +10560,7 @@
             </a:avLst>
           </a:prstGeom>
           <a:solidFill>
-            <a:srgbClr val="1F1810"/>
+            <a:srgbClr val="1E2620"/>
           </a:solidFill>
           <a:ln/>
         </p:spPr>
@@ -10631,7 +10592,7 @@
             <a:r>
               <a:rPr lang="en-US" sz="1600" b="1" dirty="0">
                 <a:solidFill>
-                  <a:srgbClr val="F3E6D0"/>
+                  <a:srgbClr val="F8FAF7"/>
                 </a:solidFill>
                 <a:latin typeface="Microsoft JhengHei" pitchFamily="34" charset="0"/>
                 <a:ea typeface="Microsoft JhengHei" pitchFamily="34" charset="-122"/>
@@ -10670,7 +10631,7 @@
             <a:r>
               <a:rPr lang="en-US" sz="1100" dirty="0">
                 <a:solidFill>
-                  <a:srgbClr val="5C4A38"/>
+                  <a:srgbClr val="48544C"/>
                 </a:solidFill>
                 <a:latin typeface="Georgia" pitchFamily="34" charset="0"/>
                 <a:ea typeface="Georgia" pitchFamily="34" charset="-122"/>

</xml_diff>

<commit_message>
Embed all high quality real spot photos directly into download files (PPTX slides & Pocket Map folded sheet)
</commit_message>
<xml_diff>
--- a/itinerary.pptx
+++ b/itinerary.pptx
@@ -4459,7 +4459,7 @@
         <p:spPr>
           <a:xfrm>
             <a:off x="1051560" y="1691640"/>
-            <a:ext cx="2011680" cy="320040"/>
+            <a:ext cx="1645920" cy="320040"/>
           </a:xfrm>
           <a:prstGeom prst="rect">
             <a:avLst/>
@@ -4475,7 +4475,7 @@
               <a:buNone/>
             </a:pPr>
             <a:r>
-              <a:rPr lang="en-US" sz="1600" b="1" dirty="0">
+              <a:rPr lang="en-US" sz="1500" b="1" dirty="0">
                 <a:solidFill>
                   <a:srgbClr val="C23B22"/>
                 </a:solidFill>
@@ -4485,7 +4485,7 @@
               </a:rPr>
               <a:t>12:05</a:t>
             </a:r>
-            <a:endParaRPr lang="en-US" sz="1600" dirty="0"/>
+            <a:endParaRPr lang="en-US" sz="1500" dirty="0"/>
           </a:p>
         </p:txBody>
       </p:sp>
@@ -4497,8 +4497,8 @@
         </p:nvSpPr>
         <p:spPr>
           <a:xfrm>
-            <a:off x="3108960" y="1691640"/>
-            <a:ext cx="8412480" cy="320040"/>
+            <a:off x="2743200" y="1691640"/>
+            <a:ext cx="4389120" cy="320040"/>
           </a:xfrm>
           <a:prstGeom prst="rect">
             <a:avLst/>
@@ -4514,7 +4514,7 @@
               <a:buNone/>
             </a:pPr>
             <a:r>
-              <a:rPr lang="en-US" sz="1600" b="1" dirty="0">
+              <a:rPr lang="en-US" sz="1500" b="1" dirty="0">
                 <a:solidFill>
                   <a:srgbClr val="1E2620"/>
                 </a:solidFill>
@@ -4524,7 +4524,7 @@
               </a:rPr>
               <a:t>關西國際機場（KIX）降落</a:t>
             </a:r>
-            <a:endParaRPr lang="en-US" sz="1600" dirty="0"/>
+            <a:endParaRPr lang="en-US" sz="1500" dirty="0"/>
           </a:p>
         </p:txBody>
       </p:sp>
@@ -4536,8 +4536,8 @@
         </p:nvSpPr>
         <p:spPr>
           <a:xfrm>
-            <a:off x="3108960" y="2039112"/>
-            <a:ext cx="8412480" cy="411480"/>
+            <a:off x="2743200" y="2039112"/>
+            <a:ext cx="4389120" cy="411480"/>
           </a:xfrm>
           <a:prstGeom prst="rect">
             <a:avLst/>
@@ -4553,7 +4553,7 @@
               <a:buNone/>
             </a:pPr>
             <a:r>
-              <a:rPr lang="en-US" sz="1300" dirty="0">
+              <a:rPr lang="en-US" sz="1200" dirty="0">
                 <a:solidFill>
                   <a:srgbClr val="48544C"/>
                 </a:solidFill>
@@ -4563,7 +4563,7 @@
               </a:rPr>
               <a:t>出關、提取行李。保持節奏緩慢，讓寶寶適應環境。</a:t>
             </a:r>
-            <a:endParaRPr lang="en-US" sz="1300" dirty="0"/>
+            <a:endParaRPr lang="en-US" sz="1200" dirty="0"/>
           </a:p>
         </p:txBody>
       </p:sp>
@@ -4626,7 +4626,7 @@
         <p:spPr>
           <a:xfrm>
             <a:off x="1051560" y="2743200"/>
-            <a:ext cx="2011680" cy="320040"/>
+            <a:ext cx="1645920" cy="320040"/>
           </a:xfrm>
           <a:prstGeom prst="rect">
             <a:avLst/>
@@ -4642,7 +4642,7 @@
               <a:buNone/>
             </a:pPr>
             <a:r>
-              <a:rPr lang="en-US" sz="1600" b="1" dirty="0">
+              <a:rPr lang="en-US" sz="1500" b="1" dirty="0">
                 <a:solidFill>
                   <a:srgbClr val="C23B22"/>
                 </a:solidFill>
@@ -4652,7 +4652,7 @@
               </a:rPr>
               <a:t>13:30 前後</a:t>
             </a:r>
-            <a:endParaRPr lang="en-US" sz="1600" dirty="0"/>
+            <a:endParaRPr lang="en-US" sz="1500" dirty="0"/>
           </a:p>
         </p:txBody>
       </p:sp>
@@ -4664,8 +4664,8 @@
         </p:nvSpPr>
         <p:spPr>
           <a:xfrm>
-            <a:off x="3108960" y="2743200"/>
-            <a:ext cx="8412480" cy="320040"/>
+            <a:off x="2743200" y="2743200"/>
+            <a:ext cx="4389120" cy="320040"/>
           </a:xfrm>
           <a:prstGeom prst="rect">
             <a:avLst/>
@@ -4681,7 +4681,7 @@
               <a:buNone/>
             </a:pPr>
             <a:r>
-              <a:rPr lang="en-US" sz="1600" b="1" dirty="0">
+              <a:rPr lang="en-US" sz="1500" b="1" dirty="0">
                 <a:solidFill>
                   <a:srgbClr val="1E2620"/>
                 </a:solidFill>
@@ -4691,7 +4691,7 @@
               </a:rPr>
               <a:t>外派接駁車 D1 · 機場直達飯店</a:t>
             </a:r>
-            <a:endParaRPr lang="en-US" sz="1600" dirty="0"/>
+            <a:endParaRPr lang="en-US" sz="1500" dirty="0"/>
           </a:p>
         </p:txBody>
       </p:sp>
@@ -4703,8 +4703,8 @@
         </p:nvSpPr>
         <p:spPr>
           <a:xfrm>
-            <a:off x="3108960" y="3090672"/>
-            <a:ext cx="8412480" cy="411480"/>
+            <a:off x="2743200" y="3090672"/>
+            <a:ext cx="4389120" cy="411480"/>
           </a:xfrm>
           <a:prstGeom prst="rect">
             <a:avLst/>
@@ -4720,7 +4720,7 @@
               <a:buNone/>
             </a:pPr>
             <a:r>
-              <a:rPr lang="en-US" sz="1300" dirty="0">
+              <a:rPr lang="en-US" sz="1200" dirty="0">
                 <a:solidFill>
                   <a:srgbClr val="48544C"/>
                 </a:solidFill>
@@ -4730,7 +4730,7 @@
               </a:rPr>
               <a:t>專車直達 nol kyoto sanjo。車程約 80–90 分鐘，寶寶於車上休息。</a:t>
             </a:r>
-            <a:endParaRPr lang="en-US" sz="1300" dirty="0"/>
+            <a:endParaRPr lang="en-US" sz="1200" dirty="0"/>
           </a:p>
         </p:txBody>
       </p:sp>
@@ -4793,7 +4793,7 @@
         <p:spPr>
           <a:xfrm>
             <a:off x="1051560" y="3794760"/>
-            <a:ext cx="2011680" cy="320040"/>
+            <a:ext cx="1645920" cy="320040"/>
           </a:xfrm>
           <a:prstGeom prst="rect">
             <a:avLst/>
@@ -4809,7 +4809,7 @@
               <a:buNone/>
             </a:pPr>
             <a:r>
-              <a:rPr lang="en-US" sz="1600" b="1" dirty="0">
+              <a:rPr lang="en-US" sz="1500" b="1" dirty="0">
                 <a:solidFill>
                   <a:srgbClr val="C23B22"/>
                 </a:solidFill>
@@ -4819,7 +4819,7 @@
               </a:rPr>
               <a:t>15:40–16:30</a:t>
             </a:r>
-            <a:endParaRPr lang="en-US" sz="1600" dirty="0"/>
+            <a:endParaRPr lang="en-US" sz="1500" dirty="0"/>
           </a:p>
         </p:txBody>
       </p:sp>
@@ -4831,8 +4831,8 @@
         </p:nvSpPr>
         <p:spPr>
           <a:xfrm>
-            <a:off x="3108960" y="3794760"/>
-            <a:ext cx="8412480" cy="320040"/>
+            <a:off x="2743200" y="3794760"/>
+            <a:ext cx="4389120" cy="320040"/>
           </a:xfrm>
           <a:prstGeom prst="rect">
             <a:avLst/>
@@ -4848,7 +4848,7 @@
               <a:buNone/>
             </a:pPr>
             <a:r>
-              <a:rPr lang="en-US" sz="1600" b="1" dirty="0">
+              <a:rPr lang="en-US" sz="1500" b="1" dirty="0">
                 <a:solidFill>
                   <a:srgbClr val="1E2620"/>
                 </a:solidFill>
@@ -4858,7 +4858,7 @@
               </a:rPr>
               <a:t>【計程車快閃】御金神社參拜</a:t>
             </a:r>
-            <a:endParaRPr lang="en-US" sz="1600" dirty="0"/>
+            <a:endParaRPr lang="en-US" sz="1500" dirty="0"/>
           </a:p>
         </p:txBody>
       </p:sp>
@@ -4870,8 +4870,8 @@
         </p:nvSpPr>
         <p:spPr>
           <a:xfrm>
-            <a:off x="3108960" y="4142232"/>
-            <a:ext cx="8412480" cy="411480"/>
+            <a:off x="2743200" y="4142232"/>
+            <a:ext cx="4389120" cy="411480"/>
           </a:xfrm>
           <a:prstGeom prst="rect">
             <a:avLst/>
@@ -4887,7 +4887,7 @@
               <a:buNone/>
             </a:pPr>
             <a:r>
-              <a:rPr lang="en-US" sz="1300" dirty="0">
+              <a:rPr lang="en-US" sz="1200" dirty="0">
                 <a:solidFill>
                   <a:srgbClr val="48544C"/>
                 </a:solidFill>
@@ -4897,7 +4897,7 @@
               </a:rPr>
               <a:t>飯店門口搭計程車 5 分鐘直達。參拜金山毘古神，17:00 社務所關閉前購入金運御守。</a:t>
             </a:r>
-            <a:endParaRPr lang="en-US" sz="1300" dirty="0"/>
+            <a:endParaRPr lang="en-US" sz="1200" dirty="0"/>
           </a:p>
         </p:txBody>
       </p:sp>
@@ -4935,7 +4935,7 @@
         <p:spPr>
           <a:xfrm>
             <a:off x="1051560" y="4846320"/>
-            <a:ext cx="2011680" cy="320040"/>
+            <a:ext cx="1645920" cy="320040"/>
           </a:xfrm>
           <a:prstGeom prst="rect">
             <a:avLst/>
@@ -4951,7 +4951,7 @@
               <a:buNone/>
             </a:pPr>
             <a:r>
-              <a:rPr lang="en-US" sz="1600" b="1" dirty="0">
+              <a:rPr lang="en-US" sz="1500" b="1" dirty="0">
                 <a:solidFill>
                   <a:srgbClr val="C23B22"/>
                 </a:solidFill>
@@ -4961,7 +4961,7 @@
               </a:rPr>
               <a:t>16:40–17:30</a:t>
             </a:r>
-            <a:endParaRPr lang="en-US" sz="1600" dirty="0"/>
+            <a:endParaRPr lang="en-US" sz="1500" dirty="0"/>
           </a:p>
         </p:txBody>
       </p:sp>
@@ -4973,8 +4973,8 @@
         </p:nvSpPr>
         <p:spPr>
           <a:xfrm>
-            <a:off x="3108960" y="4846320"/>
-            <a:ext cx="8412480" cy="320040"/>
+            <a:off x="2743200" y="4846320"/>
+            <a:ext cx="4389120" cy="320040"/>
           </a:xfrm>
           <a:prstGeom prst="rect">
             <a:avLst/>
@@ -4990,7 +4990,7 @@
               <a:buNone/>
             </a:pPr>
             <a:r>
-              <a:rPr lang="en-US" sz="1600" b="1" dirty="0">
+              <a:rPr lang="en-US" sz="1500" b="1" dirty="0">
                 <a:solidFill>
                   <a:srgbClr val="1E2620"/>
                 </a:solidFill>
@@ -5000,7 +5000,7 @@
               </a:rPr>
               <a:t>HUMAN MADE 1928 &amp; LE LABO</a:t>
             </a:r>
-            <a:endParaRPr lang="en-US" sz="1600" dirty="0"/>
+            <a:endParaRPr lang="en-US" sz="1500" dirty="0"/>
           </a:p>
         </p:txBody>
       </p:sp>
@@ -5012,8 +5012,8 @@
         </p:nvSpPr>
         <p:spPr>
           <a:xfrm>
-            <a:off x="3108960" y="5193792"/>
-            <a:ext cx="8412480" cy="411480"/>
+            <a:off x="2743200" y="5193792"/>
+            <a:ext cx="4389120" cy="411480"/>
           </a:xfrm>
           <a:prstGeom prst="rect">
             <a:avLst/>
@@ -5029,7 +5029,7 @@
               <a:buNone/>
             </a:pPr>
             <a:r>
-              <a:rPr lang="en-US" sz="1300" dirty="0">
+              <a:rPr lang="en-US" sz="1200" dirty="0">
                 <a:solidFill>
                   <a:srgbClr val="48544C"/>
                 </a:solidFill>
@@ -5039,13 +5039,61 @@
               </a:rPr>
               <a:t>HUMAN MADE 1928 Cafe by Blue Bottle Coffee 與 LE LABO KYOTO 美學散步（離飯店 350m）。</a:t>
             </a:r>
-            <a:endParaRPr lang="en-US" sz="1300" dirty="0"/>
-          </a:p>
-        </p:txBody>
-      </p:sp>
-      <p:sp>
-        <p:nvSpPr>
-          <p:cNvPr id="27" name="Text 25"/>
+            <a:endParaRPr lang="en-US" sz="1200" dirty="0"/>
+          </a:p>
+        </p:txBody>
+      </p:sp>
+      <p:pic>
+        <p:nvPicPr>
+          <p:cNvPr id="27" name="Image 0" descr="/Users/maxchan/Desktop/京都大阪親子手繪行程_202608/img/mikane.jpg">    </p:cNvPr>
+          <p:cNvPicPr>
+            <a:picLocks noChangeAspect="1"/>
+          </p:cNvPicPr>
+          <p:nvPr/>
+        </p:nvPicPr>
+        <p:blipFill>
+          <a:blip r:embed="rId1"/>
+          <a:stretch>
+            <a:fillRect/>
+          </a:stretch>
+        </p:blipFill>
+        <p:spPr>
+          <a:xfrm>
+            <a:off x="7315200" y="1691640"/>
+            <a:ext cx="4297680" cy="2103120"/>
+          </a:xfrm>
+          <a:prstGeom prst="rect">
+            <a:avLst/>
+          </a:prstGeom>
+        </p:spPr>
+      </p:pic>
+      <p:pic>
+        <p:nvPicPr>
+          <p:cNvPr id="28" name="Image 1" descr="/Users/maxchan/Desktop/京都大阪親子手繪行程_202608/img/nol_kyoto.jpg">    </p:cNvPr>
+          <p:cNvPicPr>
+            <a:picLocks noChangeAspect="1"/>
+          </p:cNvPicPr>
+          <p:nvPr/>
+        </p:nvPicPr>
+        <p:blipFill>
+          <a:blip r:embed="rId2"/>
+          <a:stretch>
+            <a:fillRect/>
+          </a:stretch>
+        </p:blipFill>
+        <p:spPr>
+          <a:xfrm>
+            <a:off x="7315200" y="3977640"/>
+            <a:ext cx="4297680" cy="2103120"/>
+          </a:xfrm>
+          <a:prstGeom prst="rect">
+            <a:avLst/>
+          </a:prstGeom>
+        </p:spPr>
+      </p:pic>
+      <p:sp>
+        <p:nvSpPr>
+          <p:cNvPr id="29" name="Text 25"/>
           <p:cNvSpPr/>
           <p:nvPr/>
         </p:nvSpPr>
@@ -7388,11 +7436,11 @@
         <p:spPr>
           <a:xfrm>
             <a:off x="502920" y="1691640"/>
-            <a:ext cx="5486400" cy="1874520"/>
+            <a:ext cx="6583680" cy="960120"/>
           </a:xfrm>
           <a:prstGeom prst="roundRect">
             <a:avLst>
-              <a:gd name="adj" fmla="val 4878"/>
+              <a:gd name="adj" fmla="val 9524"/>
             </a:avLst>
           </a:prstGeom>
           <a:solidFill>
@@ -7414,8 +7462,8 @@
         </p:nvSpPr>
         <p:spPr>
           <a:xfrm>
-            <a:off x="731520" y="1920240"/>
-            <a:ext cx="5029200" cy="320040"/>
+            <a:off x="685800" y="1783080"/>
+            <a:ext cx="1645920" cy="320040"/>
           </a:xfrm>
           <a:prstGeom prst="rect">
             <a:avLst/>
@@ -7431,7 +7479,7 @@
               <a:buNone/>
             </a:pPr>
             <a:r>
-              <a:rPr lang="en-US" sz="1600" b="1" dirty="0">
+              <a:rPr lang="en-US" sz="1500" b="1" dirty="0">
                 <a:solidFill>
                   <a:srgbClr val="6B7F5A"/>
                 </a:solidFill>
@@ -7441,7 +7489,7 @@
               </a:rPr>
               <a:t>10:00</a:t>
             </a:r>
-            <a:endParaRPr lang="en-US" sz="1600" dirty="0"/>
+            <a:endParaRPr lang="en-US" sz="1500" dirty="0"/>
           </a:p>
         </p:txBody>
       </p:sp>
@@ -7453,8 +7501,8 @@
         </p:nvSpPr>
         <p:spPr>
           <a:xfrm>
-            <a:off x="731520" y="2286000"/>
-            <a:ext cx="5029200" cy="365760"/>
+            <a:off x="2377440" y="1783080"/>
+            <a:ext cx="4480560" cy="320040"/>
           </a:xfrm>
           <a:prstGeom prst="rect">
             <a:avLst/>
@@ -7470,7 +7518,7 @@
               <a:buNone/>
             </a:pPr>
             <a:r>
-              <a:rPr lang="en-US" sz="1800" b="1" dirty="0">
+              <a:rPr lang="en-US" sz="1500" b="1" dirty="0">
                 <a:solidFill>
                   <a:srgbClr val="1E2620"/>
                 </a:solidFill>
@@ -7480,7 +7528,7 @@
               </a:rPr>
               <a:t>退房上車</a:t>
             </a:r>
-            <a:endParaRPr lang="en-US" sz="1800" dirty="0"/>
+            <a:endParaRPr lang="en-US" sz="1500" dirty="0"/>
           </a:p>
         </p:txBody>
       </p:sp>
@@ -7492,8 +7540,8 @@
         </p:nvSpPr>
         <p:spPr>
           <a:xfrm>
-            <a:off x="731520" y="2743200"/>
-            <a:ext cx="5029200" cy="594360"/>
+            <a:off x="2377440" y="2130552"/>
+            <a:ext cx="4480560" cy="411480"/>
           </a:xfrm>
           <a:prstGeom prst="rect">
             <a:avLst/>
@@ -7509,7 +7557,7 @@
               <a:buNone/>
             </a:pPr>
             <a:r>
-              <a:rPr lang="en-US" sz="1300" dirty="0">
+              <a:rPr lang="en-US" sz="1200" dirty="0">
                 <a:solidFill>
                   <a:srgbClr val="48544C"/>
                 </a:solidFill>
@@ -7519,7 +7567,7 @@
               </a:rPr>
               <a:t>nol kyoto sanjo 辦理退房，行李直接放入專車後車廂。</a:t>
             </a:r>
-            <a:endParaRPr lang="en-US" sz="1300" dirty="0"/>
+            <a:endParaRPr lang="en-US" sz="1200" dirty="0"/>
           </a:p>
         </p:txBody>
       </p:sp>
@@ -7531,12 +7579,12 @@
         </p:nvSpPr>
         <p:spPr>
           <a:xfrm>
-            <a:off x="6263640" y="1691640"/>
-            <a:ext cx="5486400" cy="1874520"/>
+            <a:off x="502920" y="2743200"/>
+            <a:ext cx="6583680" cy="960120"/>
           </a:xfrm>
           <a:prstGeom prst="roundRect">
             <a:avLst>
-              <a:gd name="adj" fmla="val 4878"/>
+              <a:gd name="adj" fmla="val 9524"/>
             </a:avLst>
           </a:prstGeom>
           <a:solidFill>
@@ -7558,8 +7606,8 @@
         </p:nvSpPr>
         <p:spPr>
           <a:xfrm>
-            <a:off x="6492240" y="1920240"/>
-            <a:ext cx="5029200" cy="320040"/>
+            <a:off x="685800" y="2834640"/>
+            <a:ext cx="1645920" cy="320040"/>
           </a:xfrm>
           <a:prstGeom prst="rect">
             <a:avLst/>
@@ -7575,7 +7623,7 @@
               <a:buNone/>
             </a:pPr>
             <a:r>
-              <a:rPr lang="en-US" sz="1600" b="1" dirty="0">
+              <a:rPr lang="en-US" sz="1500" b="1" dirty="0">
                 <a:solidFill>
                   <a:srgbClr val="6B7F5A"/>
                 </a:solidFill>
@@ -7585,7 +7633,7 @@
               </a:rPr>
               <a:t>10:15–11:30</a:t>
             </a:r>
-            <a:endParaRPr lang="en-US" sz="1600" dirty="0"/>
+            <a:endParaRPr lang="en-US" sz="1500" dirty="0"/>
           </a:p>
         </p:txBody>
       </p:sp>
@@ -7597,8 +7645,8 @@
         </p:nvSpPr>
         <p:spPr>
           <a:xfrm>
-            <a:off x="6492240" y="2286000"/>
-            <a:ext cx="5029200" cy="365760"/>
+            <a:off x="2377440" y="2834640"/>
+            <a:ext cx="4480560" cy="320040"/>
           </a:xfrm>
           <a:prstGeom prst="rect">
             <a:avLst/>
@@ -7614,7 +7662,7 @@
               <a:buNone/>
             </a:pPr>
             <a:r>
-              <a:rPr lang="en-US" sz="1800" b="1" dirty="0">
+              <a:rPr lang="en-US" sz="1500" b="1" dirty="0">
                 <a:solidFill>
                   <a:srgbClr val="1E2620"/>
                 </a:solidFill>
@@ -7624,7 +7672,7 @@
               </a:rPr>
               <a:t>專車直達 OMO7 Osaka</a:t>
             </a:r>
-            <a:endParaRPr lang="en-US" sz="1800" dirty="0"/>
+            <a:endParaRPr lang="en-US" sz="1500" dirty="0"/>
           </a:p>
         </p:txBody>
       </p:sp>
@@ -7636,8 +7684,8 @@
         </p:nvSpPr>
         <p:spPr>
           <a:xfrm>
-            <a:off x="6492240" y="2743200"/>
-            <a:ext cx="5029200" cy="594360"/>
+            <a:off x="2377440" y="3182112"/>
+            <a:ext cx="4480560" cy="411480"/>
           </a:xfrm>
           <a:prstGeom prst="rect">
             <a:avLst/>
@@ -7653,7 +7701,7 @@
               <a:buNone/>
             </a:pPr>
             <a:r>
-              <a:rPr lang="en-US" sz="1300" dirty="0">
+              <a:rPr lang="en-US" sz="1200" dirty="0">
                 <a:solidFill>
                   <a:srgbClr val="48544C"/>
                 </a:solidFill>
@@ -7663,7 +7711,7 @@
               </a:rPr>
               <a:t>外派接駁車 D2 飯店對飯店點對點直達，零搬運壓力。</a:t>
             </a:r>
-            <a:endParaRPr lang="en-US" sz="1300" dirty="0"/>
+            <a:endParaRPr lang="en-US" sz="1200" dirty="0"/>
           </a:p>
         </p:txBody>
       </p:sp>
@@ -7676,11 +7724,11 @@
         <p:spPr>
           <a:xfrm>
             <a:off x="502920" y="3794760"/>
-            <a:ext cx="5486400" cy="1874520"/>
+            <a:ext cx="6583680" cy="960120"/>
           </a:xfrm>
           <a:prstGeom prst="roundRect">
             <a:avLst>
-              <a:gd name="adj" fmla="val 4878"/>
+              <a:gd name="adj" fmla="val 9524"/>
             </a:avLst>
           </a:prstGeom>
           <a:solidFill>
@@ -7702,8 +7750,8 @@
         </p:nvSpPr>
         <p:spPr>
           <a:xfrm>
-            <a:off x="731520" y="4023360"/>
-            <a:ext cx="5029200" cy="320040"/>
+            <a:off x="685800" y="3886200"/>
+            <a:ext cx="1645920" cy="320040"/>
           </a:xfrm>
           <a:prstGeom prst="rect">
             <a:avLst/>
@@ -7719,7 +7767,7 @@
               <a:buNone/>
             </a:pPr>
             <a:r>
-              <a:rPr lang="en-US" sz="1600" b="1" dirty="0">
+              <a:rPr lang="en-US" sz="1500" b="1" dirty="0">
                 <a:solidFill>
                   <a:srgbClr val="6B7F5A"/>
                 </a:solidFill>
@@ -7729,7 +7777,7 @@
               </a:rPr>
               <a:t>午後</a:t>
             </a:r>
-            <a:endParaRPr lang="en-US" sz="1600" dirty="0"/>
+            <a:endParaRPr lang="en-US" sz="1500" dirty="0"/>
           </a:p>
         </p:txBody>
       </p:sp>
@@ -7741,8 +7789,8 @@
         </p:nvSpPr>
         <p:spPr>
           <a:xfrm>
-            <a:off x="731520" y="4389120"/>
-            <a:ext cx="5029200" cy="365760"/>
+            <a:off x="2377440" y="3886200"/>
+            <a:ext cx="4480560" cy="320040"/>
           </a:xfrm>
           <a:prstGeom prst="rect">
             <a:avLst/>
@@ -7758,7 +7806,7 @@
               <a:buNone/>
             </a:pPr>
             <a:r>
-              <a:rPr lang="en-US" sz="1800" b="1" dirty="0">
+              <a:rPr lang="en-US" sz="1500" b="1" dirty="0">
                 <a:solidFill>
                   <a:srgbClr val="1E2620"/>
                 </a:solidFill>
@@ -7768,7 +7816,7 @@
               </a:rPr>
               <a:t>OMO Base 大廳休整</a:t>
             </a:r>
-            <a:endParaRPr lang="en-US" sz="1800" dirty="0"/>
+            <a:endParaRPr lang="en-US" sz="1500" dirty="0"/>
           </a:p>
         </p:txBody>
       </p:sp>
@@ -7780,8 +7828,8 @@
         </p:nvSpPr>
         <p:spPr>
           <a:xfrm>
-            <a:off x="731520" y="4846320"/>
-            <a:ext cx="5029200" cy="594360"/>
+            <a:off x="2377440" y="4233672"/>
+            <a:ext cx="4480560" cy="411480"/>
           </a:xfrm>
           <a:prstGeom prst="rect">
             <a:avLst/>
@@ -7797,7 +7845,7 @@
               <a:buNone/>
             </a:pPr>
             <a:r>
-              <a:rPr lang="en-US" sz="1300" dirty="0">
+              <a:rPr lang="en-US" sz="1200" dirty="0">
                 <a:solidFill>
                   <a:srgbClr val="48544C"/>
                 </a:solidFill>
@@ -7807,7 +7855,7 @@
               </a:rPr>
               <a:t>強勁冷氣、沙發舒適，輕鬆體驗星野大廳美學空間。</a:t>
             </a:r>
-            <a:endParaRPr lang="en-US" sz="1300" dirty="0"/>
+            <a:endParaRPr lang="en-US" sz="1200" dirty="0"/>
           </a:p>
         </p:txBody>
       </p:sp>
@@ -7819,12 +7867,12 @@
         </p:nvSpPr>
         <p:spPr>
           <a:xfrm>
-            <a:off x="6263640" y="3794760"/>
-            <a:ext cx="5486400" cy="1874520"/>
+            <a:off x="502920" y="4846320"/>
+            <a:ext cx="6583680" cy="960120"/>
           </a:xfrm>
           <a:prstGeom prst="roundRect">
             <a:avLst>
-              <a:gd name="adj" fmla="val 4878"/>
+              <a:gd name="adj" fmla="val 9524"/>
             </a:avLst>
           </a:prstGeom>
           <a:solidFill>
@@ -7846,8 +7894,8 @@
         </p:nvSpPr>
         <p:spPr>
           <a:xfrm>
-            <a:off x="6492240" y="4023360"/>
-            <a:ext cx="5029200" cy="320040"/>
+            <a:off x="685800" y="4937760"/>
+            <a:ext cx="1645920" cy="320040"/>
           </a:xfrm>
           <a:prstGeom prst="rect">
             <a:avLst/>
@@ -7863,7 +7911,7 @@
               <a:buNone/>
             </a:pPr>
             <a:r>
-              <a:rPr lang="en-US" sz="1600" b="1" dirty="0">
+              <a:rPr lang="en-US" sz="1500" b="1" dirty="0">
                 <a:solidFill>
                   <a:srgbClr val="6B7F5A"/>
                 </a:solidFill>
@@ -7873,7 +7921,7 @@
               </a:rPr>
               <a:t>傍晚</a:t>
             </a:r>
-            <a:endParaRPr lang="en-US" sz="1600" dirty="0"/>
+            <a:endParaRPr lang="en-US" sz="1500" dirty="0"/>
           </a:p>
         </p:txBody>
       </p:sp>
@@ -7885,8 +7933,8 @@
         </p:nvSpPr>
         <p:spPr>
           <a:xfrm>
-            <a:off x="6492240" y="4389120"/>
-            <a:ext cx="5029200" cy="365760"/>
+            <a:off x="2377440" y="4937760"/>
+            <a:ext cx="4480560" cy="320040"/>
           </a:xfrm>
           <a:prstGeom prst="rect">
             <a:avLst/>
@@ -7902,7 +7950,7 @@
               <a:buNone/>
             </a:pPr>
             <a:r>
-              <a:rPr lang="en-US" sz="1800" b="1" dirty="0">
+              <a:rPr lang="en-US" sz="1500" b="1" dirty="0">
                 <a:solidFill>
                   <a:srgbClr val="1E2620"/>
                 </a:solidFill>
@@ -7912,7 +7960,7 @@
               </a:rPr>
               <a:t>Miya-green 大草皮</a:t>
             </a:r>
-            <a:endParaRPr lang="en-US" sz="1800" dirty="0"/>
+            <a:endParaRPr lang="en-US" sz="1500" dirty="0"/>
           </a:p>
         </p:txBody>
       </p:sp>
@@ -7924,8 +7972,8 @@
         </p:nvSpPr>
         <p:spPr>
           <a:xfrm>
-            <a:off x="6492240" y="4846320"/>
-            <a:ext cx="5029200" cy="594360"/>
+            <a:off x="2377440" y="5285232"/>
+            <a:ext cx="4480560" cy="411480"/>
           </a:xfrm>
           <a:prstGeom prst="rect">
             <a:avLst/>
@@ -7941,7 +7989,7 @@
               <a:buNone/>
             </a:pPr>
             <a:r>
-              <a:rPr lang="en-US" sz="1300" dirty="0">
+              <a:rPr lang="en-US" sz="1200" dirty="0">
                 <a:solidFill>
                   <a:srgbClr val="48544C"/>
                 </a:solidFill>
@@ -7951,13 +7999,37 @@
               </a:rPr>
               <a:t>數千坪封閉安全草皮放電；住客限定 PIKA PIKA NIGHT 與免費章魚燒。</a:t>
             </a:r>
-            <a:endParaRPr lang="en-US" sz="1300" dirty="0"/>
-          </a:p>
-        </p:txBody>
-      </p:sp>
-      <p:sp>
-        <p:nvSpPr>
-          <p:cNvPr id="24" name="Text 22"/>
+            <a:endParaRPr lang="en-US" sz="1200" dirty="0"/>
+          </a:p>
+        </p:txBody>
+      </p:sp>
+      <p:pic>
+        <p:nvPicPr>
+          <p:cNvPr id="24" name="Image 0" descr="/Users/maxchan/Desktop/京都大阪親子手繪行程_202608/img/omo7.jpg">    </p:cNvPr>
+          <p:cNvPicPr>
+            <a:picLocks noChangeAspect="1"/>
+          </p:cNvPicPr>
+          <p:nvPr/>
+        </p:nvPicPr>
+        <p:blipFill>
+          <a:blip r:embed="rId1"/>
+          <a:stretch>
+            <a:fillRect/>
+          </a:stretch>
+        </p:blipFill>
+        <p:spPr>
+          <a:xfrm>
+            <a:off x="7315200" y="1691640"/>
+            <a:ext cx="4297680" cy="4114800"/>
+          </a:xfrm>
+          <a:prstGeom prst="rect">
+            <a:avLst/>
+          </a:prstGeom>
+        </p:spPr>
+      </p:pic>
+      <p:sp>
+        <p:nvSpPr>
+          <p:cNvPr id="25" name="Text 22"/>
           <p:cNvSpPr/>
           <p:nvPr/>
         </p:nvSpPr>
@@ -8219,7 +8291,7 @@
         <p:spPr>
           <a:xfrm>
             <a:off x="502920" y="1645920"/>
-            <a:ext cx="11155680" cy="1280160"/>
+            <a:ext cx="6583680" cy="1280160"/>
           </a:xfrm>
           <a:prstGeom prst="roundRect">
             <a:avLst>
@@ -8246,7 +8318,7 @@
         <p:spPr>
           <a:xfrm>
             <a:off x="685800" y="1965960"/>
-            <a:ext cx="1371600" cy="640080"/>
+            <a:ext cx="1097280" cy="640080"/>
           </a:xfrm>
           <a:prstGeom prst="roundRect">
             <a:avLst>
@@ -8268,7 +8340,7 @@
         <p:spPr>
           <a:xfrm>
             <a:off x="685800" y="2057400"/>
-            <a:ext cx="1371600" cy="457200"/>
+            <a:ext cx="1097280" cy="457200"/>
           </a:xfrm>
           <a:prstGeom prst="rect">
             <a:avLst/>
@@ -8284,15 +8356,54 @@
               <a:buNone/>
             </a:pPr>
             <a:r>
+              <a:rPr lang="en-US" sz="1500" b="1" dirty="0">
+                <a:solidFill>
+                  <a:srgbClr val="FFFFFF"/>
+                </a:solidFill>
+                <a:latin typeface="Microsoft JhengHei" pitchFamily="34" charset="0"/>
+                <a:ea typeface="Microsoft JhengHei" pitchFamily="34" charset="-122"/>
+                <a:cs typeface="Microsoft JhengHei" pitchFamily="34" charset="-120"/>
+              </a:rPr>
+              <a:t>上午</a:t>
+            </a:r>
+            <a:endParaRPr lang="en-US" sz="1500" dirty="0"/>
+          </a:p>
+        </p:txBody>
+      </p:sp>
+      <p:sp>
+        <p:nvSpPr>
+          <p:cNvPr id="11" name="Text 9"/>
+          <p:cNvSpPr/>
+          <p:nvPr/>
+        </p:nvSpPr>
+        <p:spPr>
+          <a:xfrm>
+            <a:off x="1920240" y="1828800"/>
+            <a:ext cx="4937760" cy="320040"/>
+          </a:xfrm>
+          <a:prstGeom prst="rect">
+            <a:avLst/>
+          </a:prstGeom>
+          <a:noFill/>
+          <a:ln/>
+        </p:spPr>
+        <p:txBody>
+          <a:bodyPr wrap="square" lIns="0" tIns="0" rIns="0" bIns="0" rtlCol="0" anchor="ctr"/>
+          <a:lstStyle/>
+          <a:p>
+            <a:pPr indent="0" marL="0">
+              <a:buNone/>
+            </a:pPr>
+            <a:r>
               <a:rPr lang="en-US" sz="1600" b="1" dirty="0">
                 <a:solidFill>
-                  <a:srgbClr val="FFFFFF"/>
-                </a:solidFill>
-                <a:latin typeface="Microsoft JhengHei" pitchFamily="34" charset="0"/>
-                <a:ea typeface="Microsoft JhengHei" pitchFamily="34" charset="-122"/>
-                <a:cs typeface="Microsoft JhengHei" pitchFamily="34" charset="-120"/>
-              </a:rPr>
-              <a:t>上午</a:t>
+                  <a:srgbClr val="1E2620"/>
+                </a:solidFill>
+                <a:latin typeface="Microsoft JhengHei" pitchFamily="34" charset="0"/>
+                <a:ea typeface="Microsoft JhengHei" pitchFamily="34" charset="-122"/>
+                <a:cs typeface="Microsoft JhengHei" pitchFamily="34" charset="-120"/>
+              </a:rPr>
+              <a:t>神戶 · 麵包超人兒童博物館</a:t>
             </a:r>
             <a:endParaRPr lang="en-US" sz="1600" dirty="0"/>
           </a:p>
@@ -8300,14 +8411,14 @@
       </p:sp>
       <p:sp>
         <p:nvSpPr>
-          <p:cNvPr id="11" name="Text 9"/>
-          <p:cNvSpPr/>
-          <p:nvPr/>
-        </p:nvSpPr>
-        <p:spPr>
-          <a:xfrm>
-            <a:off x="2286000" y="1828800"/>
-            <a:ext cx="9052560" cy="320040"/>
+          <p:cNvPr id="12" name="Text 10"/>
+          <p:cNvSpPr/>
+          <p:nvPr/>
+        </p:nvSpPr>
+        <p:spPr>
+          <a:xfrm>
+            <a:off x="1920240" y="2148840"/>
+            <a:ext cx="4937760" cy="365760"/>
           </a:xfrm>
           <a:prstGeom prst="rect">
             <a:avLst/>
@@ -8323,30 +8434,30 @@
               <a:buNone/>
             </a:pPr>
             <a:r>
-              <a:rPr lang="en-US" sz="1800" b="1" dirty="0">
-                <a:solidFill>
-                  <a:srgbClr val="1E2620"/>
-                </a:solidFill>
-                <a:latin typeface="Microsoft JhengHei" pitchFamily="34" charset="0"/>
-                <a:ea typeface="Microsoft JhengHei" pitchFamily="34" charset="-122"/>
-                <a:cs typeface="Microsoft JhengHei" pitchFamily="34" charset="-120"/>
-              </a:rPr>
-              <a:t>神戶 · 麵包超人兒童博物館</a:t>
-            </a:r>
-            <a:endParaRPr lang="en-US" sz="1800" dirty="0"/>
-          </a:p>
-        </p:txBody>
-      </p:sp>
-      <p:sp>
-        <p:nvSpPr>
-          <p:cNvPr id="12" name="Text 10"/>
-          <p:cNvSpPr/>
-          <p:nvPr/>
-        </p:nvSpPr>
-        <p:spPr>
-          <a:xfrm>
-            <a:off x="2286000" y="2148840"/>
-            <a:ext cx="9052560" cy="365760"/>
+              <a:rPr lang="en-US" sz="1200" dirty="0">
+                <a:solidFill>
+                  <a:srgbClr val="48544C"/>
+                </a:solidFill>
+                <a:latin typeface="Microsoft JhengHei" pitchFamily="34" charset="0"/>
+                <a:ea typeface="Microsoft JhengHei" pitchFamily="34" charset="-122"/>
+                <a:cs typeface="Microsoft JhengHei" pitchFamily="34" charset="-120"/>
+              </a:rPr>
+              <a:t>開館直入，全室內冷氣避暑，幼兒高放電公園。</a:t>
+            </a:r>
+            <a:endParaRPr lang="en-US" sz="1200" dirty="0"/>
+          </a:p>
+        </p:txBody>
+      </p:sp>
+      <p:sp>
+        <p:nvSpPr>
+          <p:cNvPr id="13" name="Text 11"/>
+          <p:cNvSpPr/>
+          <p:nvPr/>
+        </p:nvSpPr>
+        <p:spPr>
+          <a:xfrm>
+            <a:off x="1920240" y="2514600"/>
+            <a:ext cx="4937760" cy="274320"/>
           </a:xfrm>
           <a:prstGeom prst="rect">
             <a:avLst/>
@@ -8362,46 +8473,7 @@
               <a:buNone/>
             </a:pPr>
             <a:r>
-              <a:rPr lang="en-US" sz="1300" dirty="0">
-                <a:solidFill>
-                  <a:srgbClr val="48544C"/>
-                </a:solidFill>
-                <a:latin typeface="Microsoft JhengHei" pitchFamily="34" charset="0"/>
-                <a:ea typeface="Microsoft JhengHei" pitchFamily="34" charset="-122"/>
-                <a:cs typeface="Microsoft JhengHei" pitchFamily="34" charset="-120"/>
-              </a:rPr>
-              <a:t>開館直入，全室內冷氣避暑，幼兒高放電效率公園。</a:t>
-            </a:r>
-            <a:endParaRPr lang="en-US" sz="1300" dirty="0"/>
-          </a:p>
-        </p:txBody>
-      </p:sp>
-      <p:sp>
-        <p:nvSpPr>
-          <p:cNvPr id="13" name="Text 11"/>
-          <p:cNvSpPr/>
-          <p:nvPr/>
-        </p:nvSpPr>
-        <p:spPr>
-          <a:xfrm>
-            <a:off x="2286000" y="2514600"/>
-            <a:ext cx="9052560" cy="274320"/>
-          </a:xfrm>
-          <a:prstGeom prst="rect">
-            <a:avLst/>
-          </a:prstGeom>
-          <a:noFill/>
-          <a:ln/>
-        </p:spPr>
-        <p:txBody>
-          <a:bodyPr wrap="square" lIns="0" tIns="0" rIns="0" bIns="0" rtlCol="0" anchor="ctr"/>
-          <a:lstStyle/>
-          <a:p>
-            <a:pPr indent="0" marL="0">
-              <a:buNone/>
-            </a:pPr>
-            <a:r>
-              <a:rPr lang="en-US" sz="1200" dirty="0">
+              <a:rPr lang="en-US" sz="1100" dirty="0">
                 <a:solidFill>
                   <a:srgbClr val="4A6B7C"/>
                 </a:solidFill>
@@ -8411,7 +8483,7 @@
               </a:rPr>
               <a:t>全室內避暑 · 高放電</a:t>
             </a:r>
-            <a:endParaRPr lang="en-US" sz="1200" dirty="0"/>
+            <a:endParaRPr lang="en-US" sz="1100" dirty="0"/>
           </a:p>
         </p:txBody>
       </p:sp>
@@ -8424,7 +8496,7 @@
         <p:spPr>
           <a:xfrm>
             <a:off x="502920" y="3063240"/>
-            <a:ext cx="11155680" cy="1280160"/>
+            <a:ext cx="6583680" cy="1280160"/>
           </a:xfrm>
           <a:prstGeom prst="roundRect">
             <a:avLst>
@@ -8451,7 +8523,7 @@
         <p:spPr>
           <a:xfrm>
             <a:off x="685800" y="3383280"/>
-            <a:ext cx="1371600" cy="640080"/>
+            <a:ext cx="1097280" cy="640080"/>
           </a:xfrm>
           <a:prstGeom prst="roundRect">
             <a:avLst>
@@ -8473,7 +8545,7 @@
         <p:spPr>
           <a:xfrm>
             <a:off x="685800" y="3474720"/>
-            <a:ext cx="1371600" cy="457200"/>
+            <a:ext cx="1097280" cy="457200"/>
           </a:xfrm>
           <a:prstGeom prst="rect">
             <a:avLst/>
@@ -8489,15 +8561,54 @@
               <a:buNone/>
             </a:pPr>
             <a:r>
+              <a:rPr lang="en-US" sz="1500" b="1" dirty="0">
+                <a:solidFill>
+                  <a:srgbClr val="FFFFFF"/>
+                </a:solidFill>
+                <a:latin typeface="Microsoft JhengHei" pitchFamily="34" charset="0"/>
+                <a:ea typeface="Microsoft JhengHei" pitchFamily="34" charset="-122"/>
+                <a:cs typeface="Microsoft JhengHei" pitchFamily="34" charset="-120"/>
+              </a:rPr>
+              <a:t>下午</a:t>
+            </a:r>
+            <a:endParaRPr lang="en-US" sz="1500" dirty="0"/>
+          </a:p>
+        </p:txBody>
+      </p:sp>
+      <p:sp>
+        <p:nvSpPr>
+          <p:cNvPr id="17" name="Text 15"/>
+          <p:cNvSpPr/>
+          <p:nvPr/>
+        </p:nvSpPr>
+        <p:spPr>
+          <a:xfrm>
+            <a:off x="1920240" y="3246120"/>
+            <a:ext cx="4937760" cy="320040"/>
+          </a:xfrm>
+          <a:prstGeom prst="rect">
+            <a:avLst/>
+          </a:prstGeom>
+          <a:noFill/>
+          <a:ln/>
+        </p:spPr>
+        <p:txBody>
+          <a:bodyPr wrap="square" lIns="0" tIns="0" rIns="0" bIns="0" rtlCol="0" anchor="ctr"/>
+          <a:lstStyle/>
+          <a:p>
+            <a:pPr indent="0" marL="0">
+              <a:buNone/>
+            </a:pPr>
+            <a:r>
               <a:rPr lang="en-US" sz="1600" b="1" dirty="0">
                 <a:solidFill>
-                  <a:srgbClr val="FFFFFF"/>
-                </a:solidFill>
-                <a:latin typeface="Microsoft JhengHei" pitchFamily="34" charset="0"/>
-                <a:ea typeface="Microsoft JhengHei" pitchFamily="34" charset="-122"/>
-                <a:cs typeface="Microsoft JhengHei" pitchFamily="34" charset="-120"/>
-              </a:rPr>
-              <a:t>下午</a:t>
+                  <a:srgbClr val="1E2620"/>
+                </a:solidFill>
+                <a:latin typeface="Microsoft JhengHei" pitchFamily="34" charset="0"/>
+                <a:ea typeface="Microsoft JhengHei" pitchFamily="34" charset="-122"/>
+                <a:cs typeface="Microsoft JhengHei" pitchFamily="34" charset="-120"/>
+              </a:rPr>
+              <a:t>返大阪車程 / 飯店休整</a:t>
             </a:r>
             <a:endParaRPr lang="en-US" sz="1600" dirty="0"/>
           </a:p>
@@ -8505,14 +8616,14 @@
       </p:sp>
       <p:sp>
         <p:nvSpPr>
-          <p:cNvPr id="17" name="Text 15"/>
-          <p:cNvSpPr/>
-          <p:nvPr/>
-        </p:nvSpPr>
-        <p:spPr>
-          <a:xfrm>
-            <a:off x="2286000" y="3246120"/>
-            <a:ext cx="9052560" cy="320040"/>
+          <p:cNvPr id="18" name="Text 16"/>
+          <p:cNvSpPr/>
+          <p:nvPr/>
+        </p:nvSpPr>
+        <p:spPr>
+          <a:xfrm>
+            <a:off x="1920240" y="3566160"/>
+            <a:ext cx="4937760" cy="365760"/>
           </a:xfrm>
           <a:prstGeom prst="rect">
             <a:avLst/>
@@ -8528,30 +8639,30 @@
               <a:buNone/>
             </a:pPr>
             <a:r>
-              <a:rPr lang="en-US" sz="1800" b="1" dirty="0">
-                <a:solidFill>
-                  <a:srgbClr val="1E2620"/>
-                </a:solidFill>
-                <a:latin typeface="Microsoft JhengHei" pitchFamily="34" charset="0"/>
-                <a:ea typeface="Microsoft JhengHei" pitchFamily="34" charset="-122"/>
-                <a:cs typeface="Microsoft JhengHei" pitchFamily="34" charset="-120"/>
-              </a:rPr>
-              <a:t>返大阪車程 / 飯店休整</a:t>
-            </a:r>
-            <a:endParaRPr lang="en-US" sz="1800" dirty="0"/>
-          </a:p>
-        </p:txBody>
-      </p:sp>
-      <p:sp>
-        <p:nvSpPr>
-          <p:cNvPr id="18" name="Text 16"/>
-          <p:cNvSpPr/>
-          <p:nvPr/>
-        </p:nvSpPr>
-        <p:spPr>
-          <a:xfrm>
-            <a:off x="2286000" y="3566160"/>
-            <a:ext cx="9052560" cy="365760"/>
+              <a:rPr lang="en-US" sz="1200" dirty="0">
+                <a:solidFill>
+                  <a:srgbClr val="48544C"/>
+                </a:solidFill>
+                <a:latin typeface="Microsoft JhengHei" pitchFamily="34" charset="0"/>
+                <a:ea typeface="Microsoft JhengHei" pitchFamily="34" charset="-122"/>
+                <a:cs typeface="Microsoft JhengHei" pitchFamily="34" charset="-120"/>
+              </a:rPr>
+              <a:t>返大阪輕鬆移動與返回 OMO7 休整。</a:t>
+            </a:r>
+            <a:endParaRPr lang="en-US" sz="1200" dirty="0"/>
+          </a:p>
+        </p:txBody>
+      </p:sp>
+      <p:sp>
+        <p:nvSpPr>
+          <p:cNvPr id="19" name="Text 17"/>
+          <p:cNvSpPr/>
+          <p:nvPr/>
+        </p:nvSpPr>
+        <p:spPr>
+          <a:xfrm>
+            <a:off x="1920240" y="3931920"/>
+            <a:ext cx="4937760" cy="274320"/>
           </a:xfrm>
           <a:prstGeom prst="rect">
             <a:avLst/>
@@ -8567,46 +8678,7 @@
               <a:buNone/>
             </a:pPr>
             <a:r>
-              <a:rPr lang="en-US" sz="1300" dirty="0">
-                <a:solidFill>
-                  <a:srgbClr val="48544C"/>
-                </a:solidFill>
-                <a:latin typeface="Microsoft JhengHei" pitchFamily="34" charset="0"/>
-                <a:ea typeface="Microsoft JhengHei" pitchFamily="34" charset="-122"/>
-                <a:cs typeface="Microsoft JhengHei" pitchFamily="34" charset="-120"/>
-              </a:rPr>
-              <a:t>返大阪輕鬆移動與返回 OMO7 休整。</a:t>
-            </a:r>
-            <a:endParaRPr lang="en-US" sz="1300" dirty="0"/>
-          </a:p>
-        </p:txBody>
-      </p:sp>
-      <p:sp>
-        <p:nvSpPr>
-          <p:cNvPr id="19" name="Text 17"/>
-          <p:cNvSpPr/>
-          <p:nvPr/>
-        </p:nvSpPr>
-        <p:spPr>
-          <a:xfrm>
-            <a:off x="2286000" y="3931920"/>
-            <a:ext cx="9052560" cy="274320"/>
-          </a:xfrm>
-          <a:prstGeom prst="rect">
-            <a:avLst/>
-          </a:prstGeom>
-          <a:noFill/>
-          <a:ln/>
-        </p:spPr>
-        <p:txBody>
-          <a:bodyPr wrap="square" lIns="0" tIns="0" rIns="0" bIns="0" rtlCol="0" anchor="ctr"/>
-          <a:lstStyle/>
-          <a:p>
-            <a:pPr indent="0" marL="0">
-              <a:buNone/>
-            </a:pPr>
-            <a:r>
-              <a:rPr lang="en-US" sz="1200" dirty="0">
+              <a:rPr lang="en-US" sz="1100" dirty="0">
                 <a:solidFill>
                   <a:srgbClr val="4A6B7C"/>
                 </a:solidFill>
@@ -8616,7 +8688,7 @@
               </a:rPr>
               <a:t>輕鬆休整</a:t>
             </a:r>
-            <a:endParaRPr lang="en-US" sz="1200" dirty="0"/>
+            <a:endParaRPr lang="en-US" sz="1100" dirty="0"/>
           </a:p>
         </p:txBody>
       </p:sp>
@@ -8629,7 +8701,7 @@
         <p:spPr>
           <a:xfrm>
             <a:off x="502920" y="4480560"/>
-            <a:ext cx="11155680" cy="1280160"/>
+            <a:ext cx="6583680" cy="1280160"/>
           </a:xfrm>
           <a:prstGeom prst="roundRect">
             <a:avLst>
@@ -8656,7 +8728,7 @@
         <p:spPr>
           <a:xfrm>
             <a:off x="685800" y="4800600"/>
-            <a:ext cx="1371600" cy="640080"/>
+            <a:ext cx="1097280" cy="640080"/>
           </a:xfrm>
           <a:prstGeom prst="roundRect">
             <a:avLst>
@@ -8678,7 +8750,7 @@
         <p:spPr>
           <a:xfrm>
             <a:off x="685800" y="4892040"/>
-            <a:ext cx="1371600" cy="457200"/>
+            <a:ext cx="1097280" cy="457200"/>
           </a:xfrm>
           <a:prstGeom prst="rect">
             <a:avLst/>
@@ -8694,15 +8766,54 @@
               <a:buNone/>
             </a:pPr>
             <a:r>
+              <a:rPr lang="en-US" sz="1500" b="1" dirty="0">
+                <a:solidFill>
+                  <a:srgbClr val="FFFFFF"/>
+                </a:solidFill>
+                <a:latin typeface="Microsoft JhengHei" pitchFamily="34" charset="0"/>
+                <a:ea typeface="Microsoft JhengHei" pitchFamily="34" charset="-122"/>
+                <a:cs typeface="Microsoft JhengHei" pitchFamily="34" charset="-120"/>
+              </a:rPr>
+              <a:t>傍晚</a:t>
+            </a:r>
+            <a:endParaRPr lang="en-US" sz="1500" dirty="0"/>
+          </a:p>
+        </p:txBody>
+      </p:sp>
+      <p:sp>
+        <p:nvSpPr>
+          <p:cNvPr id="23" name="Text 21"/>
+          <p:cNvSpPr/>
+          <p:nvPr/>
+        </p:nvSpPr>
+        <p:spPr>
+          <a:xfrm>
+            <a:off x="1920240" y="4663440"/>
+            <a:ext cx="4937760" cy="320040"/>
+          </a:xfrm>
+          <a:prstGeom prst="rect">
+            <a:avLst/>
+          </a:prstGeom>
+          <a:noFill/>
+          <a:ln/>
+        </p:spPr>
+        <p:txBody>
+          <a:bodyPr wrap="square" lIns="0" tIns="0" rIns="0" bIns="0" rtlCol="0" anchor="ctr"/>
+          <a:lstStyle/>
+          <a:p>
+            <a:pPr indent="0" marL="0">
+              <a:buNone/>
+            </a:pPr>
+            <a:r>
               <a:rPr lang="en-US" sz="1600" b="1" dirty="0">
                 <a:solidFill>
-                  <a:srgbClr val="FFFFFF"/>
-                </a:solidFill>
-                <a:latin typeface="Microsoft JhengHei" pitchFamily="34" charset="0"/>
-                <a:ea typeface="Microsoft JhengHei" pitchFamily="34" charset="-122"/>
-                <a:cs typeface="Microsoft JhengHei" pitchFamily="34" charset="-120"/>
-              </a:rPr>
-              <a:t>傍晚</a:t>
+                  <a:srgbClr val="1E2620"/>
+                </a:solidFill>
+                <a:latin typeface="Microsoft JhengHei" pitchFamily="34" charset="0"/>
+                <a:ea typeface="Microsoft JhengHei" pitchFamily="34" charset="-122"/>
+                <a:cs typeface="Microsoft JhengHei" pitchFamily="34" charset="-120"/>
+              </a:rPr>
+              <a:t>阿倍野 Harukas 觀景台 · 阿卡將</a:t>
             </a:r>
             <a:endParaRPr lang="en-US" sz="1600" dirty="0"/>
           </a:p>
@@ -8710,14 +8821,14 @@
       </p:sp>
       <p:sp>
         <p:nvSpPr>
-          <p:cNvPr id="23" name="Text 21"/>
-          <p:cNvSpPr/>
-          <p:nvPr/>
-        </p:nvSpPr>
-        <p:spPr>
-          <a:xfrm>
-            <a:off x="2286000" y="4663440"/>
-            <a:ext cx="9052560" cy="320040"/>
+          <p:cNvPr id="24" name="Text 22"/>
+          <p:cNvSpPr/>
+          <p:nvPr/>
+        </p:nvSpPr>
+        <p:spPr>
+          <a:xfrm>
+            <a:off x="1920240" y="4983480"/>
+            <a:ext cx="4937760" cy="365760"/>
           </a:xfrm>
           <a:prstGeom prst="rect">
             <a:avLst/>
@@ -8733,30 +8844,30 @@
               <a:buNone/>
             </a:pPr>
             <a:r>
-              <a:rPr lang="en-US" sz="1800" b="1" dirty="0">
-                <a:solidFill>
-                  <a:srgbClr val="1E2620"/>
-                </a:solidFill>
-                <a:latin typeface="Microsoft JhengHei" pitchFamily="34" charset="0"/>
-                <a:ea typeface="Microsoft JhengHei" pitchFamily="34" charset="-122"/>
-                <a:cs typeface="Microsoft JhengHei" pitchFamily="34" charset="-120"/>
-              </a:rPr>
-              <a:t>阿倍野 Harukas 觀景台 · 近鐵阿卡將</a:t>
-            </a:r>
-            <a:endParaRPr lang="en-US" sz="1800" dirty="0"/>
-          </a:p>
-        </p:txBody>
-      </p:sp>
-      <p:sp>
-        <p:nvSpPr>
-          <p:cNvPr id="24" name="Text 22"/>
-          <p:cNvSpPr/>
-          <p:nvPr/>
-        </p:nvSpPr>
-        <p:spPr>
-          <a:xfrm>
-            <a:off x="2286000" y="4983480"/>
-            <a:ext cx="9052560" cy="365760"/>
+              <a:rPr lang="en-US" sz="1200" dirty="0">
+                <a:solidFill>
+                  <a:srgbClr val="48544C"/>
+                </a:solidFill>
+                <a:latin typeface="Microsoft JhengHei" pitchFamily="34" charset="0"/>
+                <a:ea typeface="Microsoft JhengHei" pitchFamily="34" charset="-122"/>
+                <a:cs typeface="Microsoft JhengHei" pitchFamily="34" charset="-120"/>
+              </a:rPr>
+              <a:t>高空夜景體驗；近鐵百貨 8F 阿卡將採購。</a:t>
+            </a:r>
+            <a:endParaRPr lang="en-US" sz="1200" dirty="0"/>
+          </a:p>
+        </p:txBody>
+      </p:sp>
+      <p:sp>
+        <p:nvSpPr>
+          <p:cNvPr id="25" name="Text 23"/>
+          <p:cNvSpPr/>
+          <p:nvPr/>
+        </p:nvSpPr>
+        <p:spPr>
+          <a:xfrm>
+            <a:off x="1920240" y="5349240"/>
+            <a:ext cx="4937760" cy="274320"/>
           </a:xfrm>
           <a:prstGeom prst="rect">
             <a:avLst/>
@@ -8772,46 +8883,7 @@
               <a:buNone/>
             </a:pPr>
             <a:r>
-              <a:rPr lang="en-US" sz="1300" dirty="0">
-                <a:solidFill>
-                  <a:srgbClr val="48544C"/>
-                </a:solidFill>
-                <a:latin typeface="Microsoft JhengHei" pitchFamily="34" charset="0"/>
-                <a:ea typeface="Microsoft JhengHei" pitchFamily="34" charset="-122"/>
-                <a:cs typeface="Microsoft JhengHei" pitchFamily="34" charset="-120"/>
-              </a:rPr>
-              <a:t>高空夜景體驗；於近鐵百貨 8F 阿卡將本鋪集中採購母嬰用品與藥妝。</a:t>
-            </a:r>
-            <a:endParaRPr lang="en-US" sz="1300" dirty="0"/>
-          </a:p>
-        </p:txBody>
-      </p:sp>
-      <p:sp>
-        <p:nvSpPr>
-          <p:cNvPr id="25" name="Text 23"/>
-          <p:cNvSpPr/>
-          <p:nvPr/>
-        </p:nvSpPr>
-        <p:spPr>
-          <a:xfrm>
-            <a:off x="2286000" y="5349240"/>
-            <a:ext cx="9052560" cy="274320"/>
-          </a:xfrm>
-          <a:prstGeom prst="rect">
-            <a:avLst/>
-          </a:prstGeom>
-          <a:noFill/>
-          <a:ln/>
-        </p:spPr>
-        <p:txBody>
-          <a:bodyPr wrap="square" lIns="0" tIns="0" rIns="0" bIns="0" rtlCol="0" anchor="ctr"/>
-          <a:lstStyle/>
-          <a:p>
-            <a:pPr indent="0" marL="0">
-              <a:buNone/>
-            </a:pPr>
-            <a:r>
-              <a:rPr lang="en-US" sz="1200" dirty="0">
+              <a:rPr lang="en-US" sz="1100" dirty="0">
                 <a:solidFill>
                   <a:srgbClr val="4A6B7C"/>
                 </a:solidFill>
@@ -8821,13 +8893,61 @@
               </a:rPr>
               <a:t>頂級育嬰室 · 阿卡將 8F · 夜景</a:t>
             </a:r>
-            <a:endParaRPr lang="en-US" sz="1200" dirty="0"/>
-          </a:p>
-        </p:txBody>
-      </p:sp>
-      <p:sp>
-        <p:nvSpPr>
-          <p:cNvPr id="26" name="Text 24"/>
+            <a:endParaRPr lang="en-US" sz="1100" dirty="0"/>
+          </a:p>
+        </p:txBody>
+      </p:sp>
+      <p:pic>
+        <p:nvPicPr>
+          <p:cNvPr id="26" name="Image 0" descr="/Users/maxchan/Desktop/京都大阪親子手繪行程_202608/img/anpanman_custom.jpg">    </p:cNvPr>
+          <p:cNvPicPr>
+            <a:picLocks noChangeAspect="1"/>
+          </p:cNvPicPr>
+          <p:nvPr/>
+        </p:nvPicPr>
+        <p:blipFill>
+          <a:blip r:embed="rId1"/>
+          <a:stretch>
+            <a:fillRect/>
+          </a:stretch>
+        </p:blipFill>
+        <p:spPr>
+          <a:xfrm>
+            <a:off x="7315200" y="1645920"/>
+            <a:ext cx="4297680" cy="2103120"/>
+          </a:xfrm>
+          <a:prstGeom prst="rect">
+            <a:avLst/>
+          </a:prstGeom>
+        </p:spPr>
+      </p:pic>
+      <p:pic>
+        <p:nvPicPr>
+          <p:cNvPr id="27" name="Image 1" descr="/Users/maxchan/Desktop/京都大阪親子手繪行程_202608/img/harukas.jpg">    </p:cNvPr>
+          <p:cNvPicPr>
+            <a:picLocks noChangeAspect="1"/>
+          </p:cNvPicPr>
+          <p:nvPr/>
+        </p:nvPicPr>
+        <p:blipFill>
+          <a:blip r:embed="rId2"/>
+          <a:stretch>
+            <a:fillRect/>
+          </a:stretch>
+        </p:blipFill>
+        <p:spPr>
+          <a:xfrm>
+            <a:off x="7315200" y="3931920"/>
+            <a:ext cx="4297680" cy="2103120"/>
+          </a:xfrm>
+          <a:prstGeom prst="rect">
+            <a:avLst/>
+          </a:prstGeom>
+        </p:spPr>
+      </p:pic>
+      <p:sp>
+        <p:nvSpPr>
+          <p:cNvPr id="28" name="Text 24"/>
           <p:cNvSpPr/>
           <p:nvPr/>
         </p:nvSpPr>
@@ -9089,11 +9209,11 @@
         <p:spPr>
           <a:xfrm>
             <a:off x="502920" y="1645920"/>
-            <a:ext cx="3657600" cy="3931920"/>
+            <a:ext cx="2103120" cy="3931920"/>
           </a:xfrm>
           <a:prstGeom prst="roundRect">
             <a:avLst>
-              <a:gd name="adj" fmla="val 2500"/>
+              <a:gd name="adj" fmla="val 4348"/>
             </a:avLst>
           </a:prstGeom>
           <a:solidFill>
@@ -9116,7 +9236,7 @@
         <p:spPr>
           <a:xfrm>
             <a:off x="502920" y="1920240"/>
-            <a:ext cx="3657600" cy="365760"/>
+            <a:ext cx="2103120" cy="365760"/>
           </a:xfrm>
           <a:prstGeom prst="rect">
             <a:avLst/>
@@ -9154,8 +9274,8 @@
         </p:nvSpPr>
         <p:spPr>
           <a:xfrm>
-            <a:off x="685800" y="2468880"/>
-            <a:ext cx="3291840" cy="822960"/>
+            <a:off x="594360" y="2468880"/>
+            <a:ext cx="1920240" cy="822960"/>
           </a:xfrm>
           <a:prstGeom prst="rect">
             <a:avLst/>
@@ -9171,7 +9291,7 @@
               <a:buNone/>
             </a:pPr>
             <a:r>
-              <a:rPr lang="en-US" sz="1800" b="1" dirty="0">
+              <a:rPr lang="en-US" sz="1600" b="1" dirty="0">
                 <a:solidFill>
                   <a:srgbClr val="1E2620"/>
                 </a:solidFill>
@@ -9181,7 +9301,7 @@
               </a:rPr>
               <a:t>天保山海遊館</a:t>
             </a:r>
-            <a:endParaRPr lang="en-US" sz="1800" dirty="0"/>
+            <a:endParaRPr lang="en-US" sz="1600" dirty="0"/>
           </a:p>
         </p:txBody>
       </p:sp>
@@ -9193,8 +9313,8 @@
         </p:nvSpPr>
         <p:spPr>
           <a:xfrm>
-            <a:off x="731520" y="3383280"/>
-            <a:ext cx="3200400" cy="1280160"/>
+            <a:off x="594360" y="3383280"/>
+            <a:ext cx="1920240" cy="1280160"/>
           </a:xfrm>
           <a:prstGeom prst="rect">
             <a:avLst/>
@@ -9210,7 +9330,7 @@
               <a:buNone/>
             </a:pPr>
             <a:r>
-              <a:rPr lang="en-US" sz="1300" dirty="0">
+              <a:rPr lang="en-US" sz="1200" dirty="0">
                 <a:solidFill>
                   <a:srgbClr val="48544C"/>
                 </a:solidFill>
@@ -9218,9 +9338,9 @@
                 <a:ea typeface="Microsoft JhengHei" pitchFamily="34" charset="-122"/>
                 <a:cs typeface="Microsoft JhengHei" pitchFamily="34" charset="-120"/>
               </a:rPr>
-              <a:t>全室內恆溫避暑，無障礙推車動線看鯨鯊。天保山購物中心美食街午餐。</a:t>
-            </a:r>
-            <a:endParaRPr lang="en-US" sz="1300" dirty="0"/>
+              <a:t>全室內恆溫避暑，無障礙動線看鯨鯊。</a:t>
+            </a:r>
+            <a:endParaRPr lang="en-US" sz="1200" dirty="0"/>
           </a:p>
         </p:txBody>
       </p:sp>
@@ -9232,73 +9352,12 @@
         </p:nvSpPr>
         <p:spPr>
           <a:xfrm>
-            <a:off x="960120" y="4846320"/>
-            <a:ext cx="2743200" cy="411480"/>
+            <a:off x="2743200" y="1645920"/>
+            <a:ext cx="2103120" cy="3931920"/>
           </a:xfrm>
           <a:prstGeom prst="roundRect">
             <a:avLst>
-              <a:gd name="adj" fmla="val 44444"/>
-            </a:avLst>
-          </a:prstGeom>
-          <a:solidFill>
-            <a:srgbClr val="E8F0E4"/>
-          </a:solidFill>
-          <a:ln/>
-        </p:spPr>
-      </p:sp>
-      <p:sp>
-        <p:nvSpPr>
-          <p:cNvPr id="13" name="Text 11"/>
-          <p:cNvSpPr/>
-          <p:nvPr/>
-        </p:nvSpPr>
-        <p:spPr>
-          <a:xfrm>
-            <a:off x="960120" y="4892040"/>
-            <a:ext cx="2743200" cy="320040"/>
-          </a:xfrm>
-          <a:prstGeom prst="rect">
-            <a:avLst/>
-          </a:prstGeom>
-          <a:noFill/>
-          <a:ln/>
-        </p:spPr>
-        <p:txBody>
-          <a:bodyPr wrap="square" lIns="0" tIns="0" rIns="0" bIns="0" rtlCol="0" anchor="ctr"/>
-          <a:lstStyle/>
-          <a:p>
-            <a:pPr algn="ctr" indent="0" marL="0">
-              <a:buNone/>
-            </a:pPr>
-            <a:r>
-              <a:rPr lang="en-US" sz="1200" b="1" dirty="0">
-                <a:solidFill>
-                  <a:srgbClr val="6B7F5A"/>
-                </a:solidFill>
-                <a:latin typeface="Microsoft JhengHei" pitchFamily="34" charset="0"/>
-                <a:ea typeface="Microsoft JhengHei" pitchFamily="34" charset="-122"/>
-                <a:cs typeface="Microsoft JhengHei" pitchFamily="34" charset="-120"/>
-              </a:rPr>
-              <a:t>室內恆溫 · 鯨鯊</a:t>
-            </a:r>
-            <a:endParaRPr lang="en-US" sz="1200" dirty="0"/>
-          </a:p>
-        </p:txBody>
-      </p:sp>
-      <p:sp>
-        <p:nvSpPr>
-          <p:cNvPr id="14" name="Shape 12"/>
-          <p:cNvSpPr/>
-          <p:nvPr/>
-        </p:nvSpPr>
-        <p:spPr>
-          <a:xfrm>
-            <a:off x="4343400" y="1645920"/>
-            <a:ext cx="3657600" cy="3931920"/>
-          </a:xfrm>
-          <a:prstGeom prst="roundRect">
-            <a:avLst>
-              <a:gd name="adj" fmla="val 2500"/>
+              <a:gd name="adj" fmla="val 4348"/>
             </a:avLst>
           </a:prstGeom>
           <a:solidFill>
@@ -9314,14 +9373,14 @@
       </p:sp>
       <p:sp>
         <p:nvSpPr>
-          <p:cNvPr id="15" name="Text 13"/>
-          <p:cNvSpPr/>
-          <p:nvPr/>
-        </p:nvSpPr>
-        <p:spPr>
-          <a:xfrm>
-            <a:off x="4343400" y="1920240"/>
-            <a:ext cx="3657600" cy="365760"/>
+          <p:cNvPr id="13" name="Text 11"/>
+          <p:cNvSpPr/>
+          <p:nvPr/>
+        </p:nvSpPr>
+        <p:spPr>
+          <a:xfrm>
+            <a:off x="2743200" y="1920240"/>
+            <a:ext cx="2103120" cy="365760"/>
           </a:xfrm>
           <a:prstGeom prst="rect">
             <a:avLst/>
@@ -9353,14 +9412,14 @@
       </p:sp>
       <p:sp>
         <p:nvSpPr>
-          <p:cNvPr id="16" name="Text 14"/>
-          <p:cNvSpPr/>
-          <p:nvPr/>
-        </p:nvSpPr>
-        <p:spPr>
-          <a:xfrm>
-            <a:off x="4526280" y="2468880"/>
-            <a:ext cx="3291840" cy="822960"/>
+          <p:cNvPr id="14" name="Text 12"/>
+          <p:cNvSpPr/>
+          <p:nvPr/>
+        </p:nvSpPr>
+        <p:spPr>
+          <a:xfrm>
+            <a:off x="2834640" y="2468880"/>
+            <a:ext cx="1920240" cy="822960"/>
           </a:xfrm>
           <a:prstGeom prst="rect">
             <a:avLst/>
@@ -9376,7 +9435,7 @@
               <a:buNone/>
             </a:pPr>
             <a:r>
-              <a:rPr lang="en-US" sz="1800" b="1" dirty="0">
+              <a:rPr lang="en-US" sz="1600" b="1" dirty="0">
                 <a:solidFill>
                   <a:srgbClr val="1E2620"/>
                 </a:solidFill>
@@ -9386,20 +9445,20 @@
               </a:rPr>
               <a:t>海遊館周邊 / OMO7 休整</a:t>
             </a:r>
-            <a:endParaRPr lang="en-US" sz="1800" dirty="0"/>
-          </a:p>
-        </p:txBody>
-      </p:sp>
-      <p:sp>
-        <p:nvSpPr>
-          <p:cNvPr id="17" name="Text 15"/>
-          <p:cNvSpPr/>
-          <p:nvPr/>
-        </p:nvSpPr>
-        <p:spPr>
-          <a:xfrm>
-            <a:off x="4572000" y="3383280"/>
-            <a:ext cx="3200400" cy="1280160"/>
+            <a:endParaRPr lang="en-US" sz="1600" dirty="0"/>
+          </a:p>
+        </p:txBody>
+      </p:sp>
+      <p:sp>
+        <p:nvSpPr>
+          <p:cNvPr id="15" name="Text 13"/>
+          <p:cNvSpPr/>
+          <p:nvPr/>
+        </p:nvSpPr>
+        <p:spPr>
+          <a:xfrm>
+            <a:off x="2834640" y="3383280"/>
+            <a:ext cx="1920240" cy="1280160"/>
           </a:xfrm>
           <a:prstGeom prst="rect">
             <a:avLst/>
@@ -9415,7 +9474,7 @@
               <a:buNone/>
             </a:pPr>
             <a:r>
-              <a:rPr lang="en-US" sz="1300" dirty="0">
+              <a:rPr lang="en-US" sz="1200" dirty="0">
                 <a:solidFill>
                   <a:srgbClr val="48544C"/>
                 </a:solidFill>
@@ -9423,87 +9482,26 @@
                 <a:ea typeface="Microsoft JhengHei" pitchFamily="34" charset="-122"/>
                 <a:cs typeface="Microsoft JhengHei" pitchFamily="34" charset="-120"/>
               </a:rPr>
-              <a:t>海遊館周邊漫步或返回 OMO7 大廳享受設施。</a:t>
-            </a:r>
-            <a:endParaRPr lang="en-US" sz="1300" dirty="0"/>
-          </a:p>
-        </p:txBody>
-      </p:sp>
-      <p:sp>
-        <p:nvSpPr>
-          <p:cNvPr id="18" name="Shape 16"/>
-          <p:cNvSpPr/>
-          <p:nvPr/>
-        </p:nvSpPr>
-        <p:spPr>
-          <a:xfrm>
-            <a:off x="4800600" y="4846320"/>
-            <a:ext cx="2743200" cy="411480"/>
+              <a:t>海遊館漫步或返回 OMO7 享受設施。</a:t>
+            </a:r>
+            <a:endParaRPr lang="en-US" sz="1200" dirty="0"/>
+          </a:p>
+        </p:txBody>
+      </p:sp>
+      <p:sp>
+        <p:nvSpPr>
+          <p:cNvPr id="16" name="Shape 14"/>
+          <p:cNvSpPr/>
+          <p:nvPr/>
+        </p:nvSpPr>
+        <p:spPr>
+          <a:xfrm>
+            <a:off x="4983480" y="1645920"/>
+            <a:ext cx="2103120" cy="3931920"/>
           </a:xfrm>
           <a:prstGeom prst="roundRect">
             <a:avLst>
-              <a:gd name="adj" fmla="val 44444"/>
-            </a:avLst>
-          </a:prstGeom>
-          <a:solidFill>
-            <a:srgbClr val="E8F0E4"/>
-          </a:solidFill>
-          <a:ln/>
-        </p:spPr>
-      </p:sp>
-      <p:sp>
-        <p:nvSpPr>
-          <p:cNvPr id="19" name="Text 17"/>
-          <p:cNvSpPr/>
-          <p:nvPr/>
-        </p:nvSpPr>
-        <p:spPr>
-          <a:xfrm>
-            <a:off x="4800600" y="4892040"/>
-            <a:ext cx="2743200" cy="320040"/>
-          </a:xfrm>
-          <a:prstGeom prst="rect">
-            <a:avLst/>
-          </a:prstGeom>
-          <a:noFill/>
-          <a:ln/>
-        </p:spPr>
-        <p:txBody>
-          <a:bodyPr wrap="square" lIns="0" tIns="0" rIns="0" bIns="0" rtlCol="0" anchor="ctr"/>
-          <a:lstStyle/>
-          <a:p>
-            <a:pPr algn="ctr" indent="0" marL="0">
-              <a:buNone/>
-            </a:pPr>
-            <a:r>
-              <a:rPr lang="en-US" sz="1200" b="1" dirty="0">
-                <a:solidFill>
-                  <a:srgbClr val="6B7F5A"/>
-                </a:solidFill>
-                <a:latin typeface="Microsoft JhengHei" pitchFamily="34" charset="0"/>
-                <a:ea typeface="Microsoft JhengHei" pitchFamily="34" charset="-122"/>
-                <a:cs typeface="Microsoft JhengHei" pitchFamily="34" charset="-120"/>
-              </a:rPr>
-              <a:t>悠閒休整</a:t>
-            </a:r>
-            <a:endParaRPr lang="en-US" sz="1200" dirty="0"/>
-          </a:p>
-        </p:txBody>
-      </p:sp>
-      <p:sp>
-        <p:nvSpPr>
-          <p:cNvPr id="20" name="Shape 18"/>
-          <p:cNvSpPr/>
-          <p:nvPr/>
-        </p:nvSpPr>
-        <p:spPr>
-          <a:xfrm>
-            <a:off x="8183880" y="1645920"/>
-            <a:ext cx="3657600" cy="3931920"/>
-          </a:xfrm>
-          <a:prstGeom prst="roundRect">
-            <a:avLst>
-              <a:gd name="adj" fmla="val 2500"/>
+              <a:gd name="adj" fmla="val 4348"/>
             </a:avLst>
           </a:prstGeom>
           <a:solidFill>
@@ -9519,14 +9517,14 @@
       </p:sp>
       <p:sp>
         <p:nvSpPr>
-          <p:cNvPr id="21" name="Text 19"/>
-          <p:cNvSpPr/>
-          <p:nvPr/>
-        </p:nvSpPr>
-        <p:spPr>
-          <a:xfrm>
-            <a:off x="8183880" y="1920240"/>
-            <a:ext cx="3657600" cy="365760"/>
+          <p:cNvPr id="17" name="Text 15"/>
+          <p:cNvSpPr/>
+          <p:nvPr/>
+        </p:nvSpPr>
+        <p:spPr>
+          <a:xfrm>
+            <a:off x="4983480" y="1920240"/>
+            <a:ext cx="2103120" cy="365760"/>
           </a:xfrm>
           <a:prstGeom prst="rect">
             <a:avLst/>
@@ -9558,14 +9556,14 @@
       </p:sp>
       <p:sp>
         <p:nvSpPr>
-          <p:cNvPr id="22" name="Text 20"/>
-          <p:cNvSpPr/>
-          <p:nvPr/>
-        </p:nvSpPr>
-        <p:spPr>
-          <a:xfrm>
-            <a:off x="8366760" y="2468880"/>
-            <a:ext cx="3291840" cy="822960"/>
+          <p:cNvPr id="18" name="Text 16"/>
+          <p:cNvSpPr/>
+          <p:nvPr/>
+        </p:nvSpPr>
+        <p:spPr>
+          <a:xfrm>
+            <a:off x="5074920" y="2468880"/>
+            <a:ext cx="1920240" cy="822960"/>
           </a:xfrm>
           <a:prstGeom prst="rect">
             <a:avLst/>
@@ -9581,7 +9579,7 @@
               <a:buNone/>
             </a:pPr>
             <a:r>
-              <a:rPr lang="en-US" sz="1800" b="1" dirty="0">
+              <a:rPr lang="en-US" sz="1600" b="1" dirty="0">
                 <a:solidFill>
                   <a:srgbClr val="1E2620"/>
                 </a:solidFill>
@@ -9591,20 +9589,20 @@
               </a:rPr>
               <a:t>OMO7 大草皮公園散步</a:t>
             </a:r>
-            <a:endParaRPr lang="en-US" sz="1800" dirty="0"/>
-          </a:p>
-        </p:txBody>
-      </p:sp>
-      <p:sp>
-        <p:nvSpPr>
-          <p:cNvPr id="23" name="Text 21"/>
-          <p:cNvSpPr/>
-          <p:nvPr/>
-        </p:nvSpPr>
-        <p:spPr>
-          <a:xfrm>
-            <a:off x="8412480" y="3383280"/>
-            <a:ext cx="3200400" cy="1280160"/>
+            <a:endParaRPr lang="en-US" sz="1600" dirty="0"/>
+          </a:p>
+        </p:txBody>
+      </p:sp>
+      <p:sp>
+        <p:nvSpPr>
+          <p:cNvPr id="19" name="Text 17"/>
+          <p:cNvSpPr/>
+          <p:nvPr/>
+        </p:nvSpPr>
+        <p:spPr>
+          <a:xfrm>
+            <a:off x="5074920" y="3383280"/>
+            <a:ext cx="1920240" cy="1280160"/>
           </a:xfrm>
           <a:prstGeom prst="rect">
             <a:avLst/>
@@ -9620,7 +9618,7 @@
               <a:buNone/>
             </a:pPr>
             <a:r>
-              <a:rPr lang="en-US" sz="1300" dirty="0">
+              <a:rPr lang="en-US" sz="1200" dirty="0">
                 <a:solidFill>
                   <a:srgbClr val="48544C"/>
                 </a:solidFill>
@@ -9628,76 +9626,39 @@
                 <a:ea typeface="Microsoft JhengHei" pitchFamily="34" charset="-122"/>
                 <a:cs typeface="Microsoft JhengHei" pitchFamily="34" charset="-120"/>
               </a:rPr>
-              <a:t>享受草皮涼風，避開擁擠商圈，於天王寺圈享用在地晚餐。</a:t>
-            </a:r>
-            <a:endParaRPr lang="en-US" sz="1300" dirty="0"/>
-          </a:p>
-        </p:txBody>
-      </p:sp>
-      <p:sp>
-        <p:nvSpPr>
-          <p:cNvPr id="24" name="Shape 22"/>
-          <p:cNvSpPr/>
-          <p:nvPr/>
-        </p:nvSpPr>
-        <p:spPr>
-          <a:xfrm>
-            <a:off x="8641080" y="4846320"/>
-            <a:ext cx="2743200" cy="411480"/>
-          </a:xfrm>
-          <a:prstGeom prst="roundRect">
-            <a:avLst>
-              <a:gd name="adj" fmla="val 44444"/>
-            </a:avLst>
-          </a:prstGeom>
-          <a:solidFill>
-            <a:srgbClr val="E8F0E4"/>
-          </a:solidFill>
-          <a:ln/>
-        </p:spPr>
-      </p:sp>
-      <p:sp>
-        <p:nvSpPr>
-          <p:cNvPr id="25" name="Text 23"/>
-          <p:cNvSpPr/>
-          <p:nvPr/>
-        </p:nvSpPr>
-        <p:spPr>
-          <a:xfrm>
-            <a:off x="8641080" y="4892040"/>
-            <a:ext cx="2743200" cy="320040"/>
-          </a:xfrm>
-          <a:prstGeom prst="rect">
-            <a:avLst/>
-          </a:prstGeom>
-          <a:noFill/>
-          <a:ln/>
-        </p:spPr>
-        <p:txBody>
-          <a:bodyPr wrap="square" lIns="0" tIns="0" rIns="0" bIns="0" rtlCol="0" anchor="ctr"/>
-          <a:lstStyle/>
-          <a:p>
-            <a:pPr algn="ctr" indent="0" marL="0">
-              <a:buNone/>
-            </a:pPr>
-            <a:r>
-              <a:rPr lang="en-US" sz="1200" b="1" dirty="0">
-                <a:solidFill>
-                  <a:srgbClr val="6B7F5A"/>
-                </a:solidFill>
-                <a:latin typeface="Microsoft JhengHei" pitchFamily="34" charset="0"/>
-                <a:ea typeface="Microsoft JhengHei" pitchFamily="34" charset="-122"/>
-                <a:cs typeface="Microsoft JhengHei" pitchFamily="34" charset="-120"/>
-              </a:rPr>
-              <a:t>草皮散步 · 在地晚餐</a:t>
+              <a:t>享草皮涼風，天王寺在地晚餐。</a:t>
             </a:r>
             <a:endParaRPr lang="en-US" sz="1200" dirty="0"/>
           </a:p>
         </p:txBody>
       </p:sp>
-      <p:sp>
-        <p:nvSpPr>
-          <p:cNvPr id="26" name="Text 24"/>
+      <p:pic>
+        <p:nvPicPr>
+          <p:cNvPr id="20" name="Image 0" descr="/Users/maxchan/Desktop/京都大阪親子手繪行程_202608/img/kaiyukan.jpg">    </p:cNvPr>
+          <p:cNvPicPr>
+            <a:picLocks noChangeAspect="1"/>
+          </p:cNvPicPr>
+          <p:nvPr/>
+        </p:nvPicPr>
+        <p:blipFill>
+          <a:blip r:embed="rId1"/>
+          <a:stretch>
+            <a:fillRect/>
+          </a:stretch>
+        </p:blipFill>
+        <p:spPr>
+          <a:xfrm>
+            <a:off x="7315200" y="1645920"/>
+            <a:ext cx="4297680" cy="3931920"/>
+          </a:xfrm>
+          <a:prstGeom prst="rect">
+            <a:avLst/>
+          </a:prstGeom>
+        </p:spPr>
+      </p:pic>
+      <p:sp>
+        <p:nvSpPr>
+          <p:cNvPr id="21" name="Text 18"/>
           <p:cNvSpPr/>
           <p:nvPr/>
         </p:nvSpPr>

</xml_diff>